<commit_message>
Refine Topic 1.1 lesson decks and teaching flow
</commit_message>
<xml_diff>
--- a/presentations/SA_L01_FetchExecuteFactory_Lesson.pptx
+++ b/presentations/SA_L01_FetchExecuteFactory_Lesson.pptx
@@ -2,32 +2,32 @@
 <file path=ppt/presentation.xml><?xml version="1.0" encoding="utf-8"?>
 <p:presentation xmlns:p="http://schemas.openxmlformats.org/presentationml/2006/main">
   <p:sldMasterIdLst>
-    <p:sldMasterId xmlns:r="http://schemas.openxmlformats.org/officeDocument/2006/relationships" id="2147483648" r:id="R89c758b379294589"/>
+    <p:sldMasterId xmlns:r="http://schemas.openxmlformats.org/officeDocument/2006/relationships" id="2147483648" r:id="Rd8dc751e17224152"/>
   </p:sldMasterIdLst>
   <p:notesMasterIdLst>
-    <p:notesMasterId xmlns:r="http://schemas.openxmlformats.org/officeDocument/2006/relationships" r:id="R19a8d80f016f4b15"/>
+    <p:notesMasterId xmlns:r="http://schemas.openxmlformats.org/officeDocument/2006/relationships" r:id="R55a13139b4ed48ff"/>
   </p:notesMasterIdLst>
   <p:sldIdLst>
-    <p:sldId xmlns:r="http://schemas.openxmlformats.org/officeDocument/2006/relationships" id="256" r:id="R1443046e46184c5e"/>
-    <p:sldId xmlns:r="http://schemas.openxmlformats.org/officeDocument/2006/relationships" id="257" r:id="R2c98cd022b674101"/>
-    <p:sldId xmlns:r="http://schemas.openxmlformats.org/officeDocument/2006/relationships" id="258" r:id="R083dc3870e254211"/>
-    <p:sldId xmlns:r="http://schemas.openxmlformats.org/officeDocument/2006/relationships" id="259" r:id="Rec47edd1935c4cf7"/>
-    <p:sldId xmlns:r="http://schemas.openxmlformats.org/officeDocument/2006/relationships" id="260" r:id="R51122d8cb60a40eb"/>
-    <p:sldId xmlns:r="http://schemas.openxmlformats.org/officeDocument/2006/relationships" id="261" r:id="R399af84dd7fd4030"/>
-    <p:sldId xmlns:r="http://schemas.openxmlformats.org/officeDocument/2006/relationships" id="262" r:id="Ra5b96829df1748e9"/>
-    <p:sldId xmlns:r="http://schemas.openxmlformats.org/officeDocument/2006/relationships" id="263" r:id="R9c15adbcfbe043cb"/>
-    <p:sldId xmlns:r="http://schemas.openxmlformats.org/officeDocument/2006/relationships" id="264" r:id="Rb8cffd285132406d"/>
-    <p:sldId xmlns:r="http://schemas.openxmlformats.org/officeDocument/2006/relationships" id="265" r:id="R8eb4b475d0d64b6f"/>
-    <p:sldId xmlns:r="http://schemas.openxmlformats.org/officeDocument/2006/relationships" id="266" r:id="R60e2cbbda06f4a47"/>
-    <p:sldId xmlns:r="http://schemas.openxmlformats.org/officeDocument/2006/relationships" id="267" r:id="R8d0880532baa4adb"/>
-    <p:sldId xmlns:r="http://schemas.openxmlformats.org/officeDocument/2006/relationships" id="268" r:id="Rfda888439fec427b"/>
-    <p:sldId xmlns:r="http://schemas.openxmlformats.org/officeDocument/2006/relationships" id="269" r:id="R8949f43bdb964dbe"/>
-    <p:sldId xmlns:r="http://schemas.openxmlformats.org/officeDocument/2006/relationships" id="270" r:id="Rae3d753ff41845b3"/>
-    <p:sldId xmlns:r="http://schemas.openxmlformats.org/officeDocument/2006/relationships" id="271" r:id="R9ef420ba3c504b4a"/>
-    <p:sldId xmlns:r="http://schemas.openxmlformats.org/officeDocument/2006/relationships" id="272" r:id="R1b09a6832250480f"/>
-    <p:sldId xmlns:r="http://schemas.openxmlformats.org/officeDocument/2006/relationships" id="273" r:id="R0dc1ad032cd240e9"/>
-    <p:sldId xmlns:r="http://schemas.openxmlformats.org/officeDocument/2006/relationships" id="274" r:id="R84242d69284f4a10"/>
-    <p:sldId xmlns:r="http://schemas.openxmlformats.org/officeDocument/2006/relationships" id="275" r:id="R1b6aa903cbab4ed8"/>
+    <p:sldId xmlns:r="http://schemas.openxmlformats.org/officeDocument/2006/relationships" id="256" r:id="Redb21f29ede24399"/>
+    <p:sldId xmlns:r="http://schemas.openxmlformats.org/officeDocument/2006/relationships" id="257" r:id="R5693da0d86604859"/>
+    <p:sldId xmlns:r="http://schemas.openxmlformats.org/officeDocument/2006/relationships" id="258" r:id="R3076f72c184f4867"/>
+    <p:sldId xmlns:r="http://schemas.openxmlformats.org/officeDocument/2006/relationships" id="259" r:id="R094ba911e3104c74"/>
+    <p:sldId xmlns:r="http://schemas.openxmlformats.org/officeDocument/2006/relationships" id="260" r:id="R7884cc42df8d4e4e"/>
+    <p:sldId xmlns:r="http://schemas.openxmlformats.org/officeDocument/2006/relationships" id="261" r:id="Ra5e159349ba14680"/>
+    <p:sldId xmlns:r="http://schemas.openxmlformats.org/officeDocument/2006/relationships" id="262" r:id="Ra87bf9b3313c4666"/>
+    <p:sldId xmlns:r="http://schemas.openxmlformats.org/officeDocument/2006/relationships" id="263" r:id="R8a448d4673334b9e"/>
+    <p:sldId xmlns:r="http://schemas.openxmlformats.org/officeDocument/2006/relationships" id="264" r:id="Re280f7b00ebd403c"/>
+    <p:sldId xmlns:r="http://schemas.openxmlformats.org/officeDocument/2006/relationships" id="265" r:id="R25fd47b4a52f4a7d"/>
+    <p:sldId xmlns:r="http://schemas.openxmlformats.org/officeDocument/2006/relationships" id="266" r:id="Rd3f2c2252691410c"/>
+    <p:sldId xmlns:r="http://schemas.openxmlformats.org/officeDocument/2006/relationships" id="267" r:id="R4f2f823c801142be"/>
+    <p:sldId xmlns:r="http://schemas.openxmlformats.org/officeDocument/2006/relationships" id="268" r:id="R94249b8e44194ee1"/>
+    <p:sldId xmlns:r="http://schemas.openxmlformats.org/officeDocument/2006/relationships" id="269" r:id="Rfafd253fa0d14315"/>
+    <p:sldId xmlns:r="http://schemas.openxmlformats.org/officeDocument/2006/relationships" id="270" r:id="Ra0c4e11117104e17"/>
+    <p:sldId xmlns:r="http://schemas.openxmlformats.org/officeDocument/2006/relationships" id="271" r:id="R10e4af89c8794329"/>
+    <p:sldId xmlns:r="http://schemas.openxmlformats.org/officeDocument/2006/relationships" id="272" r:id="Rb7a447c1fcb84020"/>
+    <p:sldId xmlns:r="http://schemas.openxmlformats.org/officeDocument/2006/relationships" id="273" r:id="Rc67b11f48e3e4fa2"/>
+    <p:sldId xmlns:r="http://schemas.openxmlformats.org/officeDocument/2006/relationships" id="274" r:id="R5966bb0726344238"/>
+    <p:sldId xmlns:r="http://schemas.openxmlformats.org/officeDocument/2006/relationships" id="275" r:id="R1d443c4217324b9c"/>
   </p:sldIdLst>
   <p:sldSz cx="12192000" cy="6858000"/>
   <p:notesSz cx="6858000" cy="9144000"/>
@@ -611,7 +611,7 @@
           <a:lstStyle xmlns:a="http://schemas.openxmlformats.org/drawingml/2006/main"/>
           <a:p xmlns:a="http://schemas.openxmlformats.org/drawingml/2006/main">
             <a:r>
-              <a:t>Keep this slide up while the rest of the class finishes. Do not reveal station answers until pupils have completed the experience.</a:t>
+              <a:t>Use this work after the experience has been completed. Move the whole class to the plenary knowledge check near the end of the lesson. Do not reveal station answers until pupils have completed the experience.</a:t>
             </a:r>
           </a:p>
           <a:p xmlns:a="http://schemas.openxmlformats.org/drawingml/2006/main">
@@ -686,7 +686,7 @@
           <a:lstStyle xmlns:a="http://schemas.openxmlformats.org/drawingml/2006/main"/>
           <a:p xmlns:a="http://schemas.openxmlformats.org/drawingml/2006/main">
             <a:r>
-              <a:t>Show the sample answers after early finishers have attempted the two extension prompts. These are examples rather than a single required wording.</a:t>
+              <a:t>Show the sample answers after students have attempted the two application prompts. These are examples rather than a single required wording.</a:t>
             </a:r>
           </a:p>
           <a:p xmlns:a="http://schemas.openxmlformats.org/drawingml/2006/main">
@@ -1511,7 +1511,7 @@
           <a:lstStyle xmlns:a="http://schemas.openxmlformats.org/drawingml/2006/main"/>
           <a:p xmlns:a="http://schemas.openxmlformats.org/drawingml/2006/main">
             <a:r>
-              <a:t>Students write definitions from memory. These two terms are the worksheet’s exact key terminology entries, including the recap terms in Lesson 4.</a:t>
+              <a:t>These are sample answers to the exact worksheet starter question. Accept other correct examples and explanations.</a:t>
             </a:r>
           </a:p>
           <a:p xmlns:a="http://schemas.openxmlformats.org/drawingml/2006/main">
@@ -1586,7 +1586,7 @@
           <a:lstStyle xmlns:a="http://schemas.openxmlformats.org/drawingml/2006/main"/>
           <a:p xmlns:a="http://schemas.openxmlformats.org/drawingml/2006/main">
             <a:r>
-              <a:t>These are sample answers to the exact worksheet starter question. Accept other correct examples and explanations.</a:t>
+              <a:t>Students write definitions from memory. These two terms are the worksheet’s exact key terminology entries, including the recap terms in Lesson 4.</a:t>
             </a:r>
           </a:p>
           <a:p xmlns:a="http://schemas.openxmlformats.org/drawingml/2006/main">
@@ -1959,7 +1959,7 @@
   </p:cSld>
   <p:clrMap bg1="lt1" tx1="dk1" bg2="lt2" tx2="dk2" accent1="accent1" accent2="accent2" accent3="accent3" accent4="accent4" accent5="accent5" accent6="accent6" hlink="hlink" folHlink="folHlink"/>
   <p:sldLayoutIdLst>
-    <p:sldLayoutId xmlns:r="http://schemas.openxmlformats.org/officeDocument/2006/relationships" id="2147483649" r:id="R09bbfd7a958648a8"/>
+    <p:sldLayoutId xmlns:r="http://schemas.openxmlformats.org/officeDocument/2006/relationships" id="2147483649" r:id="R9da9715644564e61"/>
   </p:sldLayoutIdLst>
   <p:txStyles>
     <p:titleStyle>
@@ -2492,7 +2492,7 @@
     <p:bg>
       <p:bgPr>
         <a:solidFill xmlns:a="http://schemas.openxmlformats.org/drawingml/2006/main">
-          <a:srgbClr val="FFFFFF"/>
+          <a:srgbClr val="122448"/>
         </a:solidFill>
       </p:bgPr>
     </p:bg>
@@ -2510,7 +2510,7 @@
           <p:cNvPr id="8" name="topic">
             <a:extLst xmlns:a="http://schemas.openxmlformats.org/drawingml/2006/main">
               <a:ext uri="{FF2B5EF4-FFF2-40B4-BE49-F238E27FC236}">
-                <a16:creationId xmlns:a16="http://schemas.microsoft.com/office/drawing/2014/main" id="{39121C87-6576-44F4-9EA9-16213C3EB6CA}"/>
+                <a16:creationId xmlns:a16="http://schemas.microsoft.com/office/drawing/2014/main" id="{91EE03C4-EB31-47C7-87BC-F99ABE7ABEB3}"/>
               </a:ext>
             </a:extLst>
           </p:cNvPr>
@@ -2522,7 +2522,7 @@
         <p:spPr>
           <a:xfrm xmlns:a="http://schemas.openxmlformats.org/drawingml/2006/main">
             <a:off x="666750" y="323850"/>
-            <a:ext cx="6667500" cy="276225"/>
+            <a:ext cx="9810750" cy="276225"/>
           </a:xfrm>
           <a:prstGeom xmlns:a="http://schemas.openxmlformats.org/drawingml/2006/main" prst="rect">
             <a:avLst/>
@@ -2541,7 +2541,7 @@
             <a:pPr>
               <a:defRPr sz="1125" b="1">
                 <a:solidFill>
-                  <a:srgbClr val="2D63FF"/>
+                  <a:srgbClr val="77D8FF"/>
                 </a:solidFill>
                 <a:latin typeface="DejaVu Sans"/>
                 <a:ea typeface="DejaVu Sans"/>
@@ -2551,13 +2551,13 @@
             <a:r>
               <a:rPr sz="1125" b="1">
                 <a:solidFill>
-                  <a:srgbClr val="2D63FF"/>
-                </a:solidFill>
-                <a:latin typeface="DejaVu Sans"/>
-                <a:ea typeface="DejaVu Sans"/>
-                <a:cs typeface="DejaVu Sans"/>
-              </a:rPr>
-              <a:t>TOPIC 1.1   LESSON 01</a:t>
+                  <a:srgbClr val="77D8FF"/>
+                </a:solidFill>
+                <a:latin typeface="DejaVu Sans"/>
+                <a:ea typeface="DejaVu Sans"/>
+                <a:cs typeface="DejaVu Sans"/>
+              </a:rPr>
+              <a:t>TOPIC 1.1   /   LESSON 01</a:t>
             </a:r>
           </a:p>
         </p:txBody>
@@ -2567,7 +2567,7 @@
           <p:cNvPr id="2" name="heading">
             <a:extLst xmlns:a="http://schemas.openxmlformats.org/drawingml/2006/main">
               <a:ext uri="{FF2B5EF4-FFF2-40B4-BE49-F238E27FC236}">
-                <a16:creationId xmlns:a16="http://schemas.microsoft.com/office/drawing/2014/main" id="{AB8824DF-F964-4A10-A65A-354F5DE38415}"/>
+                <a16:creationId xmlns:a16="http://schemas.microsoft.com/office/drawing/2014/main" id="{B7FF8755-FFAC-4AAF-A2E7-2FFBF4324655}"/>
               </a:ext>
             </a:extLst>
           </p:cNvPr>
@@ -2598,7 +2598,7 @@
             <a:pPr>
               <a:defRPr sz="3225" b="1">
                 <a:solidFill>
-                  <a:srgbClr val="101828"/>
+                  <a:srgbClr val="FFFFFF"/>
                 </a:solidFill>
                 <a:latin typeface="DejaVu Sans"/>
                 <a:ea typeface="DejaVu Sans"/>
@@ -2608,7 +2608,7 @@
             <a:r>
               <a:rPr sz="3225" b="1">
                 <a:solidFill>
-                  <a:srgbClr val="101828"/>
+                  <a:srgbClr val="FFFFFF"/>
                 </a:solidFill>
                 <a:latin typeface="DejaVu Sans"/>
                 <a:ea typeface="DejaVu Sans"/>
@@ -2624,7 +2624,7 @@
           <p:cNvPr id="3" name="footer">
             <a:extLst xmlns:a="http://schemas.openxmlformats.org/drawingml/2006/main">
               <a:ext uri="{FF2B5EF4-FFF2-40B4-BE49-F238E27FC236}">
-                <a16:creationId xmlns:a16="http://schemas.microsoft.com/office/drawing/2014/main" id="{D8AFB572-4A11-4EE8-A27E-9AB404F911FC}"/>
+                <a16:creationId xmlns:a16="http://schemas.microsoft.com/office/drawing/2014/main" id="{CD63DA43-FE14-4CC9-974B-AE491E43C83C}"/>
               </a:ext>
             </a:extLst>
           </p:cNvPr>
@@ -2655,7 +2655,7 @@
             <a:pPr>
               <a:defRPr sz="1050" b="0">
                 <a:solidFill>
-                  <a:srgbClr val="526174"/>
+                  <a:srgbClr val="D7E4F3"/>
                 </a:solidFill>
                 <a:latin typeface="DejaVu Sans"/>
                 <a:ea typeface="DejaVu Sans"/>
@@ -2665,7 +2665,7 @@
             <a:r>
               <a:rPr sz="1050" b="0">
                 <a:solidFill>
-                  <a:srgbClr val="526174"/>
+                  <a:srgbClr val="D7E4F3"/>
                 </a:solidFill>
                 <a:latin typeface="DejaVu Sans"/>
                 <a:ea typeface="DejaVu Sans"/>
@@ -2681,7 +2681,7 @@
           <p:cNvPr id="4" name="page">
             <a:extLst xmlns:a="http://schemas.openxmlformats.org/drawingml/2006/main">
               <a:ext uri="{FF2B5EF4-FFF2-40B4-BE49-F238E27FC236}">
-                <a16:creationId xmlns:a16="http://schemas.microsoft.com/office/drawing/2014/main" id="{7C1D8195-EF67-45D2-94CE-7EF69B17504B}"/>
+                <a16:creationId xmlns:a16="http://schemas.microsoft.com/office/drawing/2014/main" id="{8C58CF99-DAE1-427B-859E-E6F4739CFEE2}"/>
               </a:ext>
             </a:extLst>
           </p:cNvPr>
@@ -2712,7 +2712,7 @@
             <a:pPr>
               <a:defRPr sz="1050" b="0">
                 <a:solidFill>
-                  <a:srgbClr val="526174"/>
+                  <a:srgbClr val="D7E4F3"/>
                 </a:solidFill>
                 <a:latin typeface="DejaVu Sans"/>
                 <a:ea typeface="DejaVu Sans"/>
@@ -2722,7 +2722,7 @@
             <a:r>
               <a:rPr sz="1050" b="0">
                 <a:solidFill>
-                  <a:srgbClr val="526174"/>
+                  <a:srgbClr val="D7E4F3"/>
                 </a:solidFill>
                 <a:latin typeface="DejaVu Sans"/>
                 <a:ea typeface="DejaVu Sans"/>
@@ -2738,7 +2738,7 @@
           <p:cNvPr id="5" name="subject">
             <a:extLst xmlns:a="http://schemas.openxmlformats.org/drawingml/2006/main">
               <a:ext uri="{FF2B5EF4-FFF2-40B4-BE49-F238E27FC236}">
-                <a16:creationId xmlns:a16="http://schemas.microsoft.com/office/drawing/2014/main" id="{61FB7204-E081-44C4-AA2D-22B22E172D8F}"/>
+                <a16:creationId xmlns:a16="http://schemas.microsoft.com/office/drawing/2014/main" id="{703E6183-E49E-4C37-B834-0C2BE6FBA04E}"/>
               </a:ext>
             </a:extLst>
           </p:cNvPr>
@@ -2769,7 +2769,7 @@
             <a:pPr>
               <a:defRPr sz="2325" b="0">
                 <a:solidFill>
-                  <a:srgbClr val="2D63FF"/>
+                  <a:srgbClr val="77D8FF"/>
                 </a:solidFill>
                 <a:latin typeface="DejaVu Sans"/>
                 <a:ea typeface="DejaVu Sans"/>
@@ -2779,7 +2779,7 @@
             <a:r>
               <a:rPr sz="2325" b="0">
                 <a:solidFill>
-                  <a:srgbClr val="2D63FF"/>
+                  <a:srgbClr val="77D8FF"/>
                 </a:solidFill>
                 <a:latin typeface="DejaVu Sans"/>
                 <a:ea typeface="DejaVu Sans"/>
@@ -2795,7 +2795,7 @@
           <p:cNvPr id="6" name="cover-note">
             <a:extLst xmlns:a="http://schemas.openxmlformats.org/drawingml/2006/main">
               <a:ext uri="{FF2B5EF4-FFF2-40B4-BE49-F238E27FC236}">
-                <a16:creationId xmlns:a16="http://schemas.microsoft.com/office/drawing/2014/main" id="{D6610773-BBDA-4732-B75C-DE40CB2A36C4}"/>
+                <a16:creationId xmlns:a16="http://schemas.microsoft.com/office/drawing/2014/main" id="{C80D8965-CB2B-487A-B0E9-85468A0481AB}"/>
               </a:ext>
             </a:extLst>
           </p:cNvPr>
@@ -2807,7 +2807,7 @@
         <p:spPr>
           <a:xfrm xmlns:a="http://schemas.openxmlformats.org/drawingml/2006/main">
             <a:off x="685800" y="3267075"/>
-            <a:ext cx="5143500" cy="1390650"/>
+            <a:ext cx="5143500" cy="1543050"/>
           </a:xfrm>
           <a:prstGeom xmlns:a="http://schemas.openxmlformats.org/drawingml/2006/main" prst="rect">
             <a:avLst/>
@@ -2830,7 +2830,7 @@
               <a:buNone/>
               <a:defRPr sz="1950" b="0">
                 <a:solidFill>
-                  <a:srgbClr val="101828"/>
+                  <a:srgbClr val="FFFFFF"/>
                 </a:solidFill>
                 <a:latin typeface="DejaVu Sans"/>
                 <a:ea typeface="DejaVu Sans"/>
@@ -2840,7 +2840,7 @@
             <a:r>
               <a:rPr sz="1950" b="0">
                 <a:solidFill>
-                  <a:srgbClr val="101828"/>
+                  <a:srgbClr val="FFFFFF"/>
                 </a:solidFill>
                 <a:latin typeface="DejaVu Sans"/>
                 <a:ea typeface="DejaVu Sans"/>
@@ -2857,7 +2857,7 @@
               <a:buNone/>
               <a:defRPr sz="1950" b="0">
                 <a:solidFill>
-                  <a:srgbClr val="101828"/>
+                  <a:srgbClr val="FFFFFF"/>
                 </a:solidFill>
                 <a:latin typeface="DejaVu Sans"/>
                 <a:ea typeface="DejaVu Sans"/>
@@ -2867,13 +2867,13 @@
             <a:r>
               <a:rPr sz="1950" b="0">
                 <a:solidFill>
-                  <a:srgbClr val="101828"/>
-                </a:solidFill>
-                <a:latin typeface="DejaVu Sans"/>
-                <a:ea typeface="DejaVu Sans"/>
-                <a:cs typeface="DejaVu Sans"/>
-              </a:rPr>
-              <a:t>Open the experience after the starter answers.</a:t>
+                  <a:srgbClr val="FFFFFF"/>
+                </a:solidFill>
+                <a:latin typeface="DejaVu Sans"/>
+                <a:ea typeface="DejaVu Sans"/>
+                <a:cs typeface="DejaVu Sans"/>
+              </a:rPr>
+              <a:t>Open the experience after the starter and key terms have been marked.</a:t>
             </a:r>
           </a:p>
         </p:txBody>
@@ -2887,7 +2887,7 @@
           <p:nvPr/>
         </p:nvPicPr>
         <p:blipFill>
-          <a:blip xmlns:r="http://schemas.openxmlformats.org/officeDocument/2006/relationships" xmlns:a="http://schemas.openxmlformats.org/drawingml/2006/main" r:embed="R7482a6e6a60c451b"/>
+          <a:blip xmlns:r="http://schemas.openxmlformats.org/officeDocument/2006/relationships" xmlns:a="http://schemas.openxmlformats.org/drawingml/2006/main" r:embed="Rf55efd18d9d14f72"/>
           <a:stretch xmlns:a="http://schemas.openxmlformats.org/drawingml/2006/main"/>
         </p:blipFill>
         <p:spPr>
@@ -2903,7 +2903,7 @@
     </p:spTree>
     <p:extLst>
       <p:ext uri="{BB962C8B-B14F-4D97-AF65-F5344CB8AC3E}">
-        <p14:creationId xmlns:p14="http://schemas.microsoft.com/office/powerpoint/2010/main" val="37066132"/>
+        <p14:creationId xmlns:p14="http://schemas.microsoft.com/office/powerpoint/2010/main" val="1513971552"/>
       </p:ext>
     </p:extLst>
   </p:cSld>
@@ -2934,7 +2934,7 @@
           <p:cNvPr id="8" name="topic">
             <a:extLst xmlns:a="http://schemas.openxmlformats.org/drawingml/2006/main">
               <a:ext uri="{FF2B5EF4-FFF2-40B4-BE49-F238E27FC236}">
-                <a16:creationId xmlns:a16="http://schemas.microsoft.com/office/drawing/2014/main" id="{CFD8D88E-F3A8-49AF-8038-620C3E0AB0FA}"/>
+                <a16:creationId xmlns:a16="http://schemas.microsoft.com/office/drawing/2014/main" id="{3F43C1DF-3879-46E7-B398-5963A51C3205}"/>
               </a:ext>
             </a:extLst>
           </p:cNvPr>
@@ -2946,7 +2946,7 @@
         <p:spPr>
           <a:xfrm xmlns:a="http://schemas.openxmlformats.org/drawingml/2006/main">
             <a:off x="666750" y="323850"/>
-            <a:ext cx="6667500" cy="276225"/>
+            <a:ext cx="9810750" cy="276225"/>
           </a:xfrm>
           <a:prstGeom xmlns:a="http://schemas.openxmlformats.org/drawingml/2006/main" prst="rect">
             <a:avLst/>
@@ -2981,7 +2981,7 @@
                 <a:ea typeface="DejaVu Sans"/>
                 <a:cs typeface="DejaVu Sans"/>
               </a:rPr>
-              <a:t>TOPIC 1.1   LESSON 01</a:t>
+              <a:t>TOPIC 1.1   /   LESSON 01   /   EXTENSION</a:t>
             </a:r>
           </a:p>
         </p:txBody>
@@ -2991,7 +2991,7 @@
           <p:cNvPr id="2" name="heading">
             <a:extLst xmlns:a="http://schemas.openxmlformats.org/drawingml/2006/main">
               <a:ext uri="{FF2B5EF4-FFF2-40B4-BE49-F238E27FC236}">
-                <a16:creationId xmlns:a16="http://schemas.microsoft.com/office/drawing/2014/main" id="{EBC26364-CD99-4382-ADA9-3C034DF413A8}"/>
+                <a16:creationId xmlns:a16="http://schemas.microsoft.com/office/drawing/2014/main" id="{1C0757DA-CF37-470D-A0D6-B8B2990BE5F0}"/>
               </a:ext>
             </a:extLst>
           </p:cNvPr>
@@ -3038,7 +3038,7 @@
                 <a:ea typeface="DejaVu Sans"/>
                 <a:cs typeface="DejaVu Sans"/>
               </a:rPr>
-              <a:t>Finished early: apply it</a:t>
+              <a:t>Apply your learning</a:t>
             </a:r>
           </a:p>
         </p:txBody>
@@ -3048,7 +3048,7 @@
           <p:cNvPr id="3" name="footer">
             <a:extLst xmlns:a="http://schemas.openxmlformats.org/drawingml/2006/main">
               <a:ext uri="{FF2B5EF4-FFF2-40B4-BE49-F238E27FC236}">
-                <a16:creationId xmlns:a16="http://schemas.microsoft.com/office/drawing/2014/main" id="{853FA7F2-12F4-416A-BE3E-F31A2F7F9607}"/>
+                <a16:creationId xmlns:a16="http://schemas.microsoft.com/office/drawing/2014/main" id="{FB2DA3D7-B0C4-4641-8A04-DA56EC3EFDCE}"/>
               </a:ext>
             </a:extLst>
           </p:cNvPr>
@@ -3095,7 +3095,7 @@
                 <a:ea typeface="DejaVu Sans"/>
                 <a:cs typeface="DejaVu Sans"/>
               </a:rPr>
-              <a:t>Revise 360    OCR J277 1.1 Systems architecture    Extension</a:t>
+              <a:t>Revise 360    OCR J277 1.1 Systems architecture</a:t>
             </a:r>
           </a:p>
         </p:txBody>
@@ -3105,7 +3105,7 @@
           <p:cNvPr id="4" name="page">
             <a:extLst xmlns:a="http://schemas.openxmlformats.org/drawingml/2006/main">
               <a:ext uri="{FF2B5EF4-FFF2-40B4-BE49-F238E27FC236}">
-                <a16:creationId xmlns:a16="http://schemas.microsoft.com/office/drawing/2014/main" id="{AAB45861-5F8A-4DDF-B484-BD37FDC8EFA1}"/>
+                <a16:creationId xmlns:a16="http://schemas.microsoft.com/office/drawing/2014/main" id="{376033A6-EEB2-4D12-AE2C-005FAC04C934}"/>
               </a:ext>
             </a:extLst>
           </p:cNvPr>
@@ -3162,7 +3162,7 @@
           <p:cNvPr id="5" name="extension-lead">
             <a:extLst xmlns:a="http://schemas.openxmlformats.org/drawingml/2006/main">
               <a:ext uri="{FF2B5EF4-FFF2-40B4-BE49-F238E27FC236}">
-                <a16:creationId xmlns:a16="http://schemas.microsoft.com/office/drawing/2014/main" id="{9B27DE34-6CA7-4E02-803F-4989EDCF913C}"/>
+                <a16:creationId xmlns:a16="http://schemas.microsoft.com/office/drawing/2014/main" id="{EF7AD13F-5596-4DED-8969-D112B7116C13}"/>
               </a:ext>
             </a:extLst>
           </p:cNvPr>
@@ -3209,7 +3209,7 @@
                 <a:ea typeface="DejaVu Sans"/>
                 <a:cs typeface="DejaVu Sans"/>
               </a:rPr>
-              <a:t>After completing the experience and recording your score:</a:t>
+              <a:t>Once you have completed the experience, use your worksheet to reason further.</a:t>
             </a:r>
           </a:p>
         </p:txBody>
@@ -3219,7 +3219,7 @@
           <p:cNvPr id="6" name="extension-prompt">
             <a:extLst xmlns:a="http://schemas.openxmlformats.org/drawingml/2006/main">
               <a:ext uri="{FF2B5EF4-FFF2-40B4-BE49-F238E27FC236}">
-                <a16:creationId xmlns:a16="http://schemas.microsoft.com/office/drawing/2014/main" id="{C3D812A2-652B-4A1D-B757-C1DE87B9568E}"/>
+                <a16:creationId xmlns:a16="http://schemas.microsoft.com/office/drawing/2014/main" id="{C4D95834-CC54-49CB-8288-02E5947ACAD1}"/>
               </a:ext>
             </a:extLst>
           </p:cNvPr>
@@ -3276,7 +3276,7 @@
           <p:cNvPr id="7" name="extension-follow">
             <a:extLst xmlns:a="http://schemas.openxmlformats.org/drawingml/2006/main">
               <a:ext uri="{FF2B5EF4-FFF2-40B4-BE49-F238E27FC236}">
-                <a16:creationId xmlns:a16="http://schemas.microsoft.com/office/drawing/2014/main" id="{688BE8FA-B3CE-47AB-87E0-EA2F1BE42B5C}"/>
+                <a16:creationId xmlns:a16="http://schemas.microsoft.com/office/drawing/2014/main" id="{FFC2F040-26AF-4572-8FB5-F577BE0684F3}"/>
               </a:ext>
             </a:extLst>
           </p:cNvPr>
@@ -3331,7 +3331,7 @@
     </p:spTree>
     <p:extLst>
       <p:ext uri="{BB962C8B-B14F-4D97-AF65-F5344CB8AC3E}">
-        <p14:creationId xmlns:p14="http://schemas.microsoft.com/office/powerpoint/2010/main" val="1406304482"/>
+        <p14:creationId xmlns:p14="http://schemas.microsoft.com/office/powerpoint/2010/main" val="2053217470"/>
       </p:ext>
     </p:extLst>
   </p:cSld>
@@ -3362,7 +3362,7 @@
           <p:cNvPr id="8" name="topic">
             <a:extLst xmlns:a="http://schemas.openxmlformats.org/drawingml/2006/main">
               <a:ext uri="{FF2B5EF4-FFF2-40B4-BE49-F238E27FC236}">
-                <a16:creationId xmlns:a16="http://schemas.microsoft.com/office/drawing/2014/main" id="{539CA7A5-9A2E-48FF-8553-A203BC1CBCAD}"/>
+                <a16:creationId xmlns:a16="http://schemas.microsoft.com/office/drawing/2014/main" id="{06E90E2B-A73A-4E02-B5FD-4861985F76A8}"/>
               </a:ext>
             </a:extLst>
           </p:cNvPr>
@@ -3374,7 +3374,7 @@
         <p:spPr>
           <a:xfrm xmlns:a="http://schemas.openxmlformats.org/drawingml/2006/main">
             <a:off x="666750" y="323850"/>
-            <a:ext cx="6667500" cy="276225"/>
+            <a:ext cx="9810750" cy="276225"/>
           </a:xfrm>
           <a:prstGeom xmlns:a="http://schemas.openxmlformats.org/drawingml/2006/main" prst="rect">
             <a:avLst/>
@@ -3409,7 +3409,7 @@
                 <a:ea typeface="DejaVu Sans"/>
                 <a:cs typeface="DejaVu Sans"/>
               </a:rPr>
-              <a:t>TOPIC 1.1   LESSON 01</a:t>
+              <a:t>TOPIC 1.1   /   LESSON 01   /   EXTENSION</a:t>
             </a:r>
           </a:p>
         </p:txBody>
@@ -3419,7 +3419,7 @@
           <p:cNvPr id="2" name="heading">
             <a:extLst xmlns:a="http://schemas.openxmlformats.org/drawingml/2006/main">
               <a:ext uri="{FF2B5EF4-FFF2-40B4-BE49-F238E27FC236}">
-                <a16:creationId xmlns:a16="http://schemas.microsoft.com/office/drawing/2014/main" id="{D7FCD8AB-1059-447B-BEFF-B73584DCD009}"/>
+                <a16:creationId xmlns:a16="http://schemas.microsoft.com/office/drawing/2014/main" id="{C8BC788D-F540-4252-B219-0036E5EDB0D6}"/>
               </a:ext>
             </a:extLst>
           </p:cNvPr>
@@ -3466,7 +3466,7 @@
                 <a:ea typeface="DejaVu Sans"/>
                 <a:cs typeface="DejaVu Sans"/>
               </a:rPr>
-              <a:t>Finished early: check and stretch</a:t>
+              <a:t>Check and improve</a:t>
             </a:r>
           </a:p>
         </p:txBody>
@@ -3476,7 +3476,7 @@
           <p:cNvPr id="3" name="footer">
             <a:extLst xmlns:a="http://schemas.openxmlformats.org/drawingml/2006/main">
               <a:ext uri="{FF2B5EF4-FFF2-40B4-BE49-F238E27FC236}">
-                <a16:creationId xmlns:a16="http://schemas.microsoft.com/office/drawing/2014/main" id="{867FD1BC-80A6-420B-8967-6685D2EFECDC}"/>
+                <a16:creationId xmlns:a16="http://schemas.microsoft.com/office/drawing/2014/main" id="{D1B3392E-5E61-47C9-828C-20468269557A}"/>
               </a:ext>
             </a:extLst>
           </p:cNvPr>
@@ -3523,7 +3523,7 @@
                 <a:ea typeface="DejaVu Sans"/>
                 <a:cs typeface="DejaVu Sans"/>
               </a:rPr>
-              <a:t>Revise 360    OCR J277 1.1 Systems architecture    Extension</a:t>
+              <a:t>Revise 360    OCR J277 1.1 Systems architecture</a:t>
             </a:r>
           </a:p>
         </p:txBody>
@@ -3533,7 +3533,7 @@
           <p:cNvPr id="4" name="page">
             <a:extLst xmlns:a="http://schemas.openxmlformats.org/drawingml/2006/main">
               <a:ext uri="{FF2B5EF4-FFF2-40B4-BE49-F238E27FC236}">
-                <a16:creationId xmlns:a16="http://schemas.microsoft.com/office/drawing/2014/main" id="{31F128A5-3B2C-4119-838E-F80F445EB4A0}"/>
+                <a16:creationId xmlns:a16="http://schemas.microsoft.com/office/drawing/2014/main" id="{56A95BAA-E024-4B16-B6ED-22E611FC7227}"/>
               </a:ext>
             </a:extLst>
           </p:cNvPr>
@@ -3590,7 +3590,7 @@
           <p:cNvPr id="5" name="review">
             <a:extLst xmlns:a="http://schemas.openxmlformats.org/drawingml/2006/main">
               <a:ext uri="{FF2B5EF4-FFF2-40B4-BE49-F238E27FC236}">
-                <a16:creationId xmlns:a16="http://schemas.microsoft.com/office/drawing/2014/main" id="{C6DD9123-B12D-4AC9-AEEE-AF54B316E3A0}"/>
+                <a16:creationId xmlns:a16="http://schemas.microsoft.com/office/drawing/2014/main" id="{B38D01C2-34FA-44CE-81DE-2FEEFC371DA7}"/>
               </a:ext>
             </a:extLst>
           </p:cNvPr>
@@ -3637,7 +3637,7 @@
                 <a:ea typeface="DejaVu Sans"/>
                 <a:cs typeface="DejaVu Sans"/>
               </a:rPr>
-              <a:t>Use the worksheet and the experience feedback.</a:t>
+              <a:t>Use your worksheet notes and the experience feedback.</a:t>
             </a:r>
           </a:p>
         </p:txBody>
@@ -3647,7 +3647,7 @@
           <p:cNvPr id="6" name="extension-two">
             <a:extLst xmlns:a="http://schemas.openxmlformats.org/drawingml/2006/main">
               <a:ext uri="{FF2B5EF4-FFF2-40B4-BE49-F238E27FC236}">
-                <a16:creationId xmlns:a16="http://schemas.microsoft.com/office/drawing/2014/main" id="{3BACB536-1405-4027-805F-8BA14A397641}"/>
+                <a16:creationId xmlns:a16="http://schemas.microsoft.com/office/drawing/2014/main" id="{7AF7CF1F-C850-4639-85FE-AF9DF9AD3A97}"/>
               </a:ext>
             </a:extLst>
           </p:cNvPr>
@@ -3704,7 +3704,7 @@
           <p:cNvPr id="7" name="handoff">
             <a:extLst xmlns:a="http://schemas.openxmlformats.org/drawingml/2006/main">
               <a:ext uri="{FF2B5EF4-FFF2-40B4-BE49-F238E27FC236}">
-                <a16:creationId xmlns:a16="http://schemas.microsoft.com/office/drawing/2014/main" id="{55262B9F-6B95-40D4-8DBF-08E0078BEBF4}"/>
+                <a16:creationId xmlns:a16="http://schemas.microsoft.com/office/drawing/2014/main" id="{DD850766-2343-4BF4-BAF8-057B63DFD726}"/>
               </a:ext>
             </a:extLst>
           </p:cNvPr>
@@ -3751,7 +3751,7 @@
                 <a:ea typeface="DejaVu Sans"/>
                 <a:cs typeface="DejaVu Sans"/>
               </a:rPr>
-              <a:t>When the class is ready, close the experience and answer the plenary exam quiz.</a:t>
+              <a:t>Near the end of the lesson, close the experience for the plenary knowledge check.</a:t>
             </a:r>
           </a:p>
         </p:txBody>
@@ -3759,7 +3759,7 @@
     </p:spTree>
     <p:extLst>
       <p:ext uri="{BB962C8B-B14F-4D97-AF65-F5344CB8AC3E}">
-        <p14:creationId xmlns:p14="http://schemas.microsoft.com/office/powerpoint/2010/main" val="1277491272"/>
+        <p14:creationId xmlns:p14="http://schemas.microsoft.com/office/powerpoint/2010/main" val="1779809242"/>
       </p:ext>
     </p:extLst>
   </p:cSld>
@@ -3772,7 +3772,7 @@
     <p:bg>
       <p:bgPr>
         <a:solidFill xmlns:a="http://schemas.openxmlformats.org/drawingml/2006/main">
-          <a:srgbClr val="FFFFFF"/>
+          <a:srgbClr val="EAF3FF"/>
         </a:solidFill>
       </p:bgPr>
     </p:bg>
@@ -3790,7 +3790,7 @@
           <p:cNvPr id="10" name="topic">
             <a:extLst xmlns:a="http://schemas.openxmlformats.org/drawingml/2006/main">
               <a:ext uri="{FF2B5EF4-FFF2-40B4-BE49-F238E27FC236}">
-                <a16:creationId xmlns:a16="http://schemas.microsoft.com/office/drawing/2014/main" id="{83353180-E2AD-4BE5-AA73-970EA1CBD848}"/>
+                <a16:creationId xmlns:a16="http://schemas.microsoft.com/office/drawing/2014/main" id="{7BE29F04-8DCB-4C75-B018-DF43629C6894}"/>
               </a:ext>
             </a:extLst>
           </p:cNvPr>
@@ -3802,7 +3802,7 @@
         <p:spPr>
           <a:xfrm xmlns:a="http://schemas.openxmlformats.org/drawingml/2006/main">
             <a:off x="666750" y="323850"/>
-            <a:ext cx="6667500" cy="276225"/>
+            <a:ext cx="9810750" cy="276225"/>
           </a:xfrm>
           <a:prstGeom xmlns:a="http://schemas.openxmlformats.org/drawingml/2006/main" prst="rect">
             <a:avLst/>
@@ -3837,7 +3837,7 @@
                 <a:ea typeface="DejaVu Sans"/>
                 <a:cs typeface="DejaVu Sans"/>
               </a:rPr>
-              <a:t>TOPIC 1.1   LESSON 01</a:t>
+              <a:t>TOPIC 1.1   /   LESSON 01   /   CHECK</a:t>
             </a:r>
           </a:p>
         </p:txBody>
@@ -3847,7 +3847,7 @@
           <p:cNvPr id="2" name="heading">
             <a:extLst xmlns:a="http://schemas.openxmlformats.org/drawingml/2006/main">
               <a:ext uri="{FF2B5EF4-FFF2-40B4-BE49-F238E27FC236}">
-                <a16:creationId xmlns:a16="http://schemas.microsoft.com/office/drawing/2014/main" id="{62616E08-A9DA-4290-A866-8EC25FFFC46F}"/>
+                <a16:creationId xmlns:a16="http://schemas.microsoft.com/office/drawing/2014/main" id="{6A92E434-A16A-47D3-A66A-5DC725C49DCB}"/>
               </a:ext>
             </a:extLst>
           </p:cNvPr>
@@ -3894,7 +3894,7 @@
                 <a:ea typeface="DejaVu Sans"/>
                 <a:cs typeface="DejaVu Sans"/>
               </a:rPr>
-              <a:t>Finished early: sample answers</a:t>
+              <a:t>Application: sample answers</a:t>
             </a:r>
           </a:p>
         </p:txBody>
@@ -3904,7 +3904,7 @@
           <p:cNvPr id="3" name="footer">
             <a:extLst xmlns:a="http://schemas.openxmlformats.org/drawingml/2006/main">
               <a:ext uri="{FF2B5EF4-FFF2-40B4-BE49-F238E27FC236}">
-                <a16:creationId xmlns:a16="http://schemas.microsoft.com/office/drawing/2014/main" id="{FE921B58-8C12-4FF8-B90B-9ADD73F0F298}"/>
+                <a16:creationId xmlns:a16="http://schemas.microsoft.com/office/drawing/2014/main" id="{B4DED02B-1654-4435-B517-5B3AE35D43AE}"/>
               </a:ext>
             </a:extLst>
           </p:cNvPr>
@@ -3951,7 +3951,7 @@
                 <a:ea typeface="DejaVu Sans"/>
                 <a:cs typeface="DejaVu Sans"/>
               </a:rPr>
-              <a:t>Revise 360    OCR J277 1.1 Systems architecture    Check</a:t>
+              <a:t>Revise 360    OCR J277 1.1 Systems architecture</a:t>
             </a:r>
           </a:p>
         </p:txBody>
@@ -3961,7 +3961,7 @@
           <p:cNvPr id="4" name="page">
             <a:extLst xmlns:a="http://schemas.openxmlformats.org/drawingml/2006/main">
               <a:ext uri="{FF2B5EF4-FFF2-40B4-BE49-F238E27FC236}">
-                <a16:creationId xmlns:a16="http://schemas.microsoft.com/office/drawing/2014/main" id="{DC842BDD-8E98-496E-A2CA-7A548AC3317D}"/>
+                <a16:creationId xmlns:a16="http://schemas.microsoft.com/office/drawing/2014/main" id="{325466D0-3B62-4CDC-9B15-BE08DF4991F1}"/>
               </a:ext>
             </a:extLst>
           </p:cNvPr>
@@ -4018,7 +4018,7 @@
           <p:cNvPr id="5" name="extension-check">
             <a:extLst xmlns:a="http://schemas.openxmlformats.org/drawingml/2006/main">
               <a:ext uri="{FF2B5EF4-FFF2-40B4-BE49-F238E27FC236}">
-                <a16:creationId xmlns:a16="http://schemas.microsoft.com/office/drawing/2014/main" id="{74805DE7-B329-4400-B322-780ACFD75291}"/>
+                <a16:creationId xmlns:a16="http://schemas.microsoft.com/office/drawing/2014/main" id="{D25031BD-F67D-4377-9E6A-7C838B57DBFB}"/>
               </a:ext>
             </a:extLst>
           </p:cNvPr>
@@ -4075,7 +4075,7 @@
           <p:cNvPr id="6" name="answer-application">
             <a:extLst xmlns:a="http://schemas.openxmlformats.org/drawingml/2006/main">
               <a:ext uri="{FF2B5EF4-FFF2-40B4-BE49-F238E27FC236}">
-                <a16:creationId xmlns:a16="http://schemas.microsoft.com/office/drawing/2014/main" id="{C6873105-C95A-42BE-98FA-71D7982AE4A2}"/>
+                <a16:creationId xmlns:a16="http://schemas.microsoft.com/office/drawing/2014/main" id="{0B0DB290-B7CB-4C96-87EB-E52FFA54A599}"/>
               </a:ext>
             </a:extLst>
           </p:cNvPr>
@@ -4132,7 +4132,7 @@
           <p:cNvPr id="7" name="answer-application-body">
             <a:extLst xmlns:a="http://schemas.openxmlformats.org/drawingml/2006/main">
               <a:ext uri="{FF2B5EF4-FFF2-40B4-BE49-F238E27FC236}">
-                <a16:creationId xmlns:a16="http://schemas.microsoft.com/office/drawing/2014/main" id="{A2EDA5B5-867D-4C06-8798-943B16A115ED}"/>
+                <a16:creationId xmlns:a16="http://schemas.microsoft.com/office/drawing/2014/main" id="{3B88B8D5-C132-4138-8401-8F28567AD3AD}"/>
               </a:ext>
             </a:extLst>
           </p:cNvPr>
@@ -4189,7 +4189,7 @@
           <p:cNvPr id="8" name="answer-stretch">
             <a:extLst xmlns:a="http://schemas.openxmlformats.org/drawingml/2006/main">
               <a:ext uri="{FF2B5EF4-FFF2-40B4-BE49-F238E27FC236}">
-                <a16:creationId xmlns:a16="http://schemas.microsoft.com/office/drawing/2014/main" id="{7205AFDD-0D87-4428-BC57-952785515CB3}"/>
+                <a16:creationId xmlns:a16="http://schemas.microsoft.com/office/drawing/2014/main" id="{33CD9CEE-ED34-4F86-AE4F-965723FB1BC0}"/>
               </a:ext>
             </a:extLst>
           </p:cNvPr>
@@ -4246,7 +4246,7 @@
           <p:cNvPr id="9" name="answer-stretch-body">
             <a:extLst xmlns:a="http://schemas.openxmlformats.org/drawingml/2006/main">
               <a:ext uri="{FF2B5EF4-FFF2-40B4-BE49-F238E27FC236}">
-                <a16:creationId xmlns:a16="http://schemas.microsoft.com/office/drawing/2014/main" id="{33216DF1-622B-40EE-A81C-E2227BE8A619}"/>
+                <a16:creationId xmlns:a16="http://schemas.microsoft.com/office/drawing/2014/main" id="{9D5D68A7-D7A8-499F-BAA7-FC0C0699825C}"/>
               </a:ext>
             </a:extLst>
           </p:cNvPr>
@@ -4301,7 +4301,7 @@
     </p:spTree>
     <p:extLst>
       <p:ext uri="{BB962C8B-B14F-4D97-AF65-F5344CB8AC3E}">
-        <p14:creationId xmlns:p14="http://schemas.microsoft.com/office/powerpoint/2010/main" val="1142181047"/>
+        <p14:creationId xmlns:p14="http://schemas.microsoft.com/office/powerpoint/2010/main" val="1223422640"/>
       </p:ext>
     </p:extLst>
   </p:cSld>
@@ -4314,7 +4314,7 @@
     <p:bg>
       <p:bgPr>
         <a:solidFill xmlns:a="http://schemas.openxmlformats.org/drawingml/2006/main">
-          <a:srgbClr val="FFFFFF"/>
+          <a:srgbClr val="EAF3FF"/>
         </a:solidFill>
       </p:bgPr>
     </p:bg>
@@ -4332,7 +4332,7 @@
           <p:cNvPr id="12" name="topic">
             <a:extLst xmlns:a="http://schemas.openxmlformats.org/drawingml/2006/main">
               <a:ext uri="{FF2B5EF4-FFF2-40B4-BE49-F238E27FC236}">
-                <a16:creationId xmlns:a16="http://schemas.microsoft.com/office/drawing/2014/main" id="{6E45B532-C271-4DEF-B195-2CDF3013B015}"/>
+                <a16:creationId xmlns:a16="http://schemas.microsoft.com/office/drawing/2014/main" id="{F229DF5B-F7AA-4338-85D1-51A220EA623E}"/>
               </a:ext>
             </a:extLst>
           </p:cNvPr>
@@ -4344,7 +4344,7 @@
         <p:spPr>
           <a:xfrm xmlns:a="http://schemas.openxmlformats.org/drawingml/2006/main">
             <a:off x="666750" y="323850"/>
-            <a:ext cx="6667500" cy="276225"/>
+            <a:ext cx="9810750" cy="276225"/>
           </a:xfrm>
           <a:prstGeom xmlns:a="http://schemas.openxmlformats.org/drawingml/2006/main" prst="rect">
             <a:avLst/>
@@ -4379,7 +4379,7 @@
                 <a:ea typeface="DejaVu Sans"/>
                 <a:cs typeface="DejaVu Sans"/>
               </a:rPr>
-              <a:t>TOPIC 1.1   LESSON 01</a:t>
+              <a:t>TOPIC 1.1   /   LESSON 01   /   ANSWERS</a:t>
             </a:r>
           </a:p>
         </p:txBody>
@@ -4389,7 +4389,7 @@
           <p:cNvPr id="2" name="heading">
             <a:extLst xmlns:a="http://schemas.openxmlformats.org/drawingml/2006/main">
               <a:ext uri="{FF2B5EF4-FFF2-40B4-BE49-F238E27FC236}">
-                <a16:creationId xmlns:a16="http://schemas.microsoft.com/office/drawing/2014/main" id="{103B1BF9-356C-43A6-B667-7C5BC0FA34B5}"/>
+                <a16:creationId xmlns:a16="http://schemas.microsoft.com/office/drawing/2014/main" id="{6A5B4D4B-AF5A-4763-A12B-8DF1738B43B0}"/>
               </a:ext>
             </a:extLst>
           </p:cNvPr>
@@ -4446,7 +4446,7 @@
           <p:cNvPr id="3" name="footer">
             <a:extLst xmlns:a="http://schemas.openxmlformats.org/drawingml/2006/main">
               <a:ext uri="{FF2B5EF4-FFF2-40B4-BE49-F238E27FC236}">
-                <a16:creationId xmlns:a16="http://schemas.microsoft.com/office/drawing/2014/main" id="{255E3FA3-42F8-4E70-9215-D7DFCE3EE1AE}"/>
+                <a16:creationId xmlns:a16="http://schemas.microsoft.com/office/drawing/2014/main" id="{2220A891-4A9D-43ED-AEF5-97078D03F483}"/>
               </a:ext>
             </a:extLst>
           </p:cNvPr>
@@ -4493,7 +4493,7 @@
                 <a:ea typeface="DejaVu Sans"/>
                 <a:cs typeface="DejaVu Sans"/>
               </a:rPr>
-              <a:t>Revise 360    OCR J277 1.1 Systems architecture    Answers</a:t>
+              <a:t>Revise 360    OCR J277 1.1 Systems architecture</a:t>
             </a:r>
           </a:p>
         </p:txBody>
@@ -4503,7 +4503,7 @@
           <p:cNvPr id="4" name="page">
             <a:extLst xmlns:a="http://schemas.openxmlformats.org/drawingml/2006/main">
               <a:ext uri="{FF2B5EF4-FFF2-40B4-BE49-F238E27FC236}">
-                <a16:creationId xmlns:a16="http://schemas.microsoft.com/office/drawing/2014/main" id="{ED8FB950-47FB-490B-88FD-08B534F6A6A6}"/>
+                <a16:creationId xmlns:a16="http://schemas.microsoft.com/office/drawing/2014/main" id="{1B8D3BC2-A78A-4C20-A7E3-A5270A791A98}"/>
               </a:ext>
             </a:extLst>
           </p:cNvPr>
@@ -4560,7 +4560,7 @@
           <p:cNvPr id="5" name="check-stations">
             <a:extLst xmlns:a="http://schemas.openxmlformats.org/drawingml/2006/main">
               <a:ext uri="{FF2B5EF4-FFF2-40B4-BE49-F238E27FC236}">
-                <a16:creationId xmlns:a16="http://schemas.microsoft.com/office/drawing/2014/main" id="{292F4E77-E5D4-4165-AF43-788EBC165CA0}"/>
+                <a16:creationId xmlns:a16="http://schemas.microsoft.com/office/drawing/2014/main" id="{8728258B-C734-4576-9529-1003587758AA}"/>
               </a:ext>
             </a:extLst>
           </p:cNvPr>
@@ -4617,7 +4617,7 @@
           <p:cNvPr id="6" name="station-name-0">
             <a:extLst xmlns:a="http://schemas.openxmlformats.org/drawingml/2006/main">
               <a:ext uri="{FF2B5EF4-FFF2-40B4-BE49-F238E27FC236}">
-                <a16:creationId xmlns:a16="http://schemas.microsoft.com/office/drawing/2014/main" id="{6593E34C-37C1-4A28-919F-218EC7D65FEA}"/>
+                <a16:creationId xmlns:a16="http://schemas.microsoft.com/office/drawing/2014/main" id="{322C8539-3B08-4D2B-9C8D-A17EBE49F56F}"/>
               </a:ext>
             </a:extLst>
           </p:cNvPr>
@@ -4674,7 +4674,7 @@
           <p:cNvPr id="7" name="station-answer-0">
             <a:extLst xmlns:a="http://schemas.openxmlformats.org/drawingml/2006/main">
               <a:ext uri="{FF2B5EF4-FFF2-40B4-BE49-F238E27FC236}">
-                <a16:creationId xmlns:a16="http://schemas.microsoft.com/office/drawing/2014/main" id="{CB352752-8DBF-4EED-91B2-E3D888D718A0}"/>
+                <a16:creationId xmlns:a16="http://schemas.microsoft.com/office/drawing/2014/main" id="{7F9179E1-3A9F-4BCD-8115-6A198C7F6852}"/>
               </a:ext>
             </a:extLst>
           </p:cNvPr>
@@ -4731,7 +4731,7 @@
           <p:cNvPr id="8" name="station-name-1">
             <a:extLst xmlns:a="http://schemas.openxmlformats.org/drawingml/2006/main">
               <a:ext uri="{FF2B5EF4-FFF2-40B4-BE49-F238E27FC236}">
-                <a16:creationId xmlns:a16="http://schemas.microsoft.com/office/drawing/2014/main" id="{537968F7-DA6B-454A-B4E2-20B3230A0486}"/>
+                <a16:creationId xmlns:a16="http://schemas.microsoft.com/office/drawing/2014/main" id="{BE002985-A892-426C-9711-0A7E0515A2D7}"/>
               </a:ext>
             </a:extLst>
           </p:cNvPr>
@@ -4788,7 +4788,7 @@
           <p:cNvPr id="9" name="station-answer-1">
             <a:extLst xmlns:a="http://schemas.openxmlformats.org/drawingml/2006/main">
               <a:ext uri="{FF2B5EF4-FFF2-40B4-BE49-F238E27FC236}">
-                <a16:creationId xmlns:a16="http://schemas.microsoft.com/office/drawing/2014/main" id="{78A8E6F7-24C1-4235-84B4-764C8D2FD949}"/>
+                <a16:creationId xmlns:a16="http://schemas.microsoft.com/office/drawing/2014/main" id="{330D8AA9-3F3B-4814-A459-C1900EF5C515}"/>
               </a:ext>
             </a:extLst>
           </p:cNvPr>
@@ -4845,7 +4845,7 @@
           <p:cNvPr id="10" name="station-name-2">
             <a:extLst xmlns:a="http://schemas.openxmlformats.org/drawingml/2006/main">
               <a:ext uri="{FF2B5EF4-FFF2-40B4-BE49-F238E27FC236}">
-                <a16:creationId xmlns:a16="http://schemas.microsoft.com/office/drawing/2014/main" id="{BAA9C99D-ABB8-48F6-BF26-6353A5E08BCC}"/>
+                <a16:creationId xmlns:a16="http://schemas.microsoft.com/office/drawing/2014/main" id="{D775DDBC-29F5-44F1-BA2C-E6FFFF68AA3E}"/>
               </a:ext>
             </a:extLst>
           </p:cNvPr>
@@ -4902,7 +4902,7 @@
           <p:cNvPr id="11" name="station-answer-2">
             <a:extLst xmlns:a="http://schemas.openxmlformats.org/drawingml/2006/main">
               <a:ext uri="{FF2B5EF4-FFF2-40B4-BE49-F238E27FC236}">
-                <a16:creationId xmlns:a16="http://schemas.microsoft.com/office/drawing/2014/main" id="{0B6893A3-5556-4059-913F-31D57C2BB0DD}"/>
+                <a16:creationId xmlns:a16="http://schemas.microsoft.com/office/drawing/2014/main" id="{7F0051BD-2269-495F-9EE6-3BF92C039BF3}"/>
               </a:ext>
             </a:extLst>
           </p:cNvPr>
@@ -4957,7 +4957,7 @@
     </p:spTree>
     <p:extLst>
       <p:ext uri="{BB962C8B-B14F-4D97-AF65-F5344CB8AC3E}">
-        <p14:creationId xmlns:p14="http://schemas.microsoft.com/office/powerpoint/2010/main" val="1187306397"/>
+        <p14:creationId xmlns:p14="http://schemas.microsoft.com/office/powerpoint/2010/main" val="439367537"/>
       </p:ext>
     </p:extLst>
   </p:cSld>
@@ -4970,7 +4970,7 @@
     <p:bg>
       <p:bgPr>
         <a:solidFill xmlns:a="http://schemas.openxmlformats.org/drawingml/2006/main">
-          <a:srgbClr val="FFFFFF"/>
+          <a:srgbClr val="EAF3FF"/>
         </a:solidFill>
       </p:bgPr>
     </p:bg>
@@ -4988,7 +4988,7 @@
           <p:cNvPr id="12" name="topic">
             <a:extLst xmlns:a="http://schemas.openxmlformats.org/drawingml/2006/main">
               <a:ext uri="{FF2B5EF4-FFF2-40B4-BE49-F238E27FC236}">
-                <a16:creationId xmlns:a16="http://schemas.microsoft.com/office/drawing/2014/main" id="{1D8CC889-DE90-4E21-A56D-752B5F395F3A}"/>
+                <a16:creationId xmlns:a16="http://schemas.microsoft.com/office/drawing/2014/main" id="{147F05C4-C084-4442-ACC2-4173BAC5EEAC}"/>
               </a:ext>
             </a:extLst>
           </p:cNvPr>
@@ -5000,7 +5000,7 @@
         <p:spPr>
           <a:xfrm xmlns:a="http://schemas.openxmlformats.org/drawingml/2006/main">
             <a:off x="666750" y="323850"/>
-            <a:ext cx="6667500" cy="276225"/>
+            <a:ext cx="9810750" cy="276225"/>
           </a:xfrm>
           <a:prstGeom xmlns:a="http://schemas.openxmlformats.org/drawingml/2006/main" prst="rect">
             <a:avLst/>
@@ -5035,7 +5035,7 @@
                 <a:ea typeface="DejaVu Sans"/>
                 <a:cs typeface="DejaVu Sans"/>
               </a:rPr>
-              <a:t>TOPIC 1.1   LESSON 01</a:t>
+              <a:t>TOPIC 1.1   /   LESSON 01   /   ANSWERS</a:t>
             </a:r>
           </a:p>
         </p:txBody>
@@ -5045,7 +5045,7 @@
           <p:cNvPr id="2" name="heading">
             <a:extLst xmlns:a="http://schemas.openxmlformats.org/drawingml/2006/main">
               <a:ext uri="{FF2B5EF4-FFF2-40B4-BE49-F238E27FC236}">
-                <a16:creationId xmlns:a16="http://schemas.microsoft.com/office/drawing/2014/main" id="{0EE45689-92A2-4814-9953-258B0EF9157C}"/>
+                <a16:creationId xmlns:a16="http://schemas.microsoft.com/office/drawing/2014/main" id="{1636DE75-B89A-44D9-A1EE-EEA1CECE5407}"/>
               </a:ext>
             </a:extLst>
           </p:cNvPr>
@@ -5102,7 +5102,7 @@
           <p:cNvPr id="3" name="footer">
             <a:extLst xmlns:a="http://schemas.openxmlformats.org/drawingml/2006/main">
               <a:ext uri="{FF2B5EF4-FFF2-40B4-BE49-F238E27FC236}">
-                <a16:creationId xmlns:a16="http://schemas.microsoft.com/office/drawing/2014/main" id="{260F4A68-E29E-430D-9A0C-56D1F867CC64}"/>
+                <a16:creationId xmlns:a16="http://schemas.microsoft.com/office/drawing/2014/main" id="{810C340D-CA5F-44CC-93EC-8AFB297D1A2E}"/>
               </a:ext>
             </a:extLst>
           </p:cNvPr>
@@ -5149,7 +5149,7 @@
                 <a:ea typeface="DejaVu Sans"/>
                 <a:cs typeface="DejaVu Sans"/>
               </a:rPr>
-              <a:t>Revise 360    OCR J277 1.1 Systems architecture    Answers</a:t>
+              <a:t>Revise 360    OCR J277 1.1 Systems architecture</a:t>
             </a:r>
           </a:p>
         </p:txBody>
@@ -5159,7 +5159,7 @@
           <p:cNvPr id="4" name="page">
             <a:extLst xmlns:a="http://schemas.openxmlformats.org/drawingml/2006/main">
               <a:ext uri="{FF2B5EF4-FFF2-40B4-BE49-F238E27FC236}">
-                <a16:creationId xmlns:a16="http://schemas.microsoft.com/office/drawing/2014/main" id="{C974B8F7-E486-4F15-A314-6ABC74F590B6}"/>
+                <a16:creationId xmlns:a16="http://schemas.microsoft.com/office/drawing/2014/main" id="{A219F2FB-538E-4034-85CA-05410279D51F}"/>
               </a:ext>
             </a:extLst>
           </p:cNvPr>
@@ -5216,7 +5216,7 @@
           <p:cNvPr id="5" name="check-stations">
             <a:extLst xmlns:a="http://schemas.openxmlformats.org/drawingml/2006/main">
               <a:ext uri="{FF2B5EF4-FFF2-40B4-BE49-F238E27FC236}">
-                <a16:creationId xmlns:a16="http://schemas.microsoft.com/office/drawing/2014/main" id="{5E334738-0E92-44E8-B545-332AF0707F26}"/>
+                <a16:creationId xmlns:a16="http://schemas.microsoft.com/office/drawing/2014/main" id="{4F5ADB70-7F02-4380-ABBD-EF3090D4BD59}"/>
               </a:ext>
             </a:extLst>
           </p:cNvPr>
@@ -5273,7 +5273,7 @@
           <p:cNvPr id="6" name="station-name-3">
             <a:extLst xmlns:a="http://schemas.openxmlformats.org/drawingml/2006/main">
               <a:ext uri="{FF2B5EF4-FFF2-40B4-BE49-F238E27FC236}">
-                <a16:creationId xmlns:a16="http://schemas.microsoft.com/office/drawing/2014/main" id="{909C8B13-DA84-47E9-BD12-73A47A0F27DE}"/>
+                <a16:creationId xmlns:a16="http://schemas.microsoft.com/office/drawing/2014/main" id="{69F27787-AE86-44A8-BFAE-ACA17A8A8DF3}"/>
               </a:ext>
             </a:extLst>
           </p:cNvPr>
@@ -5330,7 +5330,7 @@
           <p:cNvPr id="7" name="station-answer-3">
             <a:extLst xmlns:a="http://schemas.openxmlformats.org/drawingml/2006/main">
               <a:ext uri="{FF2B5EF4-FFF2-40B4-BE49-F238E27FC236}">
-                <a16:creationId xmlns:a16="http://schemas.microsoft.com/office/drawing/2014/main" id="{CBEF5D39-394C-4196-8CD4-00F83E536AE9}"/>
+                <a16:creationId xmlns:a16="http://schemas.microsoft.com/office/drawing/2014/main" id="{43A6CBBF-847A-454A-913F-22474F8C99B9}"/>
               </a:ext>
             </a:extLst>
           </p:cNvPr>
@@ -5387,7 +5387,7 @@
           <p:cNvPr id="8" name="station-name-4">
             <a:extLst xmlns:a="http://schemas.openxmlformats.org/drawingml/2006/main">
               <a:ext uri="{FF2B5EF4-FFF2-40B4-BE49-F238E27FC236}">
-                <a16:creationId xmlns:a16="http://schemas.microsoft.com/office/drawing/2014/main" id="{55F01712-A709-4A00-B6FF-D8283145E08C}"/>
+                <a16:creationId xmlns:a16="http://schemas.microsoft.com/office/drawing/2014/main" id="{93486925-13D5-4ACB-8CA4-BE0B64BC8FFD}"/>
               </a:ext>
             </a:extLst>
           </p:cNvPr>
@@ -5444,7 +5444,7 @@
           <p:cNvPr id="9" name="station-answer-4">
             <a:extLst xmlns:a="http://schemas.openxmlformats.org/drawingml/2006/main">
               <a:ext uri="{FF2B5EF4-FFF2-40B4-BE49-F238E27FC236}">
-                <a16:creationId xmlns:a16="http://schemas.microsoft.com/office/drawing/2014/main" id="{814797C4-D471-4179-9271-9E22F6A38768}"/>
+                <a16:creationId xmlns:a16="http://schemas.microsoft.com/office/drawing/2014/main" id="{2BB95ED4-FF57-46E9-AA4D-849F62345231}"/>
               </a:ext>
             </a:extLst>
           </p:cNvPr>
@@ -5501,7 +5501,7 @@
           <p:cNvPr id="10" name="station-name-5">
             <a:extLst xmlns:a="http://schemas.openxmlformats.org/drawingml/2006/main">
               <a:ext uri="{FF2B5EF4-FFF2-40B4-BE49-F238E27FC236}">
-                <a16:creationId xmlns:a16="http://schemas.microsoft.com/office/drawing/2014/main" id="{A06F403D-3B26-4FB2-B71B-3AA2048DE525}"/>
+                <a16:creationId xmlns:a16="http://schemas.microsoft.com/office/drawing/2014/main" id="{682BAB57-D483-447C-A6AE-03AC1601338A}"/>
               </a:ext>
             </a:extLst>
           </p:cNvPr>
@@ -5558,7 +5558,7 @@
           <p:cNvPr id="11" name="station-answer-5">
             <a:extLst xmlns:a="http://schemas.openxmlformats.org/drawingml/2006/main">
               <a:ext uri="{FF2B5EF4-FFF2-40B4-BE49-F238E27FC236}">
-                <a16:creationId xmlns:a16="http://schemas.microsoft.com/office/drawing/2014/main" id="{07300700-DBB0-4B73-B638-104ED26D5DE6}"/>
+                <a16:creationId xmlns:a16="http://schemas.microsoft.com/office/drawing/2014/main" id="{02A383CA-55D9-42CD-8EEE-7E1BD69E3A09}"/>
               </a:ext>
             </a:extLst>
           </p:cNvPr>
@@ -5613,7 +5613,7 @@
     </p:spTree>
     <p:extLst>
       <p:ext uri="{BB962C8B-B14F-4D97-AF65-F5344CB8AC3E}">
-        <p14:creationId xmlns:p14="http://schemas.microsoft.com/office/powerpoint/2010/main" val="654764363"/>
+        <p14:creationId xmlns:p14="http://schemas.microsoft.com/office/powerpoint/2010/main" val="1251455536"/>
       </p:ext>
     </p:extLst>
   </p:cSld>
@@ -5626,7 +5626,7 @@
     <p:bg>
       <p:bgPr>
         <a:solidFill xmlns:a="http://schemas.openxmlformats.org/drawingml/2006/main">
-          <a:srgbClr val="FFFFFF"/>
+          <a:srgbClr val="EAF3FF"/>
         </a:solidFill>
       </p:bgPr>
     </p:bg>
@@ -5644,7 +5644,7 @@
           <p:cNvPr id="18" name="topic">
             <a:extLst xmlns:a="http://schemas.openxmlformats.org/drawingml/2006/main">
               <a:ext uri="{FF2B5EF4-FFF2-40B4-BE49-F238E27FC236}">
-                <a16:creationId xmlns:a16="http://schemas.microsoft.com/office/drawing/2014/main" id="{F1A773CA-B128-4D28-8428-81CDAA11FD41}"/>
+                <a16:creationId xmlns:a16="http://schemas.microsoft.com/office/drawing/2014/main" id="{D4C0DC17-ADB2-48D4-BFF2-E83744F8586D}"/>
               </a:ext>
             </a:extLst>
           </p:cNvPr>
@@ -5656,7 +5656,7 @@
         <p:spPr>
           <a:xfrm xmlns:a="http://schemas.openxmlformats.org/drawingml/2006/main">
             <a:off x="666750" y="323850"/>
-            <a:ext cx="6667500" cy="276225"/>
+            <a:ext cx="9810750" cy="276225"/>
           </a:xfrm>
           <a:prstGeom xmlns:a="http://schemas.openxmlformats.org/drawingml/2006/main" prst="rect">
             <a:avLst/>
@@ -5691,7 +5691,7 @@
                 <a:ea typeface="DejaVu Sans"/>
                 <a:cs typeface="DejaVu Sans"/>
               </a:rPr>
-              <a:t>TOPIC 1.1   LESSON 01</a:t>
+              <a:t>TOPIC 1.1   /   LESSON 01   /   CHECK</a:t>
             </a:r>
           </a:p>
         </p:txBody>
@@ -5701,7 +5701,7 @@
           <p:cNvPr id="2" name="heading">
             <a:extLst xmlns:a="http://schemas.openxmlformats.org/drawingml/2006/main">
               <a:ext uri="{FF2B5EF4-FFF2-40B4-BE49-F238E27FC236}">
-                <a16:creationId xmlns:a16="http://schemas.microsoft.com/office/drawing/2014/main" id="{9FC1F705-A340-48A1-B636-A31C4AB2608F}"/>
+                <a16:creationId xmlns:a16="http://schemas.microsoft.com/office/drawing/2014/main" id="{B7A2D056-15E7-4968-954A-9FD4F53D3B9F}"/>
               </a:ext>
             </a:extLst>
           </p:cNvPr>
@@ -5758,7 +5758,7 @@
           <p:cNvPr id="3" name="footer">
             <a:extLst xmlns:a="http://schemas.openxmlformats.org/drawingml/2006/main">
               <a:ext uri="{FF2B5EF4-FFF2-40B4-BE49-F238E27FC236}">
-                <a16:creationId xmlns:a16="http://schemas.microsoft.com/office/drawing/2014/main" id="{EB87D0EA-17D3-4BEB-8C96-D45573CFB86A}"/>
+                <a16:creationId xmlns:a16="http://schemas.microsoft.com/office/drawing/2014/main" id="{AA256596-3A6A-498F-84E8-569ECD36331E}"/>
               </a:ext>
             </a:extLst>
           </p:cNvPr>
@@ -5805,7 +5805,7 @@
                 <a:ea typeface="DejaVu Sans"/>
                 <a:cs typeface="DejaVu Sans"/>
               </a:rPr>
-              <a:t>Revise 360    OCR J277 1.1 Systems architecture    Check</a:t>
+              <a:t>Revise 360    OCR J277 1.1 Systems architecture</a:t>
             </a:r>
           </a:p>
         </p:txBody>
@@ -5815,7 +5815,7 @@
           <p:cNvPr id="4" name="page">
             <a:extLst xmlns:a="http://schemas.openxmlformats.org/drawingml/2006/main">
               <a:ext uri="{FF2B5EF4-FFF2-40B4-BE49-F238E27FC236}">
-                <a16:creationId xmlns:a16="http://schemas.microsoft.com/office/drawing/2014/main" id="{B58A5093-A947-4C02-85D4-29F9A04C7F1B}"/>
+                <a16:creationId xmlns:a16="http://schemas.microsoft.com/office/drawing/2014/main" id="{3904D8D1-9955-4A01-B272-48D2B51D140E}"/>
               </a:ext>
             </a:extLst>
           </p:cNvPr>
@@ -5872,7 +5872,7 @@
           <p:cNvPr id="5" name="star-key">
             <a:extLst xmlns:a="http://schemas.openxmlformats.org/drawingml/2006/main">
               <a:ext uri="{FF2B5EF4-FFF2-40B4-BE49-F238E27FC236}">
-                <a16:creationId xmlns:a16="http://schemas.microsoft.com/office/drawing/2014/main" id="{03D163F3-D587-40F1-8327-9E6EA5E7EC72}"/>
+                <a16:creationId xmlns:a16="http://schemas.microsoft.com/office/drawing/2014/main" id="{A61D5CC8-A396-43E2-A47E-3B55C52A86AD}"/>
               </a:ext>
             </a:extLst>
           </p:cNvPr>
@@ -5929,7 +5929,7 @@
           <p:cNvPr id="6" name="number-1">
             <a:extLst xmlns:a="http://schemas.openxmlformats.org/drawingml/2006/main">
               <a:ext uri="{FF2B5EF4-FFF2-40B4-BE49-F238E27FC236}">
-                <a16:creationId xmlns:a16="http://schemas.microsoft.com/office/drawing/2014/main" id="{8506742C-3E43-41D5-84C7-500E9829FA95}"/>
+                <a16:creationId xmlns:a16="http://schemas.microsoft.com/office/drawing/2014/main" id="{0FCF1761-20A9-44B5-8118-A67C738AD7E0}"/>
               </a:ext>
             </a:extLst>
           </p:cNvPr>
@@ -5986,7 +5986,7 @@
           <p:cNvPr id="7" name="item-1">
             <a:extLst xmlns:a="http://schemas.openxmlformats.org/drawingml/2006/main">
               <a:ext uri="{FF2B5EF4-FFF2-40B4-BE49-F238E27FC236}">
-                <a16:creationId xmlns:a16="http://schemas.microsoft.com/office/drawing/2014/main" id="{6231C427-D10E-4F29-AAD0-B1895C2EF939}"/>
+                <a16:creationId xmlns:a16="http://schemas.microsoft.com/office/drawing/2014/main" id="{868E7FA0-BD27-4CF4-BBFA-07F7FD04BDEB}"/>
               </a:ext>
             </a:extLst>
           </p:cNvPr>
@@ -6043,7 +6043,7 @@
           <p:cNvPr id="8" name="number-2">
             <a:extLst xmlns:a="http://schemas.openxmlformats.org/drawingml/2006/main">
               <a:ext uri="{FF2B5EF4-FFF2-40B4-BE49-F238E27FC236}">
-                <a16:creationId xmlns:a16="http://schemas.microsoft.com/office/drawing/2014/main" id="{A617C189-C4F1-4984-9A82-C7398C6F8114}"/>
+                <a16:creationId xmlns:a16="http://schemas.microsoft.com/office/drawing/2014/main" id="{B2D5899A-97A8-460E-81C8-948957F92460}"/>
               </a:ext>
             </a:extLst>
           </p:cNvPr>
@@ -6100,7 +6100,7 @@
           <p:cNvPr id="9" name="item-2">
             <a:extLst xmlns:a="http://schemas.openxmlformats.org/drawingml/2006/main">
               <a:ext uri="{FF2B5EF4-FFF2-40B4-BE49-F238E27FC236}">
-                <a16:creationId xmlns:a16="http://schemas.microsoft.com/office/drawing/2014/main" id="{8EBFE18E-E7A0-4535-BF4B-5990AD400E8E}"/>
+                <a16:creationId xmlns:a16="http://schemas.microsoft.com/office/drawing/2014/main" id="{00614A7F-D45E-4FEB-8958-B47AA0F5FCE2}"/>
               </a:ext>
             </a:extLst>
           </p:cNvPr>
@@ -6157,7 +6157,7 @@
           <p:cNvPr id="10" name="number-3">
             <a:extLst xmlns:a="http://schemas.openxmlformats.org/drawingml/2006/main">
               <a:ext uri="{FF2B5EF4-FFF2-40B4-BE49-F238E27FC236}">
-                <a16:creationId xmlns:a16="http://schemas.microsoft.com/office/drawing/2014/main" id="{31B397B6-AF86-46A3-BA38-24789A85D1DA}"/>
+                <a16:creationId xmlns:a16="http://schemas.microsoft.com/office/drawing/2014/main" id="{72875AB4-2203-4A3B-8131-2F8CC32A6B52}"/>
               </a:ext>
             </a:extLst>
           </p:cNvPr>
@@ -6214,7 +6214,7 @@
           <p:cNvPr id="11" name="item-3">
             <a:extLst xmlns:a="http://schemas.openxmlformats.org/drawingml/2006/main">
               <a:ext uri="{FF2B5EF4-FFF2-40B4-BE49-F238E27FC236}">
-                <a16:creationId xmlns:a16="http://schemas.microsoft.com/office/drawing/2014/main" id="{D44F8D59-1FD5-4712-81B3-081845C337FB}"/>
+                <a16:creationId xmlns:a16="http://schemas.microsoft.com/office/drawing/2014/main" id="{B57D72B5-7217-4110-8FBF-1F41C19CE785}"/>
               </a:ext>
             </a:extLst>
           </p:cNvPr>
@@ -6271,7 +6271,7 @@
           <p:cNvPr id="12" name="number-4">
             <a:extLst xmlns:a="http://schemas.openxmlformats.org/drawingml/2006/main">
               <a:ext uri="{FF2B5EF4-FFF2-40B4-BE49-F238E27FC236}">
-                <a16:creationId xmlns:a16="http://schemas.microsoft.com/office/drawing/2014/main" id="{153D1831-C798-43EC-A92D-16ABDF25398A}"/>
+                <a16:creationId xmlns:a16="http://schemas.microsoft.com/office/drawing/2014/main" id="{84358C07-435C-4ED3-87FD-81FC8D9F4C9E}"/>
               </a:ext>
             </a:extLst>
           </p:cNvPr>
@@ -6328,7 +6328,7 @@
           <p:cNvPr id="13" name="item-4">
             <a:extLst xmlns:a="http://schemas.openxmlformats.org/drawingml/2006/main">
               <a:ext uri="{FF2B5EF4-FFF2-40B4-BE49-F238E27FC236}">
-                <a16:creationId xmlns:a16="http://schemas.microsoft.com/office/drawing/2014/main" id="{D081A94F-08DD-499E-A49C-B3F2000C4B85}"/>
+                <a16:creationId xmlns:a16="http://schemas.microsoft.com/office/drawing/2014/main" id="{A83E1B1F-7AA0-4197-92E3-D6818C1DED60}"/>
               </a:ext>
             </a:extLst>
           </p:cNvPr>
@@ -6385,7 +6385,7 @@
           <p:cNvPr id="14" name="number-5">
             <a:extLst xmlns:a="http://schemas.openxmlformats.org/drawingml/2006/main">
               <a:ext uri="{FF2B5EF4-FFF2-40B4-BE49-F238E27FC236}">
-                <a16:creationId xmlns:a16="http://schemas.microsoft.com/office/drawing/2014/main" id="{7F65422D-C943-441D-90D7-D2FE2D5D6A2C}"/>
+                <a16:creationId xmlns:a16="http://schemas.microsoft.com/office/drawing/2014/main" id="{AF11340A-E9B2-4DB8-AD8C-FB04FF10E066}"/>
               </a:ext>
             </a:extLst>
           </p:cNvPr>
@@ -6442,7 +6442,7 @@
           <p:cNvPr id="15" name="item-5">
             <a:extLst xmlns:a="http://schemas.openxmlformats.org/drawingml/2006/main">
               <a:ext uri="{FF2B5EF4-FFF2-40B4-BE49-F238E27FC236}">
-                <a16:creationId xmlns:a16="http://schemas.microsoft.com/office/drawing/2014/main" id="{A18EEEBB-7F68-43A6-9DCE-79F4B746BB24}"/>
+                <a16:creationId xmlns:a16="http://schemas.microsoft.com/office/drawing/2014/main" id="{4CB339B1-D9C9-4DF7-BA3F-0C464620E690}"/>
               </a:ext>
             </a:extLst>
           </p:cNvPr>
@@ -6499,7 +6499,7 @@
           <p:cNvPr id="16" name="number-6">
             <a:extLst xmlns:a="http://schemas.openxmlformats.org/drawingml/2006/main">
               <a:ext uri="{FF2B5EF4-FFF2-40B4-BE49-F238E27FC236}">
-                <a16:creationId xmlns:a16="http://schemas.microsoft.com/office/drawing/2014/main" id="{C4B8255F-2669-41EB-A497-1854F6C84487}"/>
+                <a16:creationId xmlns:a16="http://schemas.microsoft.com/office/drawing/2014/main" id="{97C97064-C5C6-4111-8021-ADBD13358B53}"/>
               </a:ext>
             </a:extLst>
           </p:cNvPr>
@@ -6556,7 +6556,7 @@
           <p:cNvPr id="17" name="item-6">
             <a:extLst xmlns:a="http://schemas.openxmlformats.org/drawingml/2006/main">
               <a:ext uri="{FF2B5EF4-FFF2-40B4-BE49-F238E27FC236}">
-                <a16:creationId xmlns:a16="http://schemas.microsoft.com/office/drawing/2014/main" id="{77520EE0-0920-4BCC-AF1F-88F27DC822DC}"/>
+                <a16:creationId xmlns:a16="http://schemas.microsoft.com/office/drawing/2014/main" id="{6AD8F504-DBB9-41BC-B6AE-E1770AFD9AF7}"/>
               </a:ext>
             </a:extLst>
           </p:cNvPr>
@@ -6611,7 +6611,7 @@
     </p:spTree>
     <p:extLst>
       <p:ext uri="{BB962C8B-B14F-4D97-AF65-F5344CB8AC3E}">
-        <p14:creationId xmlns:p14="http://schemas.microsoft.com/office/powerpoint/2010/main" val="60384452"/>
+        <p14:creationId xmlns:p14="http://schemas.microsoft.com/office/powerpoint/2010/main" val="198216374"/>
       </p:ext>
     </p:extLst>
   </p:cSld>
@@ -6642,7 +6642,7 @@
           <p:cNvPr id="10" name="topic">
             <a:extLst xmlns:a="http://schemas.openxmlformats.org/drawingml/2006/main">
               <a:ext uri="{FF2B5EF4-FFF2-40B4-BE49-F238E27FC236}">
-                <a16:creationId xmlns:a16="http://schemas.microsoft.com/office/drawing/2014/main" id="{B8B3DF22-1EA1-4C2E-A60D-91376C0E4135}"/>
+                <a16:creationId xmlns:a16="http://schemas.microsoft.com/office/drawing/2014/main" id="{E1887C0F-F4B7-491F-B6F2-D4DFF39ADB9B}"/>
               </a:ext>
             </a:extLst>
           </p:cNvPr>
@@ -6654,7 +6654,7 @@
         <p:spPr>
           <a:xfrm xmlns:a="http://schemas.openxmlformats.org/drawingml/2006/main">
             <a:off x="666750" y="323850"/>
-            <a:ext cx="6667500" cy="276225"/>
+            <a:ext cx="9810750" cy="276225"/>
           </a:xfrm>
           <a:prstGeom xmlns:a="http://schemas.openxmlformats.org/drawingml/2006/main" prst="rect">
             <a:avLst/>
@@ -6689,7 +6689,7 @@
                 <a:ea typeface="DejaVu Sans"/>
                 <a:cs typeface="DejaVu Sans"/>
               </a:rPr>
-              <a:t>TOPIC 1.1   LESSON 01</a:t>
+              <a:t>TOPIC 1.1   /   LESSON 01   /   PLENARY</a:t>
             </a:r>
           </a:p>
         </p:txBody>
@@ -6699,7 +6699,7 @@
           <p:cNvPr id="2" name="heading">
             <a:extLst xmlns:a="http://schemas.openxmlformats.org/drawingml/2006/main">
               <a:ext uri="{FF2B5EF4-FFF2-40B4-BE49-F238E27FC236}">
-                <a16:creationId xmlns:a16="http://schemas.microsoft.com/office/drawing/2014/main" id="{81F8284B-8457-4D91-8E1B-F08BCEF8E902}"/>
+                <a16:creationId xmlns:a16="http://schemas.microsoft.com/office/drawing/2014/main" id="{A5CDAE17-29B5-47BC-9293-99C75ECC0ED5}"/>
               </a:ext>
             </a:extLst>
           </p:cNvPr>
@@ -6746,7 +6746,7 @@
                 <a:ea typeface="DejaVu Sans"/>
                 <a:cs typeface="DejaVu Sans"/>
               </a:rPr>
-              <a:t>Exam practice: questions (a–b)</a:t>
+              <a:t>Plenary: questions (a–b)</a:t>
             </a:r>
           </a:p>
         </p:txBody>
@@ -6756,7 +6756,7 @@
           <p:cNvPr id="3" name="footer">
             <a:extLst xmlns:a="http://schemas.openxmlformats.org/drawingml/2006/main">
               <a:ext uri="{FF2B5EF4-FFF2-40B4-BE49-F238E27FC236}">
-                <a16:creationId xmlns:a16="http://schemas.microsoft.com/office/drawing/2014/main" id="{5F5AC366-8BA0-4931-B1FB-E3C20E02E904}"/>
+                <a16:creationId xmlns:a16="http://schemas.microsoft.com/office/drawing/2014/main" id="{9CE6C814-0FF3-4382-BD32-3F4713424F5F}"/>
               </a:ext>
             </a:extLst>
           </p:cNvPr>
@@ -6803,7 +6803,7 @@
                 <a:ea typeface="DejaVu Sans"/>
                 <a:cs typeface="DejaVu Sans"/>
               </a:rPr>
-              <a:t>Revise 360    OCR J277 1.1 Systems architecture    Plenary</a:t>
+              <a:t>Revise 360    OCR J277 1.1 Systems architecture</a:t>
             </a:r>
           </a:p>
         </p:txBody>
@@ -6813,7 +6813,7 @@
           <p:cNvPr id="4" name="page">
             <a:extLst xmlns:a="http://schemas.openxmlformats.org/drawingml/2006/main">
               <a:ext uri="{FF2B5EF4-FFF2-40B4-BE49-F238E27FC236}">
-                <a16:creationId xmlns:a16="http://schemas.microsoft.com/office/drawing/2014/main" id="{F7976C49-85E3-4DA3-A8F4-44517D0195C9}"/>
+                <a16:creationId xmlns:a16="http://schemas.microsoft.com/office/drawing/2014/main" id="{503002A4-D1DC-466C-8E38-D6DE2243CC83}"/>
               </a:ext>
             </a:extLst>
           </p:cNvPr>
@@ -6870,7 +6870,7 @@
           <p:cNvPr id="5" name="plenary-instruction">
             <a:extLst xmlns:a="http://schemas.openxmlformats.org/drawingml/2006/main">
               <a:ext uri="{FF2B5EF4-FFF2-40B4-BE49-F238E27FC236}">
-                <a16:creationId xmlns:a16="http://schemas.microsoft.com/office/drawing/2014/main" id="{02769B58-9318-49CA-BB7C-59A02AF4B052}"/>
+                <a16:creationId xmlns:a16="http://schemas.microsoft.com/office/drawing/2014/main" id="{5FA5A000-F8CE-451B-8468-6449EECF348A}"/>
               </a:ext>
             </a:extLst>
           </p:cNvPr>
@@ -6927,7 +6927,7 @@
           <p:cNvPr id="6" name="a">
             <a:extLst xmlns:a="http://schemas.openxmlformats.org/drawingml/2006/main">
               <a:ext uri="{FF2B5EF4-FFF2-40B4-BE49-F238E27FC236}">
-                <a16:creationId xmlns:a16="http://schemas.microsoft.com/office/drawing/2014/main" id="{C15FF877-2C4B-42B3-9AC3-26DDB97114D3}"/>
+                <a16:creationId xmlns:a16="http://schemas.microsoft.com/office/drawing/2014/main" id="{81316D5C-0B96-42A5-8431-E6F006A2DA15}"/>
               </a:ext>
             </a:extLst>
           </p:cNvPr>
@@ -6984,7 +6984,7 @@
           <p:cNvPr id="7" name="question-a">
             <a:extLst xmlns:a="http://schemas.openxmlformats.org/drawingml/2006/main">
               <a:ext uri="{FF2B5EF4-FFF2-40B4-BE49-F238E27FC236}">
-                <a16:creationId xmlns:a16="http://schemas.microsoft.com/office/drawing/2014/main" id="{8EC9B3B4-D785-412B-B8BA-27EB1F3AD28F}"/>
+                <a16:creationId xmlns:a16="http://schemas.microsoft.com/office/drawing/2014/main" id="{C52C640B-2017-42DC-8214-7309257EB03E}"/>
               </a:ext>
             </a:extLst>
           </p:cNvPr>
@@ -7041,7 +7041,7 @@
           <p:cNvPr id="8" name="b">
             <a:extLst xmlns:a="http://schemas.openxmlformats.org/drawingml/2006/main">
               <a:ext uri="{FF2B5EF4-FFF2-40B4-BE49-F238E27FC236}">
-                <a16:creationId xmlns:a16="http://schemas.microsoft.com/office/drawing/2014/main" id="{81E844D6-2D8F-400E-971D-86A6D5548761}"/>
+                <a16:creationId xmlns:a16="http://schemas.microsoft.com/office/drawing/2014/main" id="{BBC55308-4B73-4C93-BF1C-19373371CDD1}"/>
               </a:ext>
             </a:extLst>
           </p:cNvPr>
@@ -7098,7 +7098,7 @@
           <p:cNvPr id="9" name="question-b">
             <a:extLst xmlns:a="http://schemas.openxmlformats.org/drawingml/2006/main">
               <a:ext uri="{FF2B5EF4-FFF2-40B4-BE49-F238E27FC236}">
-                <a16:creationId xmlns:a16="http://schemas.microsoft.com/office/drawing/2014/main" id="{5E395904-4200-4903-BEBD-7435EC25E0C8}"/>
+                <a16:creationId xmlns:a16="http://schemas.microsoft.com/office/drawing/2014/main" id="{F94AE728-C734-4860-A77A-89FF551C15E3}"/>
               </a:ext>
             </a:extLst>
           </p:cNvPr>
@@ -7153,7 +7153,7 @@
     </p:spTree>
     <p:extLst>
       <p:ext uri="{BB962C8B-B14F-4D97-AF65-F5344CB8AC3E}">
-        <p14:creationId xmlns:p14="http://schemas.microsoft.com/office/powerpoint/2010/main" val="145754037"/>
+        <p14:creationId xmlns:p14="http://schemas.microsoft.com/office/powerpoint/2010/main" val="1015559461"/>
       </p:ext>
     </p:extLst>
   </p:cSld>
@@ -7184,7 +7184,7 @@
           <p:cNvPr id="9" name="topic">
             <a:extLst xmlns:a="http://schemas.openxmlformats.org/drawingml/2006/main">
               <a:ext uri="{FF2B5EF4-FFF2-40B4-BE49-F238E27FC236}">
-                <a16:creationId xmlns:a16="http://schemas.microsoft.com/office/drawing/2014/main" id="{5827EA16-CA96-44E6-8D9D-6385E21F5BAB}"/>
+                <a16:creationId xmlns:a16="http://schemas.microsoft.com/office/drawing/2014/main" id="{35A91DAF-5A81-4AD2-B384-A05D00F9A0E1}"/>
               </a:ext>
             </a:extLst>
           </p:cNvPr>
@@ -7196,7 +7196,7 @@
         <p:spPr>
           <a:xfrm xmlns:a="http://schemas.openxmlformats.org/drawingml/2006/main">
             <a:off x="666750" y="323850"/>
-            <a:ext cx="6667500" cy="276225"/>
+            <a:ext cx="9810750" cy="276225"/>
           </a:xfrm>
           <a:prstGeom xmlns:a="http://schemas.openxmlformats.org/drawingml/2006/main" prst="rect">
             <a:avLst/>
@@ -7231,7 +7231,7 @@
                 <a:ea typeface="DejaVu Sans"/>
                 <a:cs typeface="DejaVu Sans"/>
               </a:rPr>
-              <a:t>TOPIC 1.1   LESSON 01</a:t>
+              <a:t>TOPIC 1.1   /   LESSON 01   /   PLENARY</a:t>
             </a:r>
           </a:p>
         </p:txBody>
@@ -7241,7 +7241,7 @@
           <p:cNvPr id="2" name="heading">
             <a:extLst xmlns:a="http://schemas.openxmlformats.org/drawingml/2006/main">
               <a:ext uri="{FF2B5EF4-FFF2-40B4-BE49-F238E27FC236}">
-                <a16:creationId xmlns:a16="http://schemas.microsoft.com/office/drawing/2014/main" id="{AAAD20DD-CF1B-4266-A1DF-6849472F5DB2}"/>
+                <a16:creationId xmlns:a16="http://schemas.microsoft.com/office/drawing/2014/main" id="{EDFB7C4C-4D6A-4092-B098-EF8547162353}"/>
               </a:ext>
             </a:extLst>
           </p:cNvPr>
@@ -7288,7 +7288,7 @@
                 <a:ea typeface="DejaVu Sans"/>
                 <a:cs typeface="DejaVu Sans"/>
               </a:rPr>
-              <a:t>Exam practice: question (c)</a:t>
+              <a:t>Plenary: question (c)</a:t>
             </a:r>
           </a:p>
         </p:txBody>
@@ -7298,7 +7298,7 @@
           <p:cNvPr id="3" name="footer">
             <a:extLst xmlns:a="http://schemas.openxmlformats.org/drawingml/2006/main">
               <a:ext uri="{FF2B5EF4-FFF2-40B4-BE49-F238E27FC236}">
-                <a16:creationId xmlns:a16="http://schemas.microsoft.com/office/drawing/2014/main" id="{31E24B91-D585-4DC5-83A1-8FEEAB2D1840}"/>
+                <a16:creationId xmlns:a16="http://schemas.microsoft.com/office/drawing/2014/main" id="{13E0A777-0FA5-4021-A187-3FC34AC795CF}"/>
               </a:ext>
             </a:extLst>
           </p:cNvPr>
@@ -7345,7 +7345,7 @@
                 <a:ea typeface="DejaVu Sans"/>
                 <a:cs typeface="DejaVu Sans"/>
               </a:rPr>
-              <a:t>Revise 360    OCR J277 1.1 Systems architecture    Plenary</a:t>
+              <a:t>Revise 360    OCR J277 1.1 Systems architecture</a:t>
             </a:r>
           </a:p>
         </p:txBody>
@@ -7355,7 +7355,7 @@
           <p:cNvPr id="4" name="page">
             <a:extLst xmlns:a="http://schemas.openxmlformats.org/drawingml/2006/main">
               <a:ext uri="{FF2B5EF4-FFF2-40B4-BE49-F238E27FC236}">
-                <a16:creationId xmlns:a16="http://schemas.microsoft.com/office/drawing/2014/main" id="{9845DBB7-EFF1-4FE4-B4C8-FCF1534663CF}"/>
+                <a16:creationId xmlns:a16="http://schemas.microsoft.com/office/drawing/2014/main" id="{20F514C1-99A9-45E4-A2AB-D8563F67E8F4}"/>
               </a:ext>
             </a:extLst>
           </p:cNvPr>
@@ -7412,7 +7412,7 @@
           <p:cNvPr id="5" name="from-memory">
             <a:extLst xmlns:a="http://schemas.openxmlformats.org/drawingml/2006/main">
               <a:ext uri="{FF2B5EF4-FFF2-40B4-BE49-F238E27FC236}">
-                <a16:creationId xmlns:a16="http://schemas.microsoft.com/office/drawing/2014/main" id="{7167CDD5-ED48-4F0A-8511-CE683F6C1820}"/>
+                <a16:creationId xmlns:a16="http://schemas.microsoft.com/office/drawing/2014/main" id="{B07213AF-0168-41A4-A36A-75A022BA99DE}"/>
               </a:ext>
             </a:extLst>
           </p:cNvPr>
@@ -7469,7 +7469,7 @@
           <p:cNvPr id="6" name="c">
             <a:extLst xmlns:a="http://schemas.openxmlformats.org/drawingml/2006/main">
               <a:ext uri="{FF2B5EF4-FFF2-40B4-BE49-F238E27FC236}">
-                <a16:creationId xmlns:a16="http://schemas.microsoft.com/office/drawing/2014/main" id="{AF06B994-4447-49B5-88E3-0CFA0AA2F326}"/>
+                <a16:creationId xmlns:a16="http://schemas.microsoft.com/office/drawing/2014/main" id="{BE8AF9A4-CAF6-412D-81A2-F6D4AE319B6F}"/>
               </a:ext>
             </a:extLst>
           </p:cNvPr>
@@ -7526,7 +7526,7 @@
           <p:cNvPr id="7" name="question-c">
             <a:extLst xmlns:a="http://schemas.openxmlformats.org/drawingml/2006/main">
               <a:ext uri="{FF2B5EF4-FFF2-40B4-BE49-F238E27FC236}">
-                <a16:creationId xmlns:a16="http://schemas.microsoft.com/office/drawing/2014/main" id="{2CF73BFB-CF3B-4DA6-A5F5-C765C91CE2BC}"/>
+                <a16:creationId xmlns:a16="http://schemas.microsoft.com/office/drawing/2014/main" id="{558FA964-C4C6-4240-B59B-5F4F8682E81D}"/>
               </a:ext>
             </a:extLst>
           </p:cNvPr>
@@ -7583,7 +7583,7 @@
           <p:cNvPr id="8" name="marks">
             <a:extLst xmlns:a="http://schemas.openxmlformats.org/drawingml/2006/main">
               <a:ext uri="{FF2B5EF4-FFF2-40B4-BE49-F238E27FC236}">
-                <a16:creationId xmlns:a16="http://schemas.microsoft.com/office/drawing/2014/main" id="{20B3C75F-37DD-44C1-AEDF-D712130CA99D}"/>
+                <a16:creationId xmlns:a16="http://schemas.microsoft.com/office/drawing/2014/main" id="{8FD60CB9-C706-4F0C-8D8A-DCA8E75C8008}"/>
               </a:ext>
             </a:extLst>
           </p:cNvPr>
@@ -7638,7 +7638,7 @@
     </p:spTree>
     <p:extLst>
       <p:ext uri="{BB962C8B-B14F-4D97-AF65-F5344CB8AC3E}">
-        <p14:creationId xmlns:p14="http://schemas.microsoft.com/office/powerpoint/2010/main" val="375416291"/>
+        <p14:creationId xmlns:p14="http://schemas.microsoft.com/office/powerpoint/2010/main" val="1778029823"/>
       </p:ext>
     </p:extLst>
   </p:cSld>
@@ -7651,7 +7651,7 @@
     <p:bg>
       <p:bgPr>
         <a:solidFill xmlns:a="http://schemas.openxmlformats.org/drawingml/2006/main">
-          <a:srgbClr val="FFFFFF"/>
+          <a:srgbClr val="EAF3FF"/>
         </a:solidFill>
       </p:bgPr>
     </p:bg>
@@ -7669,7 +7669,7 @@
           <p:cNvPr id="8" name="topic">
             <a:extLst xmlns:a="http://schemas.openxmlformats.org/drawingml/2006/main">
               <a:ext uri="{FF2B5EF4-FFF2-40B4-BE49-F238E27FC236}">
-                <a16:creationId xmlns:a16="http://schemas.microsoft.com/office/drawing/2014/main" id="{481609B3-B0B1-4A35-8702-C5815F8D7991}"/>
+                <a16:creationId xmlns:a16="http://schemas.microsoft.com/office/drawing/2014/main" id="{6B86C21F-3F70-47DE-BC64-BF9AC270C8EA}"/>
               </a:ext>
             </a:extLst>
           </p:cNvPr>
@@ -7681,7 +7681,7 @@
         <p:spPr>
           <a:xfrm xmlns:a="http://schemas.openxmlformats.org/drawingml/2006/main">
             <a:off x="666750" y="323850"/>
-            <a:ext cx="6667500" cy="276225"/>
+            <a:ext cx="9810750" cy="276225"/>
           </a:xfrm>
           <a:prstGeom xmlns:a="http://schemas.openxmlformats.org/drawingml/2006/main" prst="rect">
             <a:avLst/>
@@ -7716,7 +7716,7 @@
                 <a:ea typeface="DejaVu Sans"/>
                 <a:cs typeface="DejaVu Sans"/>
               </a:rPr>
-              <a:t>TOPIC 1.1   LESSON 01</a:t>
+              <a:t>TOPIC 1.1   /   LESSON 01   /   CHECK</a:t>
             </a:r>
           </a:p>
         </p:txBody>
@@ -7726,7 +7726,7 @@
           <p:cNvPr id="2" name="heading">
             <a:extLst xmlns:a="http://schemas.openxmlformats.org/drawingml/2006/main">
               <a:ext uri="{FF2B5EF4-FFF2-40B4-BE49-F238E27FC236}">
-                <a16:creationId xmlns:a16="http://schemas.microsoft.com/office/drawing/2014/main" id="{89BCAB30-FCB3-42AC-85AA-9EB56067AE2B}"/>
+                <a16:creationId xmlns:a16="http://schemas.microsoft.com/office/drawing/2014/main" id="{A05F9260-3C89-447E-88B1-29D5BF254C5A}"/>
               </a:ext>
             </a:extLst>
           </p:cNvPr>
@@ -7773,7 +7773,7 @@
                 <a:ea typeface="DejaVu Sans"/>
                 <a:cs typeface="DejaVu Sans"/>
               </a:rPr>
-              <a:t>Exam practice: answers (a–b)</a:t>
+              <a:t>Plenary: answers (a–b)</a:t>
             </a:r>
           </a:p>
         </p:txBody>
@@ -7783,7 +7783,7 @@
           <p:cNvPr id="3" name="footer">
             <a:extLst xmlns:a="http://schemas.openxmlformats.org/drawingml/2006/main">
               <a:ext uri="{FF2B5EF4-FFF2-40B4-BE49-F238E27FC236}">
-                <a16:creationId xmlns:a16="http://schemas.microsoft.com/office/drawing/2014/main" id="{04358A0F-28B8-47A3-BD60-30A96C6B5901}"/>
+                <a16:creationId xmlns:a16="http://schemas.microsoft.com/office/drawing/2014/main" id="{7D04AF32-9ABA-489E-9462-8E7313099D7F}"/>
               </a:ext>
             </a:extLst>
           </p:cNvPr>
@@ -7830,7 +7830,7 @@
                 <a:ea typeface="DejaVu Sans"/>
                 <a:cs typeface="DejaVu Sans"/>
               </a:rPr>
-              <a:t>Revise 360    OCR J277 1.1 Systems architecture    Check</a:t>
+              <a:t>Revise 360    OCR J277 1.1 Systems architecture</a:t>
             </a:r>
           </a:p>
         </p:txBody>
@@ -7840,7 +7840,7 @@
           <p:cNvPr id="4" name="page">
             <a:extLst xmlns:a="http://schemas.openxmlformats.org/drawingml/2006/main">
               <a:ext uri="{FF2B5EF4-FFF2-40B4-BE49-F238E27FC236}">
-                <a16:creationId xmlns:a16="http://schemas.microsoft.com/office/drawing/2014/main" id="{9907109E-0635-4B20-B5BD-355FCC95A37D}"/>
+                <a16:creationId xmlns:a16="http://schemas.microsoft.com/office/drawing/2014/main" id="{735DEF94-96B1-40F3-86C7-A44EFC95DDF4}"/>
               </a:ext>
             </a:extLst>
           </p:cNvPr>
@@ -7897,7 +7897,7 @@
           <p:cNvPr id="5" name="scheme-intro">
             <a:extLst xmlns:a="http://schemas.openxmlformats.org/drawingml/2006/main">
               <a:ext uri="{FF2B5EF4-FFF2-40B4-BE49-F238E27FC236}">
-                <a16:creationId xmlns:a16="http://schemas.microsoft.com/office/drawing/2014/main" id="{7A56D11A-EE76-48BA-84FE-B62387C8274D}"/>
+                <a16:creationId xmlns:a16="http://schemas.microsoft.com/office/drawing/2014/main" id="{351CDE96-8EC7-4F84-8C23-F81A41DFB63E}"/>
               </a:ext>
             </a:extLst>
           </p:cNvPr>
@@ -7954,7 +7954,7 @@
           <p:cNvPr id="6" name="scheme-a">
             <a:extLst xmlns:a="http://schemas.openxmlformats.org/drawingml/2006/main">
               <a:ext uri="{FF2B5EF4-FFF2-40B4-BE49-F238E27FC236}">
-                <a16:creationId xmlns:a16="http://schemas.microsoft.com/office/drawing/2014/main" id="{DF1529FF-4A1A-4C91-B690-599D0B221622}"/>
+                <a16:creationId xmlns:a16="http://schemas.microsoft.com/office/drawing/2014/main" id="{A8D8E55E-D906-4CA8-B00A-29352E27C8E7}"/>
               </a:ext>
             </a:extLst>
           </p:cNvPr>
@@ -8011,7 +8011,7 @@
           <p:cNvPr id="7" name="scheme-b">
             <a:extLst xmlns:a="http://schemas.openxmlformats.org/drawingml/2006/main">
               <a:ext uri="{FF2B5EF4-FFF2-40B4-BE49-F238E27FC236}">
-                <a16:creationId xmlns:a16="http://schemas.microsoft.com/office/drawing/2014/main" id="{894480F0-E611-4847-8BB4-C8340045CE70}"/>
+                <a16:creationId xmlns:a16="http://schemas.microsoft.com/office/drawing/2014/main" id="{54CB57EC-4385-48CE-AEC3-796C9751C53E}"/>
               </a:ext>
             </a:extLst>
           </p:cNvPr>
@@ -8066,7 +8066,7 @@
     </p:spTree>
     <p:extLst>
       <p:ext uri="{BB962C8B-B14F-4D97-AF65-F5344CB8AC3E}">
-        <p14:creationId xmlns:p14="http://schemas.microsoft.com/office/powerpoint/2010/main" val="1608034177"/>
+        <p14:creationId xmlns:p14="http://schemas.microsoft.com/office/powerpoint/2010/main" val="989800926"/>
       </p:ext>
     </p:extLst>
   </p:cSld>
@@ -8079,7 +8079,7 @@
     <p:bg>
       <p:bgPr>
         <a:solidFill xmlns:a="http://schemas.openxmlformats.org/drawingml/2006/main">
-          <a:srgbClr val="FFFFFF"/>
+          <a:srgbClr val="EAF3FF"/>
         </a:solidFill>
       </p:bgPr>
     </p:bg>
@@ -8097,7 +8097,7 @@
           <p:cNvPr id="12" name="topic">
             <a:extLst xmlns:a="http://schemas.openxmlformats.org/drawingml/2006/main">
               <a:ext uri="{FF2B5EF4-FFF2-40B4-BE49-F238E27FC236}">
-                <a16:creationId xmlns:a16="http://schemas.microsoft.com/office/drawing/2014/main" id="{C558CE7A-16C9-486C-AA2D-3EF144FE19A7}"/>
+                <a16:creationId xmlns:a16="http://schemas.microsoft.com/office/drawing/2014/main" id="{27890873-6634-485A-AC32-23284520B5FB}"/>
               </a:ext>
             </a:extLst>
           </p:cNvPr>
@@ -8109,7 +8109,7 @@
         <p:spPr>
           <a:xfrm xmlns:a="http://schemas.openxmlformats.org/drawingml/2006/main">
             <a:off x="666750" y="323850"/>
-            <a:ext cx="6667500" cy="276225"/>
+            <a:ext cx="9810750" cy="276225"/>
           </a:xfrm>
           <a:prstGeom xmlns:a="http://schemas.openxmlformats.org/drawingml/2006/main" prst="rect">
             <a:avLst/>
@@ -8144,7 +8144,7 @@
                 <a:ea typeface="DejaVu Sans"/>
                 <a:cs typeface="DejaVu Sans"/>
               </a:rPr>
-              <a:t>TOPIC 1.1   LESSON 01</a:t>
+              <a:t>TOPIC 1.1   /   LESSON 01   /   CHECK</a:t>
             </a:r>
           </a:p>
         </p:txBody>
@@ -8154,7 +8154,7 @@
           <p:cNvPr id="2" name="heading">
             <a:extLst xmlns:a="http://schemas.openxmlformats.org/drawingml/2006/main">
               <a:ext uri="{FF2B5EF4-FFF2-40B4-BE49-F238E27FC236}">
-                <a16:creationId xmlns:a16="http://schemas.microsoft.com/office/drawing/2014/main" id="{F6A4F5B3-E14C-4A5A-92D7-4DC9129BF0B3}"/>
+                <a16:creationId xmlns:a16="http://schemas.microsoft.com/office/drawing/2014/main" id="{6253C0DC-2DDB-4311-8F19-2E9DFF0FFA83}"/>
               </a:ext>
             </a:extLst>
           </p:cNvPr>
@@ -8201,7 +8201,7 @@
                 <a:ea typeface="DejaVu Sans"/>
                 <a:cs typeface="DejaVu Sans"/>
               </a:rPr>
-              <a:t>Exam practice: answer (c)</a:t>
+              <a:t>Plenary: answer (c)</a:t>
             </a:r>
           </a:p>
         </p:txBody>
@@ -8211,7 +8211,7 @@
           <p:cNvPr id="3" name="footer">
             <a:extLst xmlns:a="http://schemas.openxmlformats.org/drawingml/2006/main">
               <a:ext uri="{FF2B5EF4-FFF2-40B4-BE49-F238E27FC236}">
-                <a16:creationId xmlns:a16="http://schemas.microsoft.com/office/drawing/2014/main" id="{D06E32AA-3B29-4913-BF37-2DD3FB73C3E1}"/>
+                <a16:creationId xmlns:a16="http://schemas.microsoft.com/office/drawing/2014/main" id="{FD7D3DA4-B3C8-48A5-AFC6-F7A053D02B90}"/>
               </a:ext>
             </a:extLst>
           </p:cNvPr>
@@ -8258,7 +8258,7 @@
                 <a:ea typeface="DejaVu Sans"/>
                 <a:cs typeface="DejaVu Sans"/>
               </a:rPr>
-              <a:t>Revise 360    OCR J277 1.1 Systems architecture    Check</a:t>
+              <a:t>Revise 360    OCR J277 1.1 Systems architecture</a:t>
             </a:r>
           </a:p>
         </p:txBody>
@@ -8268,7 +8268,7 @@
           <p:cNvPr id="4" name="page">
             <a:extLst xmlns:a="http://schemas.openxmlformats.org/drawingml/2006/main">
               <a:ext uri="{FF2B5EF4-FFF2-40B4-BE49-F238E27FC236}">
-                <a16:creationId xmlns:a16="http://schemas.microsoft.com/office/drawing/2014/main" id="{36F0F33C-5606-49F9-94B9-0E9A627D8BF4}"/>
+                <a16:creationId xmlns:a16="http://schemas.microsoft.com/office/drawing/2014/main" id="{3F1D1119-23CE-411E-A1EE-85F294B53D8D}"/>
               </a:ext>
             </a:extLst>
           </p:cNvPr>
@@ -8325,7 +8325,7 @@
           <p:cNvPr id="5" name="scheme-intro">
             <a:extLst xmlns:a="http://schemas.openxmlformats.org/drawingml/2006/main">
               <a:ext uri="{FF2B5EF4-FFF2-40B4-BE49-F238E27FC236}">
-                <a16:creationId xmlns:a16="http://schemas.microsoft.com/office/drawing/2014/main" id="{18943619-3D89-4BFC-9733-44398AD1A229}"/>
+                <a16:creationId xmlns:a16="http://schemas.microsoft.com/office/drawing/2014/main" id="{6914F2E0-20CE-4B43-832A-FB55F05EB82A}"/>
               </a:ext>
             </a:extLst>
           </p:cNvPr>
@@ -8382,7 +8382,7 @@
           <p:cNvPr id="6" name="number-1">
             <a:extLst xmlns:a="http://schemas.openxmlformats.org/drawingml/2006/main">
               <a:ext uri="{FF2B5EF4-FFF2-40B4-BE49-F238E27FC236}">
-                <a16:creationId xmlns:a16="http://schemas.microsoft.com/office/drawing/2014/main" id="{E8181695-9242-413B-B28D-400BDE1B7259}"/>
+                <a16:creationId xmlns:a16="http://schemas.microsoft.com/office/drawing/2014/main" id="{55F206C2-BC8D-4956-A9A3-9243DA7EBC2A}"/>
               </a:ext>
             </a:extLst>
           </p:cNvPr>
@@ -8439,7 +8439,7 @@
           <p:cNvPr id="7" name="item-1">
             <a:extLst xmlns:a="http://schemas.openxmlformats.org/drawingml/2006/main">
               <a:ext uri="{FF2B5EF4-FFF2-40B4-BE49-F238E27FC236}">
-                <a16:creationId xmlns:a16="http://schemas.microsoft.com/office/drawing/2014/main" id="{E29B800F-BA42-4BA8-A2A3-821310E6343C}"/>
+                <a16:creationId xmlns:a16="http://schemas.microsoft.com/office/drawing/2014/main" id="{D64292DB-6E7E-4E39-8053-D12F6DF2F7C2}"/>
               </a:ext>
             </a:extLst>
           </p:cNvPr>
@@ -8496,7 +8496,7 @@
           <p:cNvPr id="8" name="number-2">
             <a:extLst xmlns:a="http://schemas.openxmlformats.org/drawingml/2006/main">
               <a:ext uri="{FF2B5EF4-FFF2-40B4-BE49-F238E27FC236}">
-                <a16:creationId xmlns:a16="http://schemas.microsoft.com/office/drawing/2014/main" id="{FB56A93C-C241-4DA0-8212-6378774F0BA2}"/>
+                <a16:creationId xmlns:a16="http://schemas.microsoft.com/office/drawing/2014/main" id="{F4520436-5692-4A07-A45C-402BAAE82AE1}"/>
               </a:ext>
             </a:extLst>
           </p:cNvPr>
@@ -8553,7 +8553,7 @@
           <p:cNvPr id="9" name="item-2">
             <a:extLst xmlns:a="http://schemas.openxmlformats.org/drawingml/2006/main">
               <a:ext uri="{FF2B5EF4-FFF2-40B4-BE49-F238E27FC236}">
-                <a16:creationId xmlns:a16="http://schemas.microsoft.com/office/drawing/2014/main" id="{BD739DBA-C384-4461-86D0-8A8586B9D81C}"/>
+                <a16:creationId xmlns:a16="http://schemas.microsoft.com/office/drawing/2014/main" id="{D1F47AD8-1BC3-4E5C-B303-2D73A6773B08}"/>
               </a:ext>
             </a:extLst>
           </p:cNvPr>
@@ -8610,7 +8610,7 @@
           <p:cNvPr id="10" name="number-3">
             <a:extLst xmlns:a="http://schemas.openxmlformats.org/drawingml/2006/main">
               <a:ext uri="{FF2B5EF4-FFF2-40B4-BE49-F238E27FC236}">
-                <a16:creationId xmlns:a16="http://schemas.microsoft.com/office/drawing/2014/main" id="{2585DA0F-2F73-48E0-9860-4813ECA75BBB}"/>
+                <a16:creationId xmlns:a16="http://schemas.microsoft.com/office/drawing/2014/main" id="{72122F74-882D-4F69-977A-996BDC697C85}"/>
               </a:ext>
             </a:extLst>
           </p:cNvPr>
@@ -8667,7 +8667,7 @@
           <p:cNvPr id="11" name="item-3">
             <a:extLst xmlns:a="http://schemas.openxmlformats.org/drawingml/2006/main">
               <a:ext uri="{FF2B5EF4-FFF2-40B4-BE49-F238E27FC236}">
-                <a16:creationId xmlns:a16="http://schemas.microsoft.com/office/drawing/2014/main" id="{AC923877-33DA-4E1B-804E-1783E90D002B}"/>
+                <a16:creationId xmlns:a16="http://schemas.microsoft.com/office/drawing/2014/main" id="{922803E7-0FEB-4125-952A-6E57C9D4C0E9}"/>
               </a:ext>
             </a:extLst>
           </p:cNvPr>
@@ -8722,7 +8722,7 @@
     </p:spTree>
     <p:extLst>
       <p:ext uri="{BB962C8B-B14F-4D97-AF65-F5344CB8AC3E}">
-        <p14:creationId xmlns:p14="http://schemas.microsoft.com/office/powerpoint/2010/main" val="797145548"/>
+        <p14:creationId xmlns:p14="http://schemas.microsoft.com/office/powerpoint/2010/main" val="1044158425"/>
       </p:ext>
     </p:extLst>
   </p:cSld>
@@ -8753,7 +8753,7 @@
           <p:cNvPr id="15" name="topic">
             <a:extLst xmlns:a="http://schemas.openxmlformats.org/drawingml/2006/main">
               <a:ext uri="{FF2B5EF4-FFF2-40B4-BE49-F238E27FC236}">
-                <a16:creationId xmlns:a16="http://schemas.microsoft.com/office/drawing/2014/main" id="{BC4B5288-B70D-4973-B34A-1EBBEFBCF7B7}"/>
+                <a16:creationId xmlns:a16="http://schemas.microsoft.com/office/drawing/2014/main" id="{BFBBABC0-2E23-43F3-A814-8EAC47F707F0}"/>
               </a:ext>
             </a:extLst>
           </p:cNvPr>
@@ -8765,7 +8765,7 @@
         <p:spPr>
           <a:xfrm xmlns:a="http://schemas.openxmlformats.org/drawingml/2006/main">
             <a:off x="666750" y="323850"/>
-            <a:ext cx="6667500" cy="276225"/>
+            <a:ext cx="9810750" cy="276225"/>
           </a:xfrm>
           <a:prstGeom xmlns:a="http://schemas.openxmlformats.org/drawingml/2006/main" prst="rect">
             <a:avLst/>
@@ -8800,7 +8800,7 @@
                 <a:ea typeface="DejaVu Sans"/>
                 <a:cs typeface="DejaVu Sans"/>
               </a:rPr>
-              <a:t>TOPIC 1.1   LESSON 01</a:t>
+              <a:t>TOPIC 1.1   /   LESSON 01   /   WORKSHEET</a:t>
             </a:r>
           </a:p>
         </p:txBody>
@@ -8810,7 +8810,7 @@
           <p:cNvPr id="2" name="heading">
             <a:extLst xmlns:a="http://schemas.openxmlformats.org/drawingml/2006/main">
               <a:ext uri="{FF2B5EF4-FFF2-40B4-BE49-F238E27FC236}">
-                <a16:creationId xmlns:a16="http://schemas.microsoft.com/office/drawing/2014/main" id="{6FE582F0-C5B9-4F0D-8CD4-34C7526D0C8A}"/>
+                <a16:creationId xmlns:a16="http://schemas.microsoft.com/office/drawing/2014/main" id="{D0309D9C-6031-49ED-B67B-CCAD5949E2D0}"/>
               </a:ext>
             </a:extLst>
           </p:cNvPr>
@@ -8867,7 +8867,7 @@
           <p:cNvPr id="3" name="footer">
             <a:extLst xmlns:a="http://schemas.openxmlformats.org/drawingml/2006/main">
               <a:ext uri="{FF2B5EF4-FFF2-40B4-BE49-F238E27FC236}">
-                <a16:creationId xmlns:a16="http://schemas.microsoft.com/office/drawing/2014/main" id="{817DC1B9-464D-4844-B0BE-F02A4DDD0432}"/>
+                <a16:creationId xmlns:a16="http://schemas.microsoft.com/office/drawing/2014/main" id="{10083105-6AE6-4270-BA7F-020D6B64CBC1}"/>
               </a:ext>
             </a:extLst>
           </p:cNvPr>
@@ -8914,7 +8914,7 @@
                 <a:ea typeface="DejaVu Sans"/>
                 <a:cs typeface="DejaVu Sans"/>
               </a:rPr>
-              <a:t>Revise 360    OCR J277 1.1 Systems architecture    Worksheet</a:t>
+              <a:t>Revise 360    OCR J277 1.1 Systems architecture</a:t>
             </a:r>
           </a:p>
         </p:txBody>
@@ -8924,7 +8924,7 @@
           <p:cNvPr id="4" name="page">
             <a:extLst xmlns:a="http://schemas.openxmlformats.org/drawingml/2006/main">
               <a:ext uri="{FF2B5EF4-FFF2-40B4-BE49-F238E27FC236}">
-                <a16:creationId xmlns:a16="http://schemas.microsoft.com/office/drawing/2014/main" id="{807EDDAB-1126-4376-AA54-4F8DC26CE9D8}"/>
+                <a16:creationId xmlns:a16="http://schemas.microsoft.com/office/drawing/2014/main" id="{A2B9663B-F931-4978-A598-B6A90035D565}"/>
               </a:ext>
             </a:extLst>
           </p:cNvPr>
@@ -8981,7 +8981,7 @@
           <p:cNvPr id="5" name="outcome-intro">
             <a:extLst xmlns:a="http://schemas.openxmlformats.org/drawingml/2006/main">
               <a:ext uri="{FF2B5EF4-FFF2-40B4-BE49-F238E27FC236}">
-                <a16:creationId xmlns:a16="http://schemas.microsoft.com/office/drawing/2014/main" id="{5B4E8F6A-7DF1-4A94-B2A0-62D1D4B4DAA8}"/>
+                <a16:creationId xmlns:a16="http://schemas.microsoft.com/office/drawing/2014/main" id="{B47328FC-ABA1-427C-BCF5-5B5A4C1A749A}"/>
               </a:ext>
             </a:extLst>
           </p:cNvPr>
@@ -9038,7 +9038,7 @@
           <p:cNvPr id="6" name="number-1">
             <a:extLst xmlns:a="http://schemas.openxmlformats.org/drawingml/2006/main">
               <a:ext uri="{FF2B5EF4-FFF2-40B4-BE49-F238E27FC236}">
-                <a16:creationId xmlns:a16="http://schemas.microsoft.com/office/drawing/2014/main" id="{081451FF-F3C2-41E9-BA92-FFD165745B7A}"/>
+                <a16:creationId xmlns:a16="http://schemas.microsoft.com/office/drawing/2014/main" id="{898EB658-CF4D-421F-80E3-55236D83F713}"/>
               </a:ext>
             </a:extLst>
           </p:cNvPr>
@@ -9095,7 +9095,7 @@
           <p:cNvPr id="7" name="item-1">
             <a:extLst xmlns:a="http://schemas.openxmlformats.org/drawingml/2006/main">
               <a:ext uri="{FF2B5EF4-FFF2-40B4-BE49-F238E27FC236}">
-                <a16:creationId xmlns:a16="http://schemas.microsoft.com/office/drawing/2014/main" id="{CD416FFE-4BF1-4711-9BC4-9A05EEA204CE}"/>
+                <a16:creationId xmlns:a16="http://schemas.microsoft.com/office/drawing/2014/main" id="{8C1F592E-B20C-4F2D-92C2-CD65397B8038}"/>
               </a:ext>
             </a:extLst>
           </p:cNvPr>
@@ -9152,7 +9152,7 @@
           <p:cNvPr id="8" name="number-2">
             <a:extLst xmlns:a="http://schemas.openxmlformats.org/drawingml/2006/main">
               <a:ext uri="{FF2B5EF4-FFF2-40B4-BE49-F238E27FC236}">
-                <a16:creationId xmlns:a16="http://schemas.microsoft.com/office/drawing/2014/main" id="{567DB812-29FB-47AE-B950-3D2E288C60A0}"/>
+                <a16:creationId xmlns:a16="http://schemas.microsoft.com/office/drawing/2014/main" id="{13771095-E404-44AB-8435-CA162C3D4426}"/>
               </a:ext>
             </a:extLst>
           </p:cNvPr>
@@ -9209,7 +9209,7 @@
           <p:cNvPr id="9" name="item-2">
             <a:extLst xmlns:a="http://schemas.openxmlformats.org/drawingml/2006/main">
               <a:ext uri="{FF2B5EF4-FFF2-40B4-BE49-F238E27FC236}">
-                <a16:creationId xmlns:a16="http://schemas.microsoft.com/office/drawing/2014/main" id="{12497174-24B4-47A7-A12B-33A52DBB93AF}"/>
+                <a16:creationId xmlns:a16="http://schemas.microsoft.com/office/drawing/2014/main" id="{222D02E8-D27F-4AB1-82E8-C4BFB53F9CCB}"/>
               </a:ext>
             </a:extLst>
           </p:cNvPr>
@@ -9266,7 +9266,7 @@
           <p:cNvPr id="10" name="number-3">
             <a:extLst xmlns:a="http://schemas.openxmlformats.org/drawingml/2006/main">
               <a:ext uri="{FF2B5EF4-FFF2-40B4-BE49-F238E27FC236}">
-                <a16:creationId xmlns:a16="http://schemas.microsoft.com/office/drawing/2014/main" id="{5C7C812C-1C59-416C-94E8-EDBBEFC2E52E}"/>
+                <a16:creationId xmlns:a16="http://schemas.microsoft.com/office/drawing/2014/main" id="{F6C70AF9-1E21-42B8-9F21-73407DC7E654}"/>
               </a:ext>
             </a:extLst>
           </p:cNvPr>
@@ -9323,7 +9323,7 @@
           <p:cNvPr id="11" name="item-3">
             <a:extLst xmlns:a="http://schemas.openxmlformats.org/drawingml/2006/main">
               <a:ext uri="{FF2B5EF4-FFF2-40B4-BE49-F238E27FC236}">
-                <a16:creationId xmlns:a16="http://schemas.microsoft.com/office/drawing/2014/main" id="{CE4D04DF-243A-48C4-B73C-09DE432D3F05}"/>
+                <a16:creationId xmlns:a16="http://schemas.microsoft.com/office/drawing/2014/main" id="{6B8ED19C-5124-45FD-8B8D-1FB0D45E0025}"/>
               </a:ext>
             </a:extLst>
           </p:cNvPr>
@@ -9380,7 +9380,7 @@
           <p:cNvPr id="12" name="number-4">
             <a:extLst xmlns:a="http://schemas.openxmlformats.org/drawingml/2006/main">
               <a:ext uri="{FF2B5EF4-FFF2-40B4-BE49-F238E27FC236}">
-                <a16:creationId xmlns:a16="http://schemas.microsoft.com/office/drawing/2014/main" id="{F01C9E1F-2198-45DE-A7D1-238A38624FB7}"/>
+                <a16:creationId xmlns:a16="http://schemas.microsoft.com/office/drawing/2014/main" id="{057E8CBB-F859-494A-9CE1-FDC16D5BD1DA}"/>
               </a:ext>
             </a:extLst>
           </p:cNvPr>
@@ -9437,7 +9437,7 @@
           <p:cNvPr id="13" name="item-4">
             <a:extLst xmlns:a="http://schemas.openxmlformats.org/drawingml/2006/main">
               <a:ext uri="{FF2B5EF4-FFF2-40B4-BE49-F238E27FC236}">
-                <a16:creationId xmlns:a16="http://schemas.microsoft.com/office/drawing/2014/main" id="{C1AD11CD-458E-4F6E-9332-E9853D2B8EDF}"/>
+                <a16:creationId xmlns:a16="http://schemas.microsoft.com/office/drawing/2014/main" id="{F4B31B13-5415-4FA4-943A-8B756C15774D}"/>
               </a:ext>
             </a:extLst>
           </p:cNvPr>
@@ -9494,36 +9494,36 @@
           <p:cNvPr id="14" name="starter-next">
             <a:extLst xmlns:a="http://schemas.openxmlformats.org/drawingml/2006/main">
               <a:ext uri="{FF2B5EF4-FFF2-40B4-BE49-F238E27FC236}">
-                <a16:creationId xmlns:a16="http://schemas.microsoft.com/office/drawing/2014/main" id="{04DAE06D-0918-40C9-B9B8-5AF053096615}"/>
-              </a:ext>
-            </a:extLst>
-          </p:cNvPr>
-          <p:cNvSpPr>
-            <a:spLocks xmlns:a="http://schemas.openxmlformats.org/drawingml/2006/main" noGrp="1"/>
-          </p:cNvSpPr>
-          <p:nvPr/>
-        </p:nvSpPr>
-        <p:spPr>
-          <a:xfrm xmlns:a="http://schemas.openxmlformats.org/drawingml/2006/main">
-            <a:off x="704850" y="5800725"/>
-            <a:ext cx="10477500" cy="361950"/>
-          </a:xfrm>
-          <a:prstGeom xmlns:a="http://schemas.openxmlformats.org/drawingml/2006/main" prst="rect">
-            <a:avLst/>
-          </a:prstGeom>
-          <a:noFill xmlns:a="http://schemas.openxmlformats.org/drawingml/2006/main"/>
-          <a:ln xmlns:a="http://schemas.openxmlformats.org/drawingml/2006/main" w="0">
-            <a:noFill/>
-          </a:ln>
-        </p:spPr>
-        <p:txBody>
-          <a:bodyPr xmlns:a="http://schemas.openxmlformats.org/drawingml/2006/main" wrap="square" lIns="0" tIns="0" rIns="0" bIns="0" anchor="t">
-            <a:noAutofit/>
-          </a:bodyPr>
-          <a:lstStyle xmlns:a="http://schemas.openxmlformats.org/drawingml/2006/main"/>
-          <a:p xmlns:a="http://schemas.openxmlformats.org/drawingml/2006/main">
-            <a:pPr>
-              <a:defRPr sz="1650" b="0">
+                <a16:creationId xmlns:a16="http://schemas.microsoft.com/office/drawing/2014/main" id="{A969228D-452A-4ECD-8F72-C65A2AE489C4}"/>
+              </a:ext>
+            </a:extLst>
+          </p:cNvPr>
+          <p:cNvSpPr>
+            <a:spLocks xmlns:a="http://schemas.openxmlformats.org/drawingml/2006/main" noGrp="1"/>
+          </p:cNvSpPr>
+          <p:nvPr/>
+        </p:nvSpPr>
+        <p:spPr>
+          <a:xfrm xmlns:a="http://schemas.openxmlformats.org/drawingml/2006/main">
+            <a:off x="704850" y="5781675"/>
+            <a:ext cx="10477500" cy="400050"/>
+          </a:xfrm>
+          <a:prstGeom xmlns:a="http://schemas.openxmlformats.org/drawingml/2006/main" prst="rect">
+            <a:avLst/>
+          </a:prstGeom>
+          <a:noFill xmlns:a="http://schemas.openxmlformats.org/drawingml/2006/main"/>
+          <a:ln xmlns:a="http://schemas.openxmlformats.org/drawingml/2006/main" w="0">
+            <a:noFill/>
+          </a:ln>
+        </p:spPr>
+        <p:txBody>
+          <a:bodyPr xmlns:a="http://schemas.openxmlformats.org/drawingml/2006/main" wrap="square" lIns="0" tIns="0" rIns="0" bIns="0" anchor="t">
+            <a:noAutofit/>
+          </a:bodyPr>
+          <a:lstStyle xmlns:a="http://schemas.openxmlformats.org/drawingml/2006/main"/>
+          <a:p xmlns:a="http://schemas.openxmlformats.org/drawingml/2006/main">
+            <a:pPr>
+              <a:defRPr sz="1650" b="1">
                 <a:solidFill>
                   <a:srgbClr val="2D63FF"/>
                 </a:solidFill>
@@ -9533,7 +9533,7 @@
               </a:defRPr>
             </a:pPr>
             <a:r>
-              <a:rPr sz="1650" b="0">
+              <a:rPr sz="1650" b="1">
                 <a:solidFill>
                   <a:srgbClr val="2D63FF"/>
                 </a:solidFill>
@@ -9541,7 +9541,7 @@
                 <a:ea typeface="DejaVu Sans"/>
                 <a:cs typeface="DejaVu Sans"/>
               </a:rPr>
-              <a:t>Complete the worksheet starter before opening the experience.</a:t>
+              <a:t>Complete the experience in this lesson; finish with the plenary knowledge check.</a:t>
             </a:r>
           </a:p>
         </p:txBody>
@@ -9549,7 +9549,7 @@
     </p:spTree>
     <p:extLst>
       <p:ext uri="{BB962C8B-B14F-4D97-AF65-F5344CB8AC3E}">
-        <p14:creationId xmlns:p14="http://schemas.microsoft.com/office/powerpoint/2010/main" val="156254086"/>
+        <p14:creationId xmlns:p14="http://schemas.microsoft.com/office/powerpoint/2010/main" val="1654240099"/>
       </p:ext>
     </p:extLst>
   </p:cSld>
@@ -9580,7 +9580,7 @@
           <p:cNvPr id="14" name="topic">
             <a:extLst xmlns:a="http://schemas.openxmlformats.org/drawingml/2006/main">
               <a:ext uri="{FF2B5EF4-FFF2-40B4-BE49-F238E27FC236}">
-                <a16:creationId xmlns:a16="http://schemas.microsoft.com/office/drawing/2014/main" id="{20FC2137-2576-4B37-814E-B7603962B3D0}"/>
+                <a16:creationId xmlns:a16="http://schemas.microsoft.com/office/drawing/2014/main" id="{91EB3C47-FED5-4720-A463-2E9538F06EB2}"/>
               </a:ext>
             </a:extLst>
           </p:cNvPr>
@@ -9592,7 +9592,7 @@
         <p:spPr>
           <a:xfrm xmlns:a="http://schemas.openxmlformats.org/drawingml/2006/main">
             <a:off x="666750" y="323850"/>
-            <a:ext cx="6667500" cy="276225"/>
+            <a:ext cx="9810750" cy="276225"/>
           </a:xfrm>
           <a:prstGeom xmlns:a="http://schemas.openxmlformats.org/drawingml/2006/main" prst="rect">
             <a:avLst/>
@@ -9627,7 +9627,7 @@
                 <a:ea typeface="DejaVu Sans"/>
                 <a:cs typeface="DejaVu Sans"/>
               </a:rPr>
-              <a:t>TOPIC 1.1   LESSON 01</a:t>
+              <a:t>TOPIC 1.1   /   LESSON 01   /   SELF-CHECK</a:t>
             </a:r>
           </a:p>
         </p:txBody>
@@ -9637,7 +9637,7 @@
           <p:cNvPr id="2" name="heading">
             <a:extLst xmlns:a="http://schemas.openxmlformats.org/drawingml/2006/main">
               <a:ext uri="{FF2B5EF4-FFF2-40B4-BE49-F238E27FC236}">
-                <a16:creationId xmlns:a16="http://schemas.microsoft.com/office/drawing/2014/main" id="{1ECD4D5B-573B-4710-B849-B93488E61FE8}"/>
+                <a16:creationId xmlns:a16="http://schemas.microsoft.com/office/drawing/2014/main" id="{66266F39-3875-49E6-BD8B-BAC189551290}"/>
               </a:ext>
             </a:extLst>
           </p:cNvPr>
@@ -9694,7 +9694,7 @@
           <p:cNvPr id="3" name="footer">
             <a:extLst xmlns:a="http://schemas.openxmlformats.org/drawingml/2006/main">
               <a:ext uri="{FF2B5EF4-FFF2-40B4-BE49-F238E27FC236}">
-                <a16:creationId xmlns:a16="http://schemas.microsoft.com/office/drawing/2014/main" id="{4EFFC659-3835-41D9-BF5C-47CEDD799D7E}"/>
+                <a16:creationId xmlns:a16="http://schemas.microsoft.com/office/drawing/2014/main" id="{D15CA055-B915-4856-8F07-F330565BA22D}"/>
               </a:ext>
             </a:extLst>
           </p:cNvPr>
@@ -9741,7 +9741,7 @@
                 <a:ea typeface="DejaVu Sans"/>
                 <a:cs typeface="DejaVu Sans"/>
               </a:rPr>
-              <a:t>Revise 360    OCR J277 1.1 Systems architecture    Self-check</a:t>
+              <a:t>Revise 360    OCR J277 1.1 Systems architecture</a:t>
             </a:r>
           </a:p>
         </p:txBody>
@@ -9751,7 +9751,7 @@
           <p:cNvPr id="4" name="page">
             <a:extLst xmlns:a="http://schemas.openxmlformats.org/drawingml/2006/main">
               <a:ext uri="{FF2B5EF4-FFF2-40B4-BE49-F238E27FC236}">
-                <a16:creationId xmlns:a16="http://schemas.microsoft.com/office/drawing/2014/main" id="{56740ECF-6F3C-4308-8D08-7DA04DDC87BA}"/>
+                <a16:creationId xmlns:a16="http://schemas.microsoft.com/office/drawing/2014/main" id="{0B7111BE-A7CA-4A7C-B35A-8196B436DDE5}"/>
               </a:ext>
             </a:extLst>
           </p:cNvPr>
@@ -9808,7 +9808,7 @@
           <p:cNvPr id="5" name="confidence-instruction">
             <a:extLst xmlns:a="http://schemas.openxmlformats.org/drawingml/2006/main">
               <a:ext uri="{FF2B5EF4-FFF2-40B4-BE49-F238E27FC236}">
-                <a16:creationId xmlns:a16="http://schemas.microsoft.com/office/drawing/2014/main" id="{5A71FD8F-5308-4C2B-A85B-C3A348A89E68}"/>
+                <a16:creationId xmlns:a16="http://schemas.microsoft.com/office/drawing/2014/main" id="{74110569-8E58-4E8A-B2E7-C201066F58BD}"/>
               </a:ext>
             </a:extLst>
           </p:cNvPr>
@@ -9865,7 +9865,7 @@
           <p:cNvPr id="6" name="number-1">
             <a:extLst xmlns:a="http://schemas.openxmlformats.org/drawingml/2006/main">
               <a:ext uri="{FF2B5EF4-FFF2-40B4-BE49-F238E27FC236}">
-                <a16:creationId xmlns:a16="http://schemas.microsoft.com/office/drawing/2014/main" id="{86E0EE58-537F-4B59-890D-80254D8D6D16}"/>
+                <a16:creationId xmlns:a16="http://schemas.microsoft.com/office/drawing/2014/main" id="{D3BB37DC-5175-403D-948F-D01B1CDD62C7}"/>
               </a:ext>
             </a:extLst>
           </p:cNvPr>
@@ -9922,7 +9922,7 @@
           <p:cNvPr id="7" name="item-1">
             <a:extLst xmlns:a="http://schemas.openxmlformats.org/drawingml/2006/main">
               <a:ext uri="{FF2B5EF4-FFF2-40B4-BE49-F238E27FC236}">
-                <a16:creationId xmlns:a16="http://schemas.microsoft.com/office/drawing/2014/main" id="{9FF365B8-77B6-4858-84C3-90C6C0E5BB4C}"/>
+                <a16:creationId xmlns:a16="http://schemas.microsoft.com/office/drawing/2014/main" id="{8818D514-80EE-49DB-8572-799C3DC589FC}"/>
               </a:ext>
             </a:extLst>
           </p:cNvPr>
@@ -9979,7 +9979,7 @@
           <p:cNvPr id="8" name="number-2">
             <a:extLst xmlns:a="http://schemas.openxmlformats.org/drawingml/2006/main">
               <a:ext uri="{FF2B5EF4-FFF2-40B4-BE49-F238E27FC236}">
-                <a16:creationId xmlns:a16="http://schemas.microsoft.com/office/drawing/2014/main" id="{8FFEF5CB-8ADD-423E-93AB-FA9C591E15E7}"/>
+                <a16:creationId xmlns:a16="http://schemas.microsoft.com/office/drawing/2014/main" id="{7922EFA2-E27F-42DB-A318-3AC0503B6376}"/>
               </a:ext>
             </a:extLst>
           </p:cNvPr>
@@ -10036,7 +10036,7 @@
           <p:cNvPr id="9" name="item-2">
             <a:extLst xmlns:a="http://schemas.openxmlformats.org/drawingml/2006/main">
               <a:ext uri="{FF2B5EF4-FFF2-40B4-BE49-F238E27FC236}">
-                <a16:creationId xmlns:a16="http://schemas.microsoft.com/office/drawing/2014/main" id="{D79BE886-3A39-449F-B19B-695B372CFDA6}"/>
+                <a16:creationId xmlns:a16="http://schemas.microsoft.com/office/drawing/2014/main" id="{B81DE773-4CE3-4378-98BC-5B55666AE281}"/>
               </a:ext>
             </a:extLst>
           </p:cNvPr>
@@ -10093,7 +10093,7 @@
           <p:cNvPr id="10" name="number-3">
             <a:extLst xmlns:a="http://schemas.openxmlformats.org/drawingml/2006/main">
               <a:ext uri="{FF2B5EF4-FFF2-40B4-BE49-F238E27FC236}">
-                <a16:creationId xmlns:a16="http://schemas.microsoft.com/office/drawing/2014/main" id="{EB833849-98B9-4600-9869-72304BACD676}"/>
+                <a16:creationId xmlns:a16="http://schemas.microsoft.com/office/drawing/2014/main" id="{1A52D980-5A2D-48E8-B36B-58FB45CFFC0C}"/>
               </a:ext>
             </a:extLst>
           </p:cNvPr>
@@ -10150,7 +10150,7 @@
           <p:cNvPr id="11" name="item-3">
             <a:extLst xmlns:a="http://schemas.openxmlformats.org/drawingml/2006/main">
               <a:ext uri="{FF2B5EF4-FFF2-40B4-BE49-F238E27FC236}">
-                <a16:creationId xmlns:a16="http://schemas.microsoft.com/office/drawing/2014/main" id="{931209F6-EBC9-4904-BF71-8470848394B7}"/>
+                <a16:creationId xmlns:a16="http://schemas.microsoft.com/office/drawing/2014/main" id="{18EB30B3-9133-457E-BFCB-25CE2EF0D9B8}"/>
               </a:ext>
             </a:extLst>
           </p:cNvPr>
@@ -10207,7 +10207,7 @@
           <p:cNvPr id="12" name="number-4">
             <a:extLst xmlns:a="http://schemas.openxmlformats.org/drawingml/2006/main">
               <a:ext uri="{FF2B5EF4-FFF2-40B4-BE49-F238E27FC236}">
-                <a16:creationId xmlns:a16="http://schemas.microsoft.com/office/drawing/2014/main" id="{DF4AC0CE-C613-4990-916F-45BCCD60E5EF}"/>
+                <a16:creationId xmlns:a16="http://schemas.microsoft.com/office/drawing/2014/main" id="{B2B7313D-1DE2-4F60-8AD1-55FBFEFC8C27}"/>
               </a:ext>
             </a:extLst>
           </p:cNvPr>
@@ -10264,7 +10264,7 @@
           <p:cNvPr id="13" name="item-4">
             <a:extLst xmlns:a="http://schemas.openxmlformats.org/drawingml/2006/main">
               <a:ext uri="{FF2B5EF4-FFF2-40B4-BE49-F238E27FC236}">
-                <a16:creationId xmlns:a16="http://schemas.microsoft.com/office/drawing/2014/main" id="{76050ADD-0149-4C98-8E65-2EBF935174B6}"/>
+                <a16:creationId xmlns:a16="http://schemas.microsoft.com/office/drawing/2014/main" id="{8BC7C42B-A7C5-4DA4-9664-9E553C060E2D}"/>
               </a:ext>
             </a:extLst>
           </p:cNvPr>
@@ -10319,7 +10319,7 @@
     </p:spTree>
     <p:extLst>
       <p:ext uri="{BB962C8B-B14F-4D97-AF65-F5344CB8AC3E}">
-        <p14:creationId xmlns:p14="http://schemas.microsoft.com/office/powerpoint/2010/main" val="971318931"/>
+        <p14:creationId xmlns:p14="http://schemas.microsoft.com/office/powerpoint/2010/main" val="1133884814"/>
       </p:ext>
     </p:extLst>
   </p:cSld>
@@ -10332,7 +10332,7 @@
     <p:bg>
       <p:bgPr>
         <a:solidFill xmlns:a="http://schemas.openxmlformats.org/drawingml/2006/main">
-          <a:srgbClr val="FFFFFF"/>
+          <a:srgbClr val="FFF8E9"/>
         </a:solidFill>
       </p:bgPr>
     </p:bg>
@@ -10350,7 +10350,7 @@
           <p:cNvPr id="8" name="topic">
             <a:extLst xmlns:a="http://schemas.openxmlformats.org/drawingml/2006/main">
               <a:ext uri="{FF2B5EF4-FFF2-40B4-BE49-F238E27FC236}">
-                <a16:creationId xmlns:a16="http://schemas.microsoft.com/office/drawing/2014/main" id="{68775E35-8498-41CD-AD72-FEC78211DA5A}"/>
+                <a16:creationId xmlns:a16="http://schemas.microsoft.com/office/drawing/2014/main" id="{7CB9FDD6-D437-4497-B114-90B2F7AF0BCE}"/>
               </a:ext>
             </a:extLst>
           </p:cNvPr>
@@ -10362,7 +10362,7 @@
         <p:spPr>
           <a:xfrm xmlns:a="http://schemas.openxmlformats.org/drawingml/2006/main">
             <a:off x="666750" y="323850"/>
-            <a:ext cx="6667500" cy="276225"/>
+            <a:ext cx="9810750" cy="276225"/>
           </a:xfrm>
           <a:prstGeom xmlns:a="http://schemas.openxmlformats.org/drawingml/2006/main" prst="rect">
             <a:avLst/>
@@ -10397,7 +10397,7 @@
                 <a:ea typeface="DejaVu Sans"/>
                 <a:cs typeface="DejaVu Sans"/>
               </a:rPr>
-              <a:t>TOPIC 1.1   LESSON 01</a:t>
+              <a:t>TOPIC 1.1   /   LESSON 01   /   WORKSHEET STARTER</a:t>
             </a:r>
           </a:p>
         </p:txBody>
@@ -10407,7 +10407,7 @@
           <p:cNvPr id="2" name="heading">
             <a:extLst xmlns:a="http://schemas.openxmlformats.org/drawingml/2006/main">
               <a:ext uri="{FF2B5EF4-FFF2-40B4-BE49-F238E27FC236}">
-                <a16:creationId xmlns:a16="http://schemas.microsoft.com/office/drawing/2014/main" id="{5D6A333F-2228-4F74-AD7E-B92A49D7B35B}"/>
+                <a16:creationId xmlns:a16="http://schemas.microsoft.com/office/drawing/2014/main" id="{7D923726-E044-4613-B079-C036653AF231}"/>
               </a:ext>
             </a:extLst>
           </p:cNvPr>
@@ -10464,7 +10464,7 @@
           <p:cNvPr id="3" name="footer">
             <a:extLst xmlns:a="http://schemas.openxmlformats.org/drawingml/2006/main">
               <a:ext uri="{FF2B5EF4-FFF2-40B4-BE49-F238E27FC236}">
-                <a16:creationId xmlns:a16="http://schemas.microsoft.com/office/drawing/2014/main" id="{2C8F6001-AE63-4CC3-BC4F-4823911FBDA2}"/>
+                <a16:creationId xmlns:a16="http://schemas.microsoft.com/office/drawing/2014/main" id="{585FFAF8-9453-48BF-97CC-F69C54E0DB50}"/>
               </a:ext>
             </a:extLst>
           </p:cNvPr>
@@ -10511,7 +10511,7 @@
                 <a:ea typeface="DejaVu Sans"/>
                 <a:cs typeface="DejaVu Sans"/>
               </a:rPr>
-              <a:t>Revise 360    OCR J277 1.1 Systems architecture    Worksheet starter</a:t>
+              <a:t>Revise 360    OCR J277 1.1 Systems architecture</a:t>
             </a:r>
           </a:p>
         </p:txBody>
@@ -10521,7 +10521,7 @@
           <p:cNvPr id="4" name="page">
             <a:extLst xmlns:a="http://schemas.openxmlformats.org/drawingml/2006/main">
               <a:ext uri="{FF2B5EF4-FFF2-40B4-BE49-F238E27FC236}">
-                <a16:creationId xmlns:a16="http://schemas.microsoft.com/office/drawing/2014/main" id="{4AD67B88-5C39-4070-A695-D1A0C0781E44}"/>
+                <a16:creationId xmlns:a16="http://schemas.microsoft.com/office/drawing/2014/main" id="{60D1806B-76BF-4B1B-8CF6-A07DAD9C564B}"/>
               </a:ext>
             </a:extLst>
           </p:cNvPr>
@@ -10578,7 +10578,7 @@
           <p:cNvPr id="5" name="write-first">
             <a:extLst xmlns:a="http://schemas.openxmlformats.org/drawingml/2006/main">
               <a:ext uri="{FF2B5EF4-FFF2-40B4-BE49-F238E27FC236}">
-                <a16:creationId xmlns:a16="http://schemas.microsoft.com/office/drawing/2014/main" id="{8DF1A52F-92B8-4039-A3EC-6836E26AE680}"/>
+                <a16:creationId xmlns:a16="http://schemas.microsoft.com/office/drawing/2014/main" id="{F664F406-E7E8-434D-9609-AF819F709F5C}"/>
               </a:ext>
             </a:extLst>
           </p:cNvPr>
@@ -10635,7 +10635,7 @@
           <p:cNvPr id="6" name="worksheet-starter">
             <a:extLst xmlns:a="http://schemas.openxmlformats.org/drawingml/2006/main">
               <a:ext uri="{FF2B5EF4-FFF2-40B4-BE49-F238E27FC236}">
-                <a16:creationId xmlns:a16="http://schemas.microsoft.com/office/drawing/2014/main" id="{1AD90DFD-2E5E-4E78-B122-B8CFF0FE7CDE}"/>
+                <a16:creationId xmlns:a16="http://schemas.microsoft.com/office/drawing/2014/main" id="{2954A208-4035-456E-BE33-DC025D887881}"/>
               </a:ext>
             </a:extLst>
           </p:cNvPr>
@@ -10692,7 +10692,7 @@
           <p:cNvPr id="7" name="no-open">
             <a:extLst xmlns:a="http://schemas.openxmlformats.org/drawingml/2006/main">
               <a:ext uri="{FF2B5EF4-FFF2-40B4-BE49-F238E27FC236}">
-                <a16:creationId xmlns:a16="http://schemas.microsoft.com/office/drawing/2014/main" id="{69EC931C-CFC9-4B96-8178-875074256D6C}"/>
+                <a16:creationId xmlns:a16="http://schemas.microsoft.com/office/drawing/2014/main" id="{1EB08544-F8A4-4017-A7B3-01CE55252D41}"/>
               </a:ext>
             </a:extLst>
           </p:cNvPr>
@@ -10747,7 +10747,7 @@
     </p:spTree>
     <p:extLst>
       <p:ext uri="{BB962C8B-B14F-4D97-AF65-F5344CB8AC3E}">
-        <p14:creationId xmlns:p14="http://schemas.microsoft.com/office/powerpoint/2010/main" val="1982192889"/>
+        <p14:creationId xmlns:p14="http://schemas.microsoft.com/office/powerpoint/2010/main" val="952194560"/>
       </p:ext>
     </p:extLst>
   </p:cSld>
@@ -10760,7 +10760,7 @@
     <p:bg>
       <p:bgPr>
         <a:solidFill xmlns:a="http://schemas.openxmlformats.org/drawingml/2006/main">
-          <a:srgbClr val="FFFFFF"/>
+          <a:srgbClr val="EAF3FF"/>
         </a:solidFill>
       </p:bgPr>
     </p:bg>
@@ -10778,7 +10778,7 @@
           <p:cNvPr id="10" name="topic">
             <a:extLst xmlns:a="http://schemas.openxmlformats.org/drawingml/2006/main">
               <a:ext uri="{FF2B5EF4-FFF2-40B4-BE49-F238E27FC236}">
-                <a16:creationId xmlns:a16="http://schemas.microsoft.com/office/drawing/2014/main" id="{095DA07E-A2F9-48F0-A83A-4F4A2C5AD2F2}"/>
+                <a16:creationId xmlns:a16="http://schemas.microsoft.com/office/drawing/2014/main" id="{95EB5371-7AFE-453F-B49C-65AC83AE25CB}"/>
               </a:ext>
             </a:extLst>
           </p:cNvPr>
@@ -10790,7 +10790,7 @@
         <p:spPr>
           <a:xfrm xmlns:a="http://schemas.openxmlformats.org/drawingml/2006/main">
             <a:off x="666750" y="323850"/>
-            <a:ext cx="6667500" cy="276225"/>
+            <a:ext cx="9810750" cy="276225"/>
           </a:xfrm>
           <a:prstGeom xmlns:a="http://schemas.openxmlformats.org/drawingml/2006/main" prst="rect">
             <a:avLst/>
@@ -10825,7 +10825,7 @@
                 <a:ea typeface="DejaVu Sans"/>
                 <a:cs typeface="DejaVu Sans"/>
               </a:rPr>
-              <a:t>TOPIC 1.1   LESSON 01</a:t>
+              <a:t>TOPIC 1.1   /   LESSON 01   /   CHECK</a:t>
             </a:r>
           </a:p>
         </p:txBody>
@@ -10835,7 +10835,7 @@
           <p:cNvPr id="2" name="heading">
             <a:extLst xmlns:a="http://schemas.openxmlformats.org/drawingml/2006/main">
               <a:ext uri="{FF2B5EF4-FFF2-40B4-BE49-F238E27FC236}">
-                <a16:creationId xmlns:a16="http://schemas.microsoft.com/office/drawing/2014/main" id="{CC358497-5484-467B-B60B-C92B5955BA8C}"/>
+                <a16:creationId xmlns:a16="http://schemas.microsoft.com/office/drawing/2014/main" id="{B77983FB-08BF-4435-8164-A5C947BA4A54}"/>
               </a:ext>
             </a:extLst>
           </p:cNvPr>
@@ -10882,7 +10882,7 @@
                 <a:ea typeface="DejaVu Sans"/>
                 <a:cs typeface="DejaVu Sans"/>
               </a:rPr>
-              <a:t>Key terminology quiz</a:t>
+              <a:t>Starter: sample answers</a:t>
             </a:r>
           </a:p>
         </p:txBody>
@@ -10892,7 +10892,7 @@
           <p:cNvPr id="3" name="footer">
             <a:extLst xmlns:a="http://schemas.openxmlformats.org/drawingml/2006/main">
               <a:ext uri="{FF2B5EF4-FFF2-40B4-BE49-F238E27FC236}">
-                <a16:creationId xmlns:a16="http://schemas.microsoft.com/office/drawing/2014/main" id="{F396A464-D0DF-43F7-8D71-F7C1423538C2}"/>
+                <a16:creationId xmlns:a16="http://schemas.microsoft.com/office/drawing/2014/main" id="{D1D0EB0E-752D-47F6-8B01-96492D929F90}"/>
               </a:ext>
             </a:extLst>
           </p:cNvPr>
@@ -10939,7 +10939,7 @@
                 <a:ea typeface="DejaVu Sans"/>
                 <a:cs typeface="DejaVu Sans"/>
               </a:rPr>
-              <a:t>Revise 360    OCR J277 1.1 Systems architecture    Worksheet key terms</a:t>
+              <a:t>Revise 360    OCR J277 1.1 Systems architecture</a:t>
             </a:r>
           </a:p>
         </p:txBody>
@@ -10949,7 +10949,7 @@
           <p:cNvPr id="4" name="page">
             <a:extLst xmlns:a="http://schemas.openxmlformats.org/drawingml/2006/main">
               <a:ext uri="{FF2B5EF4-FFF2-40B4-BE49-F238E27FC236}">
-                <a16:creationId xmlns:a16="http://schemas.microsoft.com/office/drawing/2014/main" id="{5C5F6000-7123-46DD-A75E-38FD06FE6048}"/>
+                <a16:creationId xmlns:a16="http://schemas.microsoft.com/office/drawing/2014/main" id="{841142CB-3F23-4863-AE17-0B786AE86C80}"/>
               </a:ext>
             </a:extLst>
           </p:cNvPr>
@@ -11003,10 +11003,10 @@
       </p:sp>
       <p:sp>
         <p:nvSpPr>
-          <p:cNvPr id="5" name="define-first">
-            <a:extLst xmlns:a="http://schemas.openxmlformats.org/drawingml/2006/main">
-              <a:ext uri="{FF2B5EF4-FFF2-40B4-BE49-F238E27FC236}">
-                <a16:creationId xmlns:a16="http://schemas.microsoft.com/office/drawing/2014/main" id="{9019329E-9B5E-4149-8477-B551A46603CB}"/>
+          <p:cNvPr id="5" name="sample-note">
+            <a:extLst xmlns:a="http://schemas.openxmlformats.org/drawingml/2006/main">
+              <a:ext uri="{FF2B5EF4-FFF2-40B4-BE49-F238E27FC236}">
+                <a16:creationId xmlns:a16="http://schemas.microsoft.com/office/drawing/2014/main" id="{D6FCB2E0-01D7-41DF-94E4-F45D5EB78740}"/>
               </a:ext>
             </a:extLst>
           </p:cNvPr>
@@ -11018,24 +11018,24 @@
         <p:spPr>
           <a:xfrm xmlns:a="http://schemas.openxmlformats.org/drawingml/2006/main">
             <a:off x="704850" y="1562100"/>
-            <a:ext cx="10572750" cy="790575"/>
-          </a:xfrm>
-          <a:prstGeom xmlns:a="http://schemas.openxmlformats.org/drawingml/2006/main" prst="rect">
-            <a:avLst/>
-          </a:prstGeom>
-          <a:noFill xmlns:a="http://schemas.openxmlformats.org/drawingml/2006/main"/>
-          <a:ln xmlns:a="http://schemas.openxmlformats.org/drawingml/2006/main" w="0">
-            <a:noFill/>
-          </a:ln>
-        </p:spPr>
-        <p:txBody>
-          <a:bodyPr xmlns:a="http://schemas.openxmlformats.org/drawingml/2006/main" wrap="square" lIns="0" tIns="0" rIns="0" bIns="0" anchor="t">
-            <a:noAutofit/>
-          </a:bodyPr>
-          <a:lstStyle xmlns:a="http://schemas.openxmlformats.org/drawingml/2006/main"/>
-          <a:p xmlns:a="http://schemas.openxmlformats.org/drawingml/2006/main">
-            <a:pPr>
-              <a:defRPr sz="1875" b="0">
+            <a:ext cx="10477500" cy="533400"/>
+          </a:xfrm>
+          <a:prstGeom xmlns:a="http://schemas.openxmlformats.org/drawingml/2006/main" prst="rect">
+            <a:avLst/>
+          </a:prstGeom>
+          <a:noFill xmlns:a="http://schemas.openxmlformats.org/drawingml/2006/main"/>
+          <a:ln xmlns:a="http://schemas.openxmlformats.org/drawingml/2006/main" w="0">
+            <a:noFill/>
+          </a:ln>
+        </p:spPr>
+        <p:txBody>
+          <a:bodyPr xmlns:a="http://schemas.openxmlformats.org/drawingml/2006/main" wrap="square" lIns="0" tIns="0" rIns="0" bIns="0" anchor="t">
+            <a:noAutofit/>
+          </a:bodyPr>
+          <a:lstStyle xmlns:a="http://schemas.openxmlformats.org/drawingml/2006/main"/>
+          <a:p xmlns:a="http://schemas.openxmlformats.org/drawingml/2006/main">
+            <a:pPr>
+              <a:defRPr sz="1800" b="0">
                 <a:solidFill>
                   <a:srgbClr val="526174"/>
                 </a:solidFill>
@@ -11045,7 +11045,7 @@
               </a:defRPr>
             </a:pPr>
             <a:r>
-              <a:rPr sz="1875" b="0">
+              <a:rPr sz="1800" b="0">
                 <a:solidFill>
                   <a:srgbClr val="526174"/>
                 </a:solidFill>
@@ -11053,46 +11053,46 @@
                 <a:ea typeface="DejaVu Sans"/>
                 <a:cs typeface="DejaVu Sans"/>
               </a:rPr>
-              <a:t>Define the two terms listed in the key terminology section of your worksheet.</a:t>
-            </a:r>
-          </a:p>
-        </p:txBody>
-      </p:sp>
-      <p:sp>
-        <p:nvSpPr>
-          <p:cNvPr id="6" name="term-number-0">
-            <a:extLst xmlns:a="http://schemas.openxmlformats.org/drawingml/2006/main">
-              <a:ext uri="{FF2B5EF4-FFF2-40B4-BE49-F238E27FC236}">
-                <a16:creationId xmlns:a16="http://schemas.microsoft.com/office/drawing/2014/main" id="{50D016B4-2789-4C6F-9E2A-6F11915CC910}"/>
-              </a:ext>
-            </a:extLst>
-          </p:cNvPr>
-          <p:cNvSpPr>
-            <a:spLocks xmlns:a="http://schemas.openxmlformats.org/drawingml/2006/main" noGrp="1"/>
-          </p:cNvSpPr>
-          <p:nvPr/>
-        </p:nvSpPr>
-        <p:spPr>
-          <a:xfrm xmlns:a="http://schemas.openxmlformats.org/drawingml/2006/main">
-            <a:off x="723900" y="2686050"/>
-            <a:ext cx="590550" cy="533400"/>
-          </a:xfrm>
-          <a:prstGeom xmlns:a="http://schemas.openxmlformats.org/drawingml/2006/main" prst="rect">
-            <a:avLst/>
-          </a:prstGeom>
-          <a:noFill xmlns:a="http://schemas.openxmlformats.org/drawingml/2006/main"/>
-          <a:ln xmlns:a="http://schemas.openxmlformats.org/drawingml/2006/main" w="0">
-            <a:noFill/>
-          </a:ln>
-        </p:spPr>
-        <p:txBody>
-          <a:bodyPr xmlns:a="http://schemas.openxmlformats.org/drawingml/2006/main" wrap="square" lIns="0" tIns="0" rIns="0" bIns="0" anchor="t">
-            <a:noAutofit/>
-          </a:bodyPr>
-          <a:lstStyle xmlns:a="http://schemas.openxmlformats.org/drawingml/2006/main"/>
-          <a:p xmlns:a="http://schemas.openxmlformats.org/drawingml/2006/main">
-            <a:pPr>
-              <a:defRPr sz="2625" b="1">
+              <a:t>Compare your worksheet answer with these examples. Other accurate examples count.</a:t>
+            </a:r>
+          </a:p>
+        </p:txBody>
+      </p:sp>
+      <p:sp>
+        <p:nvSpPr>
+          <p:cNvPr id="6" name="number-1">
+            <a:extLst xmlns:a="http://schemas.openxmlformats.org/drawingml/2006/main">
+              <a:ext uri="{FF2B5EF4-FFF2-40B4-BE49-F238E27FC236}">
+                <a16:creationId xmlns:a16="http://schemas.microsoft.com/office/drawing/2014/main" id="{DFD618E7-1933-4CA8-A89A-B180B1EF2D89}"/>
+              </a:ext>
+            </a:extLst>
+          </p:cNvPr>
+          <p:cNvSpPr>
+            <a:spLocks xmlns:a="http://schemas.openxmlformats.org/drawingml/2006/main" noGrp="1"/>
+          </p:cNvSpPr>
+          <p:nvPr/>
+        </p:nvSpPr>
+        <p:spPr>
+          <a:xfrm xmlns:a="http://schemas.openxmlformats.org/drawingml/2006/main">
+            <a:off x="723900" y="2476500"/>
+            <a:ext cx="590550" cy="476250"/>
+          </a:xfrm>
+          <a:prstGeom xmlns:a="http://schemas.openxmlformats.org/drawingml/2006/main" prst="rect">
+            <a:avLst/>
+          </a:prstGeom>
+          <a:noFill xmlns:a="http://schemas.openxmlformats.org/drawingml/2006/main"/>
+          <a:ln xmlns:a="http://schemas.openxmlformats.org/drawingml/2006/main" w="0">
+            <a:noFill/>
+          </a:ln>
+        </p:spPr>
+        <p:txBody>
+          <a:bodyPr xmlns:a="http://schemas.openxmlformats.org/drawingml/2006/main" wrap="square" lIns="0" tIns="0" rIns="0" bIns="0" anchor="t">
+            <a:noAutofit/>
+          </a:bodyPr>
+          <a:lstStyle xmlns:a="http://schemas.openxmlformats.org/drawingml/2006/main"/>
+          <a:p xmlns:a="http://schemas.openxmlformats.org/drawingml/2006/main">
+            <a:pPr>
+              <a:defRPr sz="2175" b="1">
                 <a:solidFill>
                   <a:srgbClr val="2D63FF"/>
                 </a:solidFill>
@@ -11102,7 +11102,7 @@
               </a:defRPr>
             </a:pPr>
             <a:r>
-              <a:rPr sz="2625" b="1">
+              <a:rPr sz="2175" b="1">
                 <a:solidFill>
                   <a:srgbClr val="2D63FF"/>
                 </a:solidFill>
@@ -11117,39 +11117,39 @@
       </p:sp>
       <p:sp>
         <p:nvSpPr>
-          <p:cNvPr id="7" name="term-0">
-            <a:extLst xmlns:a="http://schemas.openxmlformats.org/drawingml/2006/main">
-              <a:ext uri="{FF2B5EF4-FFF2-40B4-BE49-F238E27FC236}">
-                <a16:creationId xmlns:a16="http://schemas.microsoft.com/office/drawing/2014/main" id="{CCA92921-D9E9-497E-A6B2-8F04928C318C}"/>
-              </a:ext>
-            </a:extLst>
-          </p:cNvPr>
-          <p:cNvSpPr>
-            <a:spLocks xmlns:a="http://schemas.openxmlformats.org/drawingml/2006/main" noGrp="1"/>
-          </p:cNvSpPr>
-          <p:nvPr/>
-        </p:nvSpPr>
-        <p:spPr>
-          <a:xfrm xmlns:a="http://schemas.openxmlformats.org/drawingml/2006/main">
-            <a:off x="1371600" y="2686050"/>
-            <a:ext cx="9667875" cy="666750"/>
-          </a:xfrm>
-          <a:prstGeom xmlns:a="http://schemas.openxmlformats.org/drawingml/2006/main" prst="rect">
-            <a:avLst/>
-          </a:prstGeom>
-          <a:noFill xmlns:a="http://schemas.openxmlformats.org/drawingml/2006/main"/>
-          <a:ln xmlns:a="http://schemas.openxmlformats.org/drawingml/2006/main" w="0">
-            <a:noFill/>
-          </a:ln>
-        </p:spPr>
-        <p:txBody>
-          <a:bodyPr xmlns:a="http://schemas.openxmlformats.org/drawingml/2006/main" wrap="square" lIns="0" tIns="0" rIns="0" bIns="0" anchor="t">
-            <a:noAutofit/>
-          </a:bodyPr>
-          <a:lstStyle xmlns:a="http://schemas.openxmlformats.org/drawingml/2006/main"/>
-          <a:p xmlns:a="http://schemas.openxmlformats.org/drawingml/2006/main">
-            <a:pPr>
-              <a:defRPr sz="2700" b="1">
+          <p:cNvPr id="7" name="item-1">
+            <a:extLst xmlns:a="http://schemas.openxmlformats.org/drawingml/2006/main">
+              <a:ext uri="{FF2B5EF4-FFF2-40B4-BE49-F238E27FC236}">
+                <a16:creationId xmlns:a16="http://schemas.microsoft.com/office/drawing/2014/main" id="{F6962C12-81A2-42AA-BC53-14F76BAA71C4}"/>
+              </a:ext>
+            </a:extLst>
+          </p:cNvPr>
+          <p:cNvSpPr>
+            <a:spLocks xmlns:a="http://schemas.openxmlformats.org/drawingml/2006/main" noGrp="1"/>
+          </p:cNvSpPr>
+          <p:nvPr/>
+        </p:nvSpPr>
+        <p:spPr>
+          <a:xfrm xmlns:a="http://schemas.openxmlformats.org/drawingml/2006/main">
+            <a:off x="1352550" y="2476500"/>
+            <a:ext cx="9925050" cy="1276350"/>
+          </a:xfrm>
+          <a:prstGeom xmlns:a="http://schemas.openxmlformats.org/drawingml/2006/main" prst="rect">
+            <a:avLst/>
+          </a:prstGeom>
+          <a:noFill xmlns:a="http://schemas.openxmlformats.org/drawingml/2006/main"/>
+          <a:ln xmlns:a="http://schemas.openxmlformats.org/drawingml/2006/main" w="0">
+            <a:noFill/>
+          </a:ln>
+        </p:spPr>
+        <p:txBody>
+          <a:bodyPr xmlns:a="http://schemas.openxmlformats.org/drawingml/2006/main" wrap="square" lIns="0" tIns="0" rIns="0" bIns="0" anchor="t">
+            <a:noAutofit/>
+          </a:bodyPr>
+          <a:lstStyle xmlns:a="http://schemas.openxmlformats.org/drawingml/2006/main"/>
+          <a:p xmlns:a="http://schemas.openxmlformats.org/drawingml/2006/main">
+            <a:pPr>
+              <a:defRPr sz="2175" b="0">
                 <a:solidFill>
                   <a:srgbClr val="101828"/>
                 </a:solidFill>
@@ -11159,7 +11159,7 @@
               </a:defRPr>
             </a:pPr>
             <a:r>
-              <a:rPr sz="2700" b="1">
+              <a:rPr sz="2175" b="0">
                 <a:solidFill>
                   <a:srgbClr val="101828"/>
                 </a:solidFill>
@@ -11167,46 +11167,46 @@
                 <a:ea typeface="DejaVu Sans"/>
                 <a:cs typeface="DejaVu Sans"/>
               </a:rPr>
-              <a:t>CPU</a:t>
-            </a:r>
-          </a:p>
-        </p:txBody>
-      </p:sp>
-      <p:sp>
-        <p:nvSpPr>
-          <p:cNvPr id="8" name="term-number-1">
-            <a:extLst xmlns:a="http://schemas.openxmlformats.org/drawingml/2006/main">
-              <a:ext uri="{FF2B5EF4-FFF2-40B4-BE49-F238E27FC236}">
-                <a16:creationId xmlns:a16="http://schemas.microsoft.com/office/drawing/2014/main" id="{0E8F8A22-2F0D-4110-8F62-7E975B134E36}"/>
-              </a:ext>
-            </a:extLst>
-          </p:cNvPr>
-          <p:cNvSpPr>
-            <a:spLocks xmlns:a="http://schemas.openxmlformats.org/drawingml/2006/main" noGrp="1"/>
-          </p:cNvSpPr>
-          <p:nvPr/>
-        </p:nvSpPr>
-        <p:spPr>
-          <a:xfrm xmlns:a="http://schemas.openxmlformats.org/drawingml/2006/main">
-            <a:off x="723900" y="4324350"/>
-            <a:ext cx="590550" cy="533400"/>
-          </a:xfrm>
-          <a:prstGeom xmlns:a="http://schemas.openxmlformats.org/drawingml/2006/main" prst="rect">
-            <a:avLst/>
-          </a:prstGeom>
-          <a:noFill xmlns:a="http://schemas.openxmlformats.org/drawingml/2006/main"/>
-          <a:ln xmlns:a="http://schemas.openxmlformats.org/drawingml/2006/main" w="0">
-            <a:noFill/>
-          </a:ln>
-        </p:spPr>
-        <p:txBody>
-          <a:bodyPr xmlns:a="http://schemas.openxmlformats.org/drawingml/2006/main" wrap="square" lIns="0" tIns="0" rIns="0" bIns="0" anchor="t">
-            <a:noAutofit/>
-          </a:bodyPr>
-          <a:lstStyle xmlns:a="http://schemas.openxmlformats.org/drawingml/2006/main"/>
-          <a:p xmlns:a="http://schemas.openxmlformats.org/drawingml/2006/main">
-            <a:pPr>
-              <a:defRPr sz="2625" b="1">
+              <a:t>Worktop = cache. Cupboard = RAM. Shop = secondary storage.</a:t>
+            </a:r>
+          </a:p>
+        </p:txBody>
+      </p:sp>
+      <p:sp>
+        <p:nvSpPr>
+          <p:cNvPr id="8" name="number-2">
+            <a:extLst xmlns:a="http://schemas.openxmlformats.org/drawingml/2006/main">
+              <a:ext uri="{FF2B5EF4-FFF2-40B4-BE49-F238E27FC236}">
+                <a16:creationId xmlns:a16="http://schemas.microsoft.com/office/drawing/2014/main" id="{E09AAE9A-53FE-4BC8-B271-EBC9F6AEE128}"/>
+              </a:ext>
+            </a:extLst>
+          </p:cNvPr>
+          <p:cNvSpPr>
+            <a:spLocks xmlns:a="http://schemas.openxmlformats.org/drawingml/2006/main" noGrp="1"/>
+          </p:cNvSpPr>
+          <p:nvPr/>
+        </p:nvSpPr>
+        <p:spPr>
+          <a:xfrm xmlns:a="http://schemas.openxmlformats.org/drawingml/2006/main">
+            <a:off x="723900" y="4000500"/>
+            <a:ext cx="590550" cy="476250"/>
+          </a:xfrm>
+          <a:prstGeom xmlns:a="http://schemas.openxmlformats.org/drawingml/2006/main" prst="rect">
+            <a:avLst/>
+          </a:prstGeom>
+          <a:noFill xmlns:a="http://schemas.openxmlformats.org/drawingml/2006/main"/>
+          <a:ln xmlns:a="http://schemas.openxmlformats.org/drawingml/2006/main" w="0">
+            <a:noFill/>
+          </a:ln>
+        </p:spPr>
+        <p:txBody>
+          <a:bodyPr xmlns:a="http://schemas.openxmlformats.org/drawingml/2006/main" wrap="square" lIns="0" tIns="0" rIns="0" bIns="0" anchor="t">
+            <a:noAutofit/>
+          </a:bodyPr>
+          <a:lstStyle xmlns:a="http://schemas.openxmlformats.org/drawingml/2006/main"/>
+          <a:p xmlns:a="http://schemas.openxmlformats.org/drawingml/2006/main">
+            <a:pPr>
+              <a:defRPr sz="2175" b="1">
                 <a:solidFill>
                   <a:srgbClr val="2D63FF"/>
                 </a:solidFill>
@@ -11216,7 +11216,7 @@
               </a:defRPr>
             </a:pPr>
             <a:r>
-              <a:rPr sz="2625" b="1">
+              <a:rPr sz="2175" b="1">
                 <a:solidFill>
                   <a:srgbClr val="2D63FF"/>
                 </a:solidFill>
@@ -11231,39 +11231,39 @@
       </p:sp>
       <p:sp>
         <p:nvSpPr>
-          <p:cNvPr id="9" name="term-1">
-            <a:extLst xmlns:a="http://schemas.openxmlformats.org/drawingml/2006/main">
-              <a:ext uri="{FF2B5EF4-FFF2-40B4-BE49-F238E27FC236}">
-                <a16:creationId xmlns:a16="http://schemas.microsoft.com/office/drawing/2014/main" id="{21D3DE3D-7A57-45E4-9361-0ED52A5F43BB}"/>
-              </a:ext>
-            </a:extLst>
-          </p:cNvPr>
-          <p:cNvSpPr>
-            <a:spLocks xmlns:a="http://schemas.openxmlformats.org/drawingml/2006/main" noGrp="1"/>
-          </p:cNvSpPr>
-          <p:nvPr/>
-        </p:nvSpPr>
-        <p:spPr>
-          <a:xfrm xmlns:a="http://schemas.openxmlformats.org/drawingml/2006/main">
-            <a:off x="1371600" y="4324350"/>
-            <a:ext cx="9667875" cy="666750"/>
-          </a:xfrm>
-          <a:prstGeom xmlns:a="http://schemas.openxmlformats.org/drawingml/2006/main" prst="rect">
-            <a:avLst/>
-          </a:prstGeom>
-          <a:noFill xmlns:a="http://schemas.openxmlformats.org/drawingml/2006/main"/>
-          <a:ln xmlns:a="http://schemas.openxmlformats.org/drawingml/2006/main" w="0">
-            <a:noFill/>
-          </a:ln>
-        </p:spPr>
-        <p:txBody>
-          <a:bodyPr xmlns:a="http://schemas.openxmlformats.org/drawingml/2006/main" wrap="square" lIns="0" tIns="0" rIns="0" bIns="0" anchor="t">
-            <a:noAutofit/>
-          </a:bodyPr>
-          <a:lstStyle xmlns:a="http://schemas.openxmlformats.org/drawingml/2006/main"/>
-          <a:p xmlns:a="http://schemas.openxmlformats.org/drawingml/2006/main">
-            <a:pPr>
-              <a:defRPr sz="2700" b="1">
+          <p:cNvPr id="9" name="item-2">
+            <a:extLst xmlns:a="http://schemas.openxmlformats.org/drawingml/2006/main">
+              <a:ext uri="{FF2B5EF4-FFF2-40B4-BE49-F238E27FC236}">
+                <a16:creationId xmlns:a16="http://schemas.microsoft.com/office/drawing/2014/main" id="{43871C7A-D9EF-450E-8D40-960CC746BFBB}"/>
+              </a:ext>
+            </a:extLst>
+          </p:cNvPr>
+          <p:cNvSpPr>
+            <a:spLocks xmlns:a="http://schemas.openxmlformats.org/drawingml/2006/main" noGrp="1"/>
+          </p:cNvSpPr>
+          <p:nvPr/>
+        </p:nvSpPr>
+        <p:spPr>
+          <a:xfrm xmlns:a="http://schemas.openxmlformats.org/drawingml/2006/main">
+            <a:off x="1352550" y="4000500"/>
+            <a:ext cx="9925050" cy="1276350"/>
+          </a:xfrm>
+          <a:prstGeom xmlns:a="http://schemas.openxmlformats.org/drawingml/2006/main" prst="rect">
+            <a:avLst/>
+          </a:prstGeom>
+          <a:noFill xmlns:a="http://schemas.openxmlformats.org/drawingml/2006/main"/>
+          <a:ln xmlns:a="http://schemas.openxmlformats.org/drawingml/2006/main" w="0">
+            <a:noFill/>
+          </a:ln>
+        </p:spPr>
+        <p:txBody>
+          <a:bodyPr xmlns:a="http://schemas.openxmlformats.org/drawingml/2006/main" wrap="square" lIns="0" tIns="0" rIns="0" bIns="0" anchor="t">
+            <a:noAutofit/>
+          </a:bodyPr>
+          <a:lstStyle xmlns:a="http://schemas.openxmlformats.org/drawingml/2006/main"/>
+          <a:p xmlns:a="http://schemas.openxmlformats.org/drawingml/2006/main">
+            <a:pPr>
+              <a:defRPr sz="2175" b="0">
                 <a:solidFill>
                   <a:srgbClr val="101828"/>
                 </a:solidFill>
@@ -11273,7 +11273,7 @@
               </a:defRPr>
             </a:pPr>
             <a:r>
-              <a:rPr sz="2700" b="1">
+              <a:rPr sz="2175" b="0">
                 <a:solidFill>
                   <a:srgbClr val="101828"/>
                 </a:solidFill>
@@ -11281,7 +11281,7 @@
                 <a:ea typeface="DejaVu Sans"/>
                 <a:cs typeface="DejaVu Sans"/>
               </a:rPr>
-              <a:t>Fetch-decode-execute cycle</a:t>
+              <a:t>The worktop keeps needed ingredients close. The CPU can use cached data without waiting as long for RAM.</a:t>
             </a:r>
           </a:p>
         </p:txBody>
@@ -11289,7 +11289,7 @@
     </p:spTree>
     <p:extLst>
       <p:ext uri="{BB962C8B-B14F-4D97-AF65-F5344CB8AC3E}">
-        <p14:creationId xmlns:p14="http://schemas.microsoft.com/office/powerpoint/2010/main" val="2146982400"/>
+        <p14:creationId xmlns:p14="http://schemas.microsoft.com/office/powerpoint/2010/main" val="1601737993"/>
       </p:ext>
     </p:extLst>
   </p:cSld>
@@ -11302,7 +11302,7 @@
     <p:bg>
       <p:bgPr>
         <a:solidFill xmlns:a="http://schemas.openxmlformats.org/drawingml/2006/main">
-          <a:srgbClr val="FFFFFF"/>
+          <a:srgbClr val="FFF8E9"/>
         </a:solidFill>
       </p:bgPr>
     </p:bg>
@@ -11320,7 +11320,7 @@
           <p:cNvPr id="10" name="topic">
             <a:extLst xmlns:a="http://schemas.openxmlformats.org/drawingml/2006/main">
               <a:ext uri="{FF2B5EF4-FFF2-40B4-BE49-F238E27FC236}">
-                <a16:creationId xmlns:a16="http://schemas.microsoft.com/office/drawing/2014/main" id="{8C7F75E6-0DA4-4CFD-915E-AFCAE7F7EAED}"/>
+                <a16:creationId xmlns:a16="http://schemas.microsoft.com/office/drawing/2014/main" id="{96C2A795-1B20-4E89-BDD0-E394EBBC4A99}"/>
               </a:ext>
             </a:extLst>
           </p:cNvPr>
@@ -11332,7 +11332,7 @@
         <p:spPr>
           <a:xfrm xmlns:a="http://schemas.openxmlformats.org/drawingml/2006/main">
             <a:off x="666750" y="323850"/>
-            <a:ext cx="6667500" cy="276225"/>
+            <a:ext cx="9810750" cy="276225"/>
           </a:xfrm>
           <a:prstGeom xmlns:a="http://schemas.openxmlformats.org/drawingml/2006/main" prst="rect">
             <a:avLst/>
@@ -11367,7 +11367,7 @@
                 <a:ea typeface="DejaVu Sans"/>
                 <a:cs typeface="DejaVu Sans"/>
               </a:rPr>
-              <a:t>TOPIC 1.1   LESSON 01</a:t>
+              <a:t>TOPIC 1.1   /   LESSON 01   /   WORKSHEET KEY TERMS</a:t>
             </a:r>
           </a:p>
         </p:txBody>
@@ -11377,7 +11377,7 @@
           <p:cNvPr id="2" name="heading">
             <a:extLst xmlns:a="http://schemas.openxmlformats.org/drawingml/2006/main">
               <a:ext uri="{FF2B5EF4-FFF2-40B4-BE49-F238E27FC236}">
-                <a16:creationId xmlns:a16="http://schemas.microsoft.com/office/drawing/2014/main" id="{E774309B-B25D-426A-A7B1-82D7CDCC40F7}"/>
+                <a16:creationId xmlns:a16="http://schemas.microsoft.com/office/drawing/2014/main" id="{32E47B28-EE8D-49E8-A362-9527D286180D}"/>
               </a:ext>
             </a:extLst>
           </p:cNvPr>
@@ -11424,7 +11424,7 @@
                 <a:ea typeface="DejaVu Sans"/>
                 <a:cs typeface="DejaVu Sans"/>
               </a:rPr>
-              <a:t>Starter: sample answers</a:t>
+              <a:t>Key terminology quiz</a:t>
             </a:r>
           </a:p>
         </p:txBody>
@@ -11434,7 +11434,7 @@
           <p:cNvPr id="3" name="footer">
             <a:extLst xmlns:a="http://schemas.openxmlformats.org/drawingml/2006/main">
               <a:ext uri="{FF2B5EF4-FFF2-40B4-BE49-F238E27FC236}">
-                <a16:creationId xmlns:a16="http://schemas.microsoft.com/office/drawing/2014/main" id="{F8D97C21-4C3E-4987-9C0B-4ED22234C9FB}"/>
+                <a16:creationId xmlns:a16="http://schemas.microsoft.com/office/drawing/2014/main" id="{A2056F00-3E3B-4721-96E1-CA0B4A0C7B8C}"/>
               </a:ext>
             </a:extLst>
           </p:cNvPr>
@@ -11481,7 +11481,7 @@
                 <a:ea typeface="DejaVu Sans"/>
                 <a:cs typeface="DejaVu Sans"/>
               </a:rPr>
-              <a:t>Revise 360    OCR J277 1.1 Systems architecture    Check</a:t>
+              <a:t>Revise 360    OCR J277 1.1 Systems architecture</a:t>
             </a:r>
           </a:p>
         </p:txBody>
@@ -11491,7 +11491,7 @@
           <p:cNvPr id="4" name="page">
             <a:extLst xmlns:a="http://schemas.openxmlformats.org/drawingml/2006/main">
               <a:ext uri="{FF2B5EF4-FFF2-40B4-BE49-F238E27FC236}">
-                <a16:creationId xmlns:a16="http://schemas.microsoft.com/office/drawing/2014/main" id="{C75A3E25-44F7-4F61-8A75-63AFF459DCC7}"/>
+                <a16:creationId xmlns:a16="http://schemas.microsoft.com/office/drawing/2014/main" id="{A1F26244-6D01-4908-822F-C6BCA71D0F12}"/>
               </a:ext>
             </a:extLst>
           </p:cNvPr>
@@ -11545,10 +11545,10 @@
       </p:sp>
       <p:sp>
         <p:nvSpPr>
-          <p:cNvPr id="5" name="sample-note">
-            <a:extLst xmlns:a="http://schemas.openxmlformats.org/drawingml/2006/main">
-              <a:ext uri="{FF2B5EF4-FFF2-40B4-BE49-F238E27FC236}">
-                <a16:creationId xmlns:a16="http://schemas.microsoft.com/office/drawing/2014/main" id="{6C35EDDA-2FCD-41C7-B147-42443D81C0E2}"/>
+          <p:cNvPr id="5" name="define-first">
+            <a:extLst xmlns:a="http://schemas.openxmlformats.org/drawingml/2006/main">
+              <a:ext uri="{FF2B5EF4-FFF2-40B4-BE49-F238E27FC236}">
+                <a16:creationId xmlns:a16="http://schemas.microsoft.com/office/drawing/2014/main" id="{7771320A-0159-4467-B8E3-75B7BFD89DF4}"/>
               </a:ext>
             </a:extLst>
           </p:cNvPr>
@@ -11560,24 +11560,24 @@
         <p:spPr>
           <a:xfrm xmlns:a="http://schemas.openxmlformats.org/drawingml/2006/main">
             <a:off x="704850" y="1562100"/>
-            <a:ext cx="10477500" cy="533400"/>
-          </a:xfrm>
-          <a:prstGeom xmlns:a="http://schemas.openxmlformats.org/drawingml/2006/main" prst="rect">
-            <a:avLst/>
-          </a:prstGeom>
-          <a:noFill xmlns:a="http://schemas.openxmlformats.org/drawingml/2006/main"/>
-          <a:ln xmlns:a="http://schemas.openxmlformats.org/drawingml/2006/main" w="0">
-            <a:noFill/>
-          </a:ln>
-        </p:spPr>
-        <p:txBody>
-          <a:bodyPr xmlns:a="http://schemas.openxmlformats.org/drawingml/2006/main" wrap="square" lIns="0" tIns="0" rIns="0" bIns="0" anchor="t">
-            <a:noAutofit/>
-          </a:bodyPr>
-          <a:lstStyle xmlns:a="http://schemas.openxmlformats.org/drawingml/2006/main"/>
-          <a:p xmlns:a="http://schemas.openxmlformats.org/drawingml/2006/main">
-            <a:pPr>
-              <a:defRPr sz="1800" b="0">
+            <a:ext cx="10572750" cy="790575"/>
+          </a:xfrm>
+          <a:prstGeom xmlns:a="http://schemas.openxmlformats.org/drawingml/2006/main" prst="rect">
+            <a:avLst/>
+          </a:prstGeom>
+          <a:noFill xmlns:a="http://schemas.openxmlformats.org/drawingml/2006/main"/>
+          <a:ln xmlns:a="http://schemas.openxmlformats.org/drawingml/2006/main" w="0">
+            <a:noFill/>
+          </a:ln>
+        </p:spPr>
+        <p:txBody>
+          <a:bodyPr xmlns:a="http://schemas.openxmlformats.org/drawingml/2006/main" wrap="square" lIns="0" tIns="0" rIns="0" bIns="0" anchor="t">
+            <a:noAutofit/>
+          </a:bodyPr>
+          <a:lstStyle xmlns:a="http://schemas.openxmlformats.org/drawingml/2006/main"/>
+          <a:p xmlns:a="http://schemas.openxmlformats.org/drawingml/2006/main">
+            <a:pPr>
+              <a:defRPr sz="1875" b="0">
                 <a:solidFill>
                   <a:srgbClr val="526174"/>
                 </a:solidFill>
@@ -11587,7 +11587,7 @@
               </a:defRPr>
             </a:pPr>
             <a:r>
-              <a:rPr sz="1800" b="0">
+              <a:rPr sz="1875" b="0">
                 <a:solidFill>
                   <a:srgbClr val="526174"/>
                 </a:solidFill>
@@ -11595,46 +11595,46 @@
                 <a:ea typeface="DejaVu Sans"/>
                 <a:cs typeface="DejaVu Sans"/>
               </a:rPr>
-              <a:t>Compare your worksheet answer with these examples. Other accurate examples count.</a:t>
-            </a:r>
-          </a:p>
-        </p:txBody>
-      </p:sp>
-      <p:sp>
-        <p:nvSpPr>
-          <p:cNvPr id="6" name="number-1">
-            <a:extLst xmlns:a="http://schemas.openxmlformats.org/drawingml/2006/main">
-              <a:ext uri="{FF2B5EF4-FFF2-40B4-BE49-F238E27FC236}">
-                <a16:creationId xmlns:a16="http://schemas.microsoft.com/office/drawing/2014/main" id="{692C0BC0-3A3E-419B-A79B-5831B898A540}"/>
-              </a:ext>
-            </a:extLst>
-          </p:cNvPr>
-          <p:cNvSpPr>
-            <a:spLocks xmlns:a="http://schemas.openxmlformats.org/drawingml/2006/main" noGrp="1"/>
-          </p:cNvSpPr>
-          <p:nvPr/>
-        </p:nvSpPr>
-        <p:spPr>
-          <a:xfrm xmlns:a="http://schemas.openxmlformats.org/drawingml/2006/main">
-            <a:off x="723900" y="2476500"/>
-            <a:ext cx="590550" cy="476250"/>
-          </a:xfrm>
-          <a:prstGeom xmlns:a="http://schemas.openxmlformats.org/drawingml/2006/main" prst="rect">
-            <a:avLst/>
-          </a:prstGeom>
-          <a:noFill xmlns:a="http://schemas.openxmlformats.org/drawingml/2006/main"/>
-          <a:ln xmlns:a="http://schemas.openxmlformats.org/drawingml/2006/main" w="0">
-            <a:noFill/>
-          </a:ln>
-        </p:spPr>
-        <p:txBody>
-          <a:bodyPr xmlns:a="http://schemas.openxmlformats.org/drawingml/2006/main" wrap="square" lIns="0" tIns="0" rIns="0" bIns="0" anchor="t">
-            <a:noAutofit/>
-          </a:bodyPr>
-          <a:lstStyle xmlns:a="http://schemas.openxmlformats.org/drawingml/2006/main"/>
-          <a:p xmlns:a="http://schemas.openxmlformats.org/drawingml/2006/main">
-            <a:pPr>
-              <a:defRPr sz="2175" b="1">
+              <a:t>Define the two terms listed in the key terminology section of your worksheet.</a:t>
+            </a:r>
+          </a:p>
+        </p:txBody>
+      </p:sp>
+      <p:sp>
+        <p:nvSpPr>
+          <p:cNvPr id="6" name="term-number-0">
+            <a:extLst xmlns:a="http://schemas.openxmlformats.org/drawingml/2006/main">
+              <a:ext uri="{FF2B5EF4-FFF2-40B4-BE49-F238E27FC236}">
+                <a16:creationId xmlns:a16="http://schemas.microsoft.com/office/drawing/2014/main" id="{70F545BD-8F51-4881-9636-B35F8ABE978D}"/>
+              </a:ext>
+            </a:extLst>
+          </p:cNvPr>
+          <p:cNvSpPr>
+            <a:spLocks xmlns:a="http://schemas.openxmlformats.org/drawingml/2006/main" noGrp="1"/>
+          </p:cNvSpPr>
+          <p:nvPr/>
+        </p:nvSpPr>
+        <p:spPr>
+          <a:xfrm xmlns:a="http://schemas.openxmlformats.org/drawingml/2006/main">
+            <a:off x="723900" y="2686050"/>
+            <a:ext cx="590550" cy="533400"/>
+          </a:xfrm>
+          <a:prstGeom xmlns:a="http://schemas.openxmlformats.org/drawingml/2006/main" prst="rect">
+            <a:avLst/>
+          </a:prstGeom>
+          <a:noFill xmlns:a="http://schemas.openxmlformats.org/drawingml/2006/main"/>
+          <a:ln xmlns:a="http://schemas.openxmlformats.org/drawingml/2006/main" w="0">
+            <a:noFill/>
+          </a:ln>
+        </p:spPr>
+        <p:txBody>
+          <a:bodyPr xmlns:a="http://schemas.openxmlformats.org/drawingml/2006/main" wrap="square" lIns="0" tIns="0" rIns="0" bIns="0" anchor="t">
+            <a:noAutofit/>
+          </a:bodyPr>
+          <a:lstStyle xmlns:a="http://schemas.openxmlformats.org/drawingml/2006/main"/>
+          <a:p xmlns:a="http://schemas.openxmlformats.org/drawingml/2006/main">
+            <a:pPr>
+              <a:defRPr sz="2625" b="1">
                 <a:solidFill>
                   <a:srgbClr val="2D63FF"/>
                 </a:solidFill>
@@ -11644,7 +11644,7 @@
               </a:defRPr>
             </a:pPr>
             <a:r>
-              <a:rPr sz="2175" b="1">
+              <a:rPr sz="2625" b="1">
                 <a:solidFill>
                   <a:srgbClr val="2D63FF"/>
                 </a:solidFill>
@@ -11659,39 +11659,39 @@
       </p:sp>
       <p:sp>
         <p:nvSpPr>
-          <p:cNvPr id="7" name="item-1">
-            <a:extLst xmlns:a="http://schemas.openxmlformats.org/drawingml/2006/main">
-              <a:ext uri="{FF2B5EF4-FFF2-40B4-BE49-F238E27FC236}">
-                <a16:creationId xmlns:a16="http://schemas.microsoft.com/office/drawing/2014/main" id="{60DD9296-A5C6-4FB0-B102-B1EAB4196D19}"/>
-              </a:ext>
-            </a:extLst>
-          </p:cNvPr>
-          <p:cNvSpPr>
-            <a:spLocks xmlns:a="http://schemas.openxmlformats.org/drawingml/2006/main" noGrp="1"/>
-          </p:cNvSpPr>
-          <p:nvPr/>
-        </p:nvSpPr>
-        <p:spPr>
-          <a:xfrm xmlns:a="http://schemas.openxmlformats.org/drawingml/2006/main">
-            <a:off x="1352550" y="2476500"/>
-            <a:ext cx="9925050" cy="1276350"/>
-          </a:xfrm>
-          <a:prstGeom xmlns:a="http://schemas.openxmlformats.org/drawingml/2006/main" prst="rect">
-            <a:avLst/>
-          </a:prstGeom>
-          <a:noFill xmlns:a="http://schemas.openxmlformats.org/drawingml/2006/main"/>
-          <a:ln xmlns:a="http://schemas.openxmlformats.org/drawingml/2006/main" w="0">
-            <a:noFill/>
-          </a:ln>
-        </p:spPr>
-        <p:txBody>
-          <a:bodyPr xmlns:a="http://schemas.openxmlformats.org/drawingml/2006/main" wrap="square" lIns="0" tIns="0" rIns="0" bIns="0" anchor="t">
-            <a:noAutofit/>
-          </a:bodyPr>
-          <a:lstStyle xmlns:a="http://schemas.openxmlformats.org/drawingml/2006/main"/>
-          <a:p xmlns:a="http://schemas.openxmlformats.org/drawingml/2006/main">
-            <a:pPr>
-              <a:defRPr sz="2175" b="0">
+          <p:cNvPr id="7" name="term-0">
+            <a:extLst xmlns:a="http://schemas.openxmlformats.org/drawingml/2006/main">
+              <a:ext uri="{FF2B5EF4-FFF2-40B4-BE49-F238E27FC236}">
+                <a16:creationId xmlns:a16="http://schemas.microsoft.com/office/drawing/2014/main" id="{6FBE9057-B430-45F2-AC8A-4FE8A0499002}"/>
+              </a:ext>
+            </a:extLst>
+          </p:cNvPr>
+          <p:cNvSpPr>
+            <a:spLocks xmlns:a="http://schemas.openxmlformats.org/drawingml/2006/main" noGrp="1"/>
+          </p:cNvSpPr>
+          <p:nvPr/>
+        </p:nvSpPr>
+        <p:spPr>
+          <a:xfrm xmlns:a="http://schemas.openxmlformats.org/drawingml/2006/main">
+            <a:off x="1371600" y="2686050"/>
+            <a:ext cx="9667875" cy="666750"/>
+          </a:xfrm>
+          <a:prstGeom xmlns:a="http://schemas.openxmlformats.org/drawingml/2006/main" prst="rect">
+            <a:avLst/>
+          </a:prstGeom>
+          <a:noFill xmlns:a="http://schemas.openxmlformats.org/drawingml/2006/main"/>
+          <a:ln xmlns:a="http://schemas.openxmlformats.org/drawingml/2006/main" w="0">
+            <a:noFill/>
+          </a:ln>
+        </p:spPr>
+        <p:txBody>
+          <a:bodyPr xmlns:a="http://schemas.openxmlformats.org/drawingml/2006/main" wrap="square" lIns="0" tIns="0" rIns="0" bIns="0" anchor="t">
+            <a:noAutofit/>
+          </a:bodyPr>
+          <a:lstStyle xmlns:a="http://schemas.openxmlformats.org/drawingml/2006/main"/>
+          <a:p xmlns:a="http://schemas.openxmlformats.org/drawingml/2006/main">
+            <a:pPr>
+              <a:defRPr sz="2700" b="1">
                 <a:solidFill>
                   <a:srgbClr val="101828"/>
                 </a:solidFill>
@@ -11701,7 +11701,7 @@
               </a:defRPr>
             </a:pPr>
             <a:r>
-              <a:rPr sz="2175" b="0">
+              <a:rPr sz="2700" b="1">
                 <a:solidFill>
                   <a:srgbClr val="101828"/>
                 </a:solidFill>
@@ -11709,46 +11709,46 @@
                 <a:ea typeface="DejaVu Sans"/>
                 <a:cs typeface="DejaVu Sans"/>
               </a:rPr>
-              <a:t>Worktop = cache. Cupboard = RAM. Shop = secondary storage.</a:t>
-            </a:r>
-          </a:p>
-        </p:txBody>
-      </p:sp>
-      <p:sp>
-        <p:nvSpPr>
-          <p:cNvPr id="8" name="number-2">
-            <a:extLst xmlns:a="http://schemas.openxmlformats.org/drawingml/2006/main">
-              <a:ext uri="{FF2B5EF4-FFF2-40B4-BE49-F238E27FC236}">
-                <a16:creationId xmlns:a16="http://schemas.microsoft.com/office/drawing/2014/main" id="{A2D3243F-0D0E-4536-AEB5-EC73B8C397A4}"/>
-              </a:ext>
-            </a:extLst>
-          </p:cNvPr>
-          <p:cNvSpPr>
-            <a:spLocks xmlns:a="http://schemas.openxmlformats.org/drawingml/2006/main" noGrp="1"/>
-          </p:cNvSpPr>
-          <p:nvPr/>
-        </p:nvSpPr>
-        <p:spPr>
-          <a:xfrm xmlns:a="http://schemas.openxmlformats.org/drawingml/2006/main">
-            <a:off x="723900" y="4000500"/>
-            <a:ext cx="590550" cy="476250"/>
-          </a:xfrm>
-          <a:prstGeom xmlns:a="http://schemas.openxmlformats.org/drawingml/2006/main" prst="rect">
-            <a:avLst/>
-          </a:prstGeom>
-          <a:noFill xmlns:a="http://schemas.openxmlformats.org/drawingml/2006/main"/>
-          <a:ln xmlns:a="http://schemas.openxmlformats.org/drawingml/2006/main" w="0">
-            <a:noFill/>
-          </a:ln>
-        </p:spPr>
-        <p:txBody>
-          <a:bodyPr xmlns:a="http://schemas.openxmlformats.org/drawingml/2006/main" wrap="square" lIns="0" tIns="0" rIns="0" bIns="0" anchor="t">
-            <a:noAutofit/>
-          </a:bodyPr>
-          <a:lstStyle xmlns:a="http://schemas.openxmlformats.org/drawingml/2006/main"/>
-          <a:p xmlns:a="http://schemas.openxmlformats.org/drawingml/2006/main">
-            <a:pPr>
-              <a:defRPr sz="2175" b="1">
+              <a:t>CPU</a:t>
+            </a:r>
+          </a:p>
+        </p:txBody>
+      </p:sp>
+      <p:sp>
+        <p:nvSpPr>
+          <p:cNvPr id="8" name="term-number-1">
+            <a:extLst xmlns:a="http://schemas.openxmlformats.org/drawingml/2006/main">
+              <a:ext uri="{FF2B5EF4-FFF2-40B4-BE49-F238E27FC236}">
+                <a16:creationId xmlns:a16="http://schemas.microsoft.com/office/drawing/2014/main" id="{0FA3C079-7ED4-4538-8AA3-6B70E55AE084}"/>
+              </a:ext>
+            </a:extLst>
+          </p:cNvPr>
+          <p:cNvSpPr>
+            <a:spLocks xmlns:a="http://schemas.openxmlformats.org/drawingml/2006/main" noGrp="1"/>
+          </p:cNvSpPr>
+          <p:nvPr/>
+        </p:nvSpPr>
+        <p:spPr>
+          <a:xfrm xmlns:a="http://schemas.openxmlformats.org/drawingml/2006/main">
+            <a:off x="723900" y="4324350"/>
+            <a:ext cx="590550" cy="533400"/>
+          </a:xfrm>
+          <a:prstGeom xmlns:a="http://schemas.openxmlformats.org/drawingml/2006/main" prst="rect">
+            <a:avLst/>
+          </a:prstGeom>
+          <a:noFill xmlns:a="http://schemas.openxmlformats.org/drawingml/2006/main"/>
+          <a:ln xmlns:a="http://schemas.openxmlformats.org/drawingml/2006/main" w="0">
+            <a:noFill/>
+          </a:ln>
+        </p:spPr>
+        <p:txBody>
+          <a:bodyPr xmlns:a="http://schemas.openxmlformats.org/drawingml/2006/main" wrap="square" lIns="0" tIns="0" rIns="0" bIns="0" anchor="t">
+            <a:noAutofit/>
+          </a:bodyPr>
+          <a:lstStyle xmlns:a="http://schemas.openxmlformats.org/drawingml/2006/main"/>
+          <a:p xmlns:a="http://schemas.openxmlformats.org/drawingml/2006/main">
+            <a:pPr>
+              <a:defRPr sz="2625" b="1">
                 <a:solidFill>
                   <a:srgbClr val="2D63FF"/>
                 </a:solidFill>
@@ -11758,7 +11758,7 @@
               </a:defRPr>
             </a:pPr>
             <a:r>
-              <a:rPr sz="2175" b="1">
+              <a:rPr sz="2625" b="1">
                 <a:solidFill>
                   <a:srgbClr val="2D63FF"/>
                 </a:solidFill>
@@ -11773,39 +11773,39 @@
       </p:sp>
       <p:sp>
         <p:nvSpPr>
-          <p:cNvPr id="9" name="item-2">
-            <a:extLst xmlns:a="http://schemas.openxmlformats.org/drawingml/2006/main">
-              <a:ext uri="{FF2B5EF4-FFF2-40B4-BE49-F238E27FC236}">
-                <a16:creationId xmlns:a16="http://schemas.microsoft.com/office/drawing/2014/main" id="{D2E22AED-A737-4A1A-948E-D1BE70274408}"/>
-              </a:ext>
-            </a:extLst>
-          </p:cNvPr>
-          <p:cNvSpPr>
-            <a:spLocks xmlns:a="http://schemas.openxmlformats.org/drawingml/2006/main" noGrp="1"/>
-          </p:cNvSpPr>
-          <p:nvPr/>
-        </p:nvSpPr>
-        <p:spPr>
-          <a:xfrm xmlns:a="http://schemas.openxmlformats.org/drawingml/2006/main">
-            <a:off x="1352550" y="4000500"/>
-            <a:ext cx="9925050" cy="1276350"/>
-          </a:xfrm>
-          <a:prstGeom xmlns:a="http://schemas.openxmlformats.org/drawingml/2006/main" prst="rect">
-            <a:avLst/>
-          </a:prstGeom>
-          <a:noFill xmlns:a="http://schemas.openxmlformats.org/drawingml/2006/main"/>
-          <a:ln xmlns:a="http://schemas.openxmlformats.org/drawingml/2006/main" w="0">
-            <a:noFill/>
-          </a:ln>
-        </p:spPr>
-        <p:txBody>
-          <a:bodyPr xmlns:a="http://schemas.openxmlformats.org/drawingml/2006/main" wrap="square" lIns="0" tIns="0" rIns="0" bIns="0" anchor="t">
-            <a:noAutofit/>
-          </a:bodyPr>
-          <a:lstStyle xmlns:a="http://schemas.openxmlformats.org/drawingml/2006/main"/>
-          <a:p xmlns:a="http://schemas.openxmlformats.org/drawingml/2006/main">
-            <a:pPr>
-              <a:defRPr sz="2175" b="0">
+          <p:cNvPr id="9" name="term-1">
+            <a:extLst xmlns:a="http://schemas.openxmlformats.org/drawingml/2006/main">
+              <a:ext uri="{FF2B5EF4-FFF2-40B4-BE49-F238E27FC236}">
+                <a16:creationId xmlns:a16="http://schemas.microsoft.com/office/drawing/2014/main" id="{BC2BB321-E484-45F7-84E3-63CAAE177636}"/>
+              </a:ext>
+            </a:extLst>
+          </p:cNvPr>
+          <p:cNvSpPr>
+            <a:spLocks xmlns:a="http://schemas.openxmlformats.org/drawingml/2006/main" noGrp="1"/>
+          </p:cNvSpPr>
+          <p:nvPr/>
+        </p:nvSpPr>
+        <p:spPr>
+          <a:xfrm xmlns:a="http://schemas.openxmlformats.org/drawingml/2006/main">
+            <a:off x="1371600" y="4324350"/>
+            <a:ext cx="9667875" cy="666750"/>
+          </a:xfrm>
+          <a:prstGeom xmlns:a="http://schemas.openxmlformats.org/drawingml/2006/main" prst="rect">
+            <a:avLst/>
+          </a:prstGeom>
+          <a:noFill xmlns:a="http://schemas.openxmlformats.org/drawingml/2006/main"/>
+          <a:ln xmlns:a="http://schemas.openxmlformats.org/drawingml/2006/main" w="0">
+            <a:noFill/>
+          </a:ln>
+        </p:spPr>
+        <p:txBody>
+          <a:bodyPr xmlns:a="http://schemas.openxmlformats.org/drawingml/2006/main" wrap="square" lIns="0" tIns="0" rIns="0" bIns="0" anchor="t">
+            <a:noAutofit/>
+          </a:bodyPr>
+          <a:lstStyle xmlns:a="http://schemas.openxmlformats.org/drawingml/2006/main"/>
+          <a:p xmlns:a="http://schemas.openxmlformats.org/drawingml/2006/main">
+            <a:pPr>
+              <a:defRPr sz="2700" b="1">
                 <a:solidFill>
                   <a:srgbClr val="101828"/>
                 </a:solidFill>
@@ -11815,7 +11815,7 @@
               </a:defRPr>
             </a:pPr>
             <a:r>
-              <a:rPr sz="2175" b="0">
+              <a:rPr sz="2700" b="1">
                 <a:solidFill>
                   <a:srgbClr val="101828"/>
                 </a:solidFill>
@@ -11823,7 +11823,7 @@
                 <a:ea typeface="DejaVu Sans"/>
                 <a:cs typeface="DejaVu Sans"/>
               </a:rPr>
-              <a:t>The worktop keeps needed ingredients close. The CPU can use cached data without waiting as long for RAM.</a:t>
+              <a:t>Fetch-decode-execute cycle</a:t>
             </a:r>
           </a:p>
         </p:txBody>
@@ -11831,7 +11831,7 @@
     </p:spTree>
     <p:extLst>
       <p:ext uri="{BB962C8B-B14F-4D97-AF65-F5344CB8AC3E}">
-        <p14:creationId xmlns:p14="http://schemas.microsoft.com/office/powerpoint/2010/main" val="959176289"/>
+        <p14:creationId xmlns:p14="http://schemas.microsoft.com/office/powerpoint/2010/main" val="1668827400"/>
       </p:ext>
     </p:extLst>
   </p:cSld>
@@ -11844,7 +11844,7 @@
     <p:bg>
       <p:bgPr>
         <a:solidFill xmlns:a="http://schemas.openxmlformats.org/drawingml/2006/main">
-          <a:srgbClr val="FFFFFF"/>
+          <a:srgbClr val="EAF3FF"/>
         </a:solidFill>
       </p:bgPr>
     </p:bg>
@@ -11862,7 +11862,7 @@
           <p:cNvPr id="10" name="topic">
             <a:extLst xmlns:a="http://schemas.openxmlformats.org/drawingml/2006/main">
               <a:ext uri="{FF2B5EF4-FFF2-40B4-BE49-F238E27FC236}">
-                <a16:creationId xmlns:a16="http://schemas.microsoft.com/office/drawing/2014/main" id="{7A757302-2A54-4B72-A01B-2CC2D5A42FFC}"/>
+                <a16:creationId xmlns:a16="http://schemas.microsoft.com/office/drawing/2014/main" id="{CE876AF7-14E5-4301-9CEE-E4B730219167}"/>
               </a:ext>
             </a:extLst>
           </p:cNvPr>
@@ -11874,7 +11874,7 @@
         <p:spPr>
           <a:xfrm xmlns:a="http://schemas.openxmlformats.org/drawingml/2006/main">
             <a:off x="666750" y="323850"/>
-            <a:ext cx="6667500" cy="276225"/>
+            <a:ext cx="9810750" cy="276225"/>
           </a:xfrm>
           <a:prstGeom xmlns:a="http://schemas.openxmlformats.org/drawingml/2006/main" prst="rect">
             <a:avLst/>
@@ -11909,7 +11909,7 @@
                 <a:ea typeface="DejaVu Sans"/>
                 <a:cs typeface="DejaVu Sans"/>
               </a:rPr>
-              <a:t>TOPIC 1.1   LESSON 01</a:t>
+              <a:t>TOPIC 1.1   /   LESSON 01   /   CHECK</a:t>
             </a:r>
           </a:p>
         </p:txBody>
@@ -11919,7 +11919,7 @@
           <p:cNvPr id="2" name="heading">
             <a:extLst xmlns:a="http://schemas.openxmlformats.org/drawingml/2006/main">
               <a:ext uri="{FF2B5EF4-FFF2-40B4-BE49-F238E27FC236}">
-                <a16:creationId xmlns:a16="http://schemas.microsoft.com/office/drawing/2014/main" id="{9F2BC15F-A7D1-44AA-839D-CA0BEE33BB8F}"/>
+                <a16:creationId xmlns:a16="http://schemas.microsoft.com/office/drawing/2014/main" id="{7832D02F-0B2C-446F-A2DD-B6FB38EF5534}"/>
               </a:ext>
             </a:extLst>
           </p:cNvPr>
@@ -11976,7 +11976,7 @@
           <p:cNvPr id="3" name="footer">
             <a:extLst xmlns:a="http://schemas.openxmlformats.org/drawingml/2006/main">
               <a:ext uri="{FF2B5EF4-FFF2-40B4-BE49-F238E27FC236}">
-                <a16:creationId xmlns:a16="http://schemas.microsoft.com/office/drawing/2014/main" id="{A9733084-3F41-43F2-9AB1-84547900E3CD}"/>
+                <a16:creationId xmlns:a16="http://schemas.microsoft.com/office/drawing/2014/main" id="{46BF6B77-981D-4358-8BB6-E347E56B32F0}"/>
               </a:ext>
             </a:extLst>
           </p:cNvPr>
@@ -12023,7 +12023,7 @@
                 <a:ea typeface="DejaVu Sans"/>
                 <a:cs typeface="DejaVu Sans"/>
               </a:rPr>
-              <a:t>Revise 360    OCR J277 1.1 Systems architecture    Check</a:t>
+              <a:t>Revise 360    OCR J277 1.1 Systems architecture</a:t>
             </a:r>
           </a:p>
         </p:txBody>
@@ -12033,7 +12033,7 @@
           <p:cNvPr id="4" name="page">
             <a:extLst xmlns:a="http://schemas.openxmlformats.org/drawingml/2006/main">
               <a:ext uri="{FF2B5EF4-FFF2-40B4-BE49-F238E27FC236}">
-                <a16:creationId xmlns:a16="http://schemas.microsoft.com/office/drawing/2014/main" id="{71BCE7B6-9C27-45BB-8B1E-A34C5958DB5F}"/>
+                <a16:creationId xmlns:a16="http://schemas.microsoft.com/office/drawing/2014/main" id="{D977C68B-4DFA-4500-8DA9-FC9D4BB98C3F}"/>
               </a:ext>
             </a:extLst>
           </p:cNvPr>
@@ -12090,7 +12090,7 @@
           <p:cNvPr id="5" name="terms-note">
             <a:extLst xmlns:a="http://schemas.openxmlformats.org/drawingml/2006/main">
               <a:ext uri="{FF2B5EF4-FFF2-40B4-BE49-F238E27FC236}">
-                <a16:creationId xmlns:a16="http://schemas.microsoft.com/office/drawing/2014/main" id="{9FBBD153-927A-43E0-9DF9-A9EE540059F8}"/>
+                <a16:creationId xmlns:a16="http://schemas.microsoft.com/office/drawing/2014/main" id="{3CF3E3C8-FF83-4B4A-AF93-C96F16B55C07}"/>
               </a:ext>
             </a:extLst>
           </p:cNvPr>
@@ -12147,7 +12147,7 @@
           <p:cNvPr id="6" name="answer-term-0">
             <a:extLst xmlns:a="http://schemas.openxmlformats.org/drawingml/2006/main">
               <a:ext uri="{FF2B5EF4-FFF2-40B4-BE49-F238E27FC236}">
-                <a16:creationId xmlns:a16="http://schemas.microsoft.com/office/drawing/2014/main" id="{E6113145-09CB-4166-91A2-B6326CA42DF0}"/>
+                <a16:creationId xmlns:a16="http://schemas.microsoft.com/office/drawing/2014/main" id="{55F2A54D-2B74-47EE-8D42-DFD5E37DAD46}"/>
               </a:ext>
             </a:extLst>
           </p:cNvPr>
@@ -12204,7 +12204,7 @@
           <p:cNvPr id="7" name="answer-definition-0">
             <a:extLst xmlns:a="http://schemas.openxmlformats.org/drawingml/2006/main">
               <a:ext uri="{FF2B5EF4-FFF2-40B4-BE49-F238E27FC236}">
-                <a16:creationId xmlns:a16="http://schemas.microsoft.com/office/drawing/2014/main" id="{1DE4B9DA-3EB5-4B34-B8C2-5468E39F0A3A}"/>
+                <a16:creationId xmlns:a16="http://schemas.microsoft.com/office/drawing/2014/main" id="{C3AE3ABB-E412-44A3-B036-D790DCC78100}"/>
               </a:ext>
             </a:extLst>
           </p:cNvPr>
@@ -12261,7 +12261,7 @@
           <p:cNvPr id="8" name="answer-term-1">
             <a:extLst xmlns:a="http://schemas.openxmlformats.org/drawingml/2006/main">
               <a:ext uri="{FF2B5EF4-FFF2-40B4-BE49-F238E27FC236}">
-                <a16:creationId xmlns:a16="http://schemas.microsoft.com/office/drawing/2014/main" id="{27DA4B8A-76DF-44EA-952F-6648996D263C}"/>
+                <a16:creationId xmlns:a16="http://schemas.microsoft.com/office/drawing/2014/main" id="{38B824FD-3DBF-4DF6-8F4D-C15259D9960E}"/>
               </a:ext>
             </a:extLst>
           </p:cNvPr>
@@ -12318,7 +12318,7 @@
           <p:cNvPr id="9" name="answer-definition-1">
             <a:extLst xmlns:a="http://schemas.openxmlformats.org/drawingml/2006/main">
               <a:ext uri="{FF2B5EF4-FFF2-40B4-BE49-F238E27FC236}">
-                <a16:creationId xmlns:a16="http://schemas.microsoft.com/office/drawing/2014/main" id="{3F67A037-9FA4-42BD-B6ED-46C971C89AA1}"/>
+                <a16:creationId xmlns:a16="http://schemas.microsoft.com/office/drawing/2014/main" id="{50B7B5B1-579B-4573-BED9-140857064DFF}"/>
               </a:ext>
             </a:extLst>
           </p:cNvPr>
@@ -12373,7 +12373,7 @@
     </p:spTree>
     <p:extLst>
       <p:ext uri="{BB962C8B-B14F-4D97-AF65-F5344CB8AC3E}">
-        <p14:creationId xmlns:p14="http://schemas.microsoft.com/office/powerpoint/2010/main" val="376170401"/>
+        <p14:creationId xmlns:p14="http://schemas.microsoft.com/office/powerpoint/2010/main" val="255281510"/>
       </p:ext>
     </p:extLst>
   </p:cSld>
@@ -12386,7 +12386,7 @@
     <p:bg>
       <p:bgPr>
         <a:solidFill xmlns:a="http://schemas.openxmlformats.org/drawingml/2006/main">
-          <a:srgbClr val="FFFFFF"/>
+          <a:srgbClr val="122448"/>
         </a:solidFill>
       </p:bgPr>
     </p:bg>
@@ -12401,10 +12401,10 @@
       </p:grpSpPr>
       <p:sp>
         <p:nvSpPr>
-          <p:cNvPr id="14" name="topic">
-            <a:extLst xmlns:a="http://schemas.openxmlformats.org/drawingml/2006/main">
-              <a:ext uri="{FF2B5EF4-FFF2-40B4-BE49-F238E27FC236}">
-                <a16:creationId xmlns:a16="http://schemas.microsoft.com/office/drawing/2014/main" id="{45612BF9-CF82-411B-8B84-4E21CDA337D3}"/>
+          <p:cNvPr id="12" name="topic">
+            <a:extLst xmlns:a="http://schemas.openxmlformats.org/drawingml/2006/main">
+              <a:ext uri="{FF2B5EF4-FFF2-40B4-BE49-F238E27FC236}">
+                <a16:creationId xmlns:a16="http://schemas.microsoft.com/office/drawing/2014/main" id="{3A7036AE-8E1F-47B4-8B6C-C0C5B1F72427}"/>
               </a:ext>
             </a:extLst>
           </p:cNvPr>
@@ -12416,7 +12416,7 @@
         <p:spPr>
           <a:xfrm xmlns:a="http://schemas.openxmlformats.org/drawingml/2006/main">
             <a:off x="666750" y="323850"/>
-            <a:ext cx="6667500" cy="276225"/>
+            <a:ext cx="9810750" cy="276225"/>
           </a:xfrm>
           <a:prstGeom xmlns:a="http://schemas.openxmlformats.org/drawingml/2006/main" prst="rect">
             <a:avLst/>
@@ -12435,7 +12435,7 @@
             <a:pPr>
               <a:defRPr sz="1125" b="1">
                 <a:solidFill>
-                  <a:srgbClr val="2D63FF"/>
+                  <a:srgbClr val="77D8FF"/>
                 </a:solidFill>
                 <a:latin typeface="DejaVu Sans"/>
                 <a:ea typeface="DejaVu Sans"/>
@@ -12445,13 +12445,13 @@
             <a:r>
               <a:rPr sz="1125" b="1">
                 <a:solidFill>
-                  <a:srgbClr val="2D63FF"/>
-                </a:solidFill>
-                <a:latin typeface="DejaVu Sans"/>
-                <a:ea typeface="DejaVu Sans"/>
-                <a:cs typeface="DejaVu Sans"/>
-              </a:rPr>
-              <a:t>TOPIC 1.1   LESSON 01</a:t>
+                  <a:srgbClr val="77D8FF"/>
+                </a:solidFill>
+                <a:latin typeface="DejaVu Sans"/>
+                <a:ea typeface="DejaVu Sans"/>
+                <a:cs typeface="DejaVu Sans"/>
+              </a:rPr>
+              <a:t>TOPIC 1.1   /   LESSON 01   /   EXPERIENCE</a:t>
             </a:r>
           </a:p>
         </p:txBody>
@@ -12461,7 +12461,7 @@
           <p:cNvPr id="2" name="heading">
             <a:extLst xmlns:a="http://schemas.openxmlformats.org/drawingml/2006/main">
               <a:ext uri="{FF2B5EF4-FFF2-40B4-BE49-F238E27FC236}">
-                <a16:creationId xmlns:a16="http://schemas.microsoft.com/office/drawing/2014/main" id="{D5CCA25F-8AF7-4993-9CA1-1258FEDDAE1A}"/>
+                <a16:creationId xmlns:a16="http://schemas.microsoft.com/office/drawing/2014/main" id="{0F8B1AD9-3995-46B8-8EB5-275309B33E77}"/>
               </a:ext>
             </a:extLst>
           </p:cNvPr>
@@ -12492,7 +12492,7 @@
             <a:pPr>
               <a:defRPr sz="3225" b="1">
                 <a:solidFill>
-                  <a:srgbClr val="101828"/>
+                  <a:srgbClr val="FFFFFF"/>
                 </a:solidFill>
                 <a:latin typeface="DejaVu Sans"/>
                 <a:ea typeface="DejaVu Sans"/>
@@ -12502,7 +12502,7 @@
             <a:r>
               <a:rPr sz="3225" b="1">
                 <a:solidFill>
-                  <a:srgbClr val="101828"/>
+                  <a:srgbClr val="FFFFFF"/>
                 </a:solidFill>
                 <a:latin typeface="DejaVu Sans"/>
                 <a:ea typeface="DejaVu Sans"/>
@@ -12518,7 +12518,7 @@
           <p:cNvPr id="3" name="footer">
             <a:extLst xmlns:a="http://schemas.openxmlformats.org/drawingml/2006/main">
               <a:ext uri="{FF2B5EF4-FFF2-40B4-BE49-F238E27FC236}">
-                <a16:creationId xmlns:a16="http://schemas.microsoft.com/office/drawing/2014/main" id="{42990638-A789-490E-8A19-17EF7AD39CAE}"/>
+                <a16:creationId xmlns:a16="http://schemas.microsoft.com/office/drawing/2014/main" id="{E2962236-C852-4FD1-8863-7278EEDF345D}"/>
               </a:ext>
             </a:extLst>
           </p:cNvPr>
@@ -12549,7 +12549,7 @@
             <a:pPr>
               <a:defRPr sz="1050" b="0">
                 <a:solidFill>
-                  <a:srgbClr val="526174"/>
+                  <a:srgbClr val="D7E4F3"/>
                 </a:solidFill>
                 <a:latin typeface="DejaVu Sans"/>
                 <a:ea typeface="DejaVu Sans"/>
@@ -12559,13 +12559,13 @@
             <a:r>
               <a:rPr sz="1050" b="0">
                 <a:solidFill>
-                  <a:srgbClr val="526174"/>
-                </a:solidFill>
-                <a:latin typeface="DejaVu Sans"/>
-                <a:ea typeface="DejaVu Sans"/>
-                <a:cs typeface="DejaVu Sans"/>
-              </a:rPr>
-              <a:t>Revise 360    OCR J277 1.1 Systems architecture    Experience</a:t>
+                  <a:srgbClr val="D7E4F3"/>
+                </a:solidFill>
+                <a:latin typeface="DejaVu Sans"/>
+                <a:ea typeface="DejaVu Sans"/>
+                <a:cs typeface="DejaVu Sans"/>
+              </a:rPr>
+              <a:t>Revise 360    OCR J277 1.1 Systems architecture</a:t>
             </a:r>
           </a:p>
         </p:txBody>
@@ -12575,7 +12575,7 @@
           <p:cNvPr id="4" name="page">
             <a:extLst xmlns:a="http://schemas.openxmlformats.org/drawingml/2006/main">
               <a:ext uri="{FF2B5EF4-FFF2-40B4-BE49-F238E27FC236}">
-                <a16:creationId xmlns:a16="http://schemas.microsoft.com/office/drawing/2014/main" id="{272148B4-BE23-4B2E-834E-B96936080F35}"/>
+                <a16:creationId xmlns:a16="http://schemas.microsoft.com/office/drawing/2014/main" id="{33C89367-CA47-41BF-9078-D6429C2DD49F}"/>
               </a:ext>
             </a:extLst>
           </p:cNvPr>
@@ -12606,7 +12606,7 @@
             <a:pPr>
               <a:defRPr sz="1050" b="0">
                 <a:solidFill>
-                  <a:srgbClr val="526174"/>
+                  <a:srgbClr val="D7E4F3"/>
                 </a:solidFill>
                 <a:latin typeface="DejaVu Sans"/>
                 <a:ea typeface="DejaVu Sans"/>
@@ -12616,7 +12616,7 @@
             <a:r>
               <a:rPr sz="1050" b="0">
                 <a:solidFill>
-                  <a:srgbClr val="526174"/>
+                  <a:srgbClr val="D7E4F3"/>
                 </a:solidFill>
                 <a:latin typeface="DejaVu Sans"/>
                 <a:ea typeface="DejaVu Sans"/>
@@ -12629,79 +12629,79 @@
       </p:sp>
       <p:sp>
         <p:nvSpPr>
-          <p:cNvPr id="5" name="number-1">
-            <a:extLst xmlns:a="http://schemas.openxmlformats.org/drawingml/2006/main">
-              <a:ext uri="{FF2B5EF4-FFF2-40B4-BE49-F238E27FC236}">
-                <a16:creationId xmlns:a16="http://schemas.microsoft.com/office/drawing/2014/main" id="{D1E30E27-FBB3-4571-9D5D-9C587D2EDBAF}"/>
-              </a:ext>
-            </a:extLst>
-          </p:cNvPr>
-          <p:cNvSpPr>
-            <a:spLocks xmlns:a="http://schemas.openxmlformats.org/drawingml/2006/main" noGrp="1"/>
-          </p:cNvSpPr>
-          <p:nvPr/>
-        </p:nvSpPr>
-        <p:spPr>
-          <a:xfrm xmlns:a="http://schemas.openxmlformats.org/drawingml/2006/main">
-            <a:off x="723900" y="1676400"/>
-            <a:ext cx="590550" cy="476250"/>
-          </a:xfrm>
-          <a:prstGeom xmlns:a="http://schemas.openxmlformats.org/drawingml/2006/main" prst="rect">
-            <a:avLst/>
-          </a:prstGeom>
-          <a:noFill xmlns:a="http://schemas.openxmlformats.org/drawingml/2006/main"/>
-          <a:ln xmlns:a="http://schemas.openxmlformats.org/drawingml/2006/main" w="0">
-            <a:noFill/>
-          </a:ln>
-        </p:spPr>
-        <p:txBody>
-          <a:bodyPr xmlns:a="http://schemas.openxmlformats.org/drawingml/2006/main" wrap="square" lIns="0" tIns="0" rIns="0" bIns="0" anchor="t">
-            <a:noAutofit/>
-          </a:bodyPr>
-          <a:lstStyle xmlns:a="http://schemas.openxmlformats.org/drawingml/2006/main"/>
-          <a:p xmlns:a="http://schemas.openxmlformats.org/drawingml/2006/main">
-            <a:pPr>
-              <a:defRPr sz="1950" b="1">
-                <a:solidFill>
-                  <a:srgbClr val="2D63FF"/>
-                </a:solidFill>
-                <a:latin typeface="DejaVu Sans"/>
-                <a:ea typeface="DejaVu Sans"/>
-                <a:cs typeface="DejaVu Sans"/>
-              </a:defRPr>
-            </a:pPr>
-            <a:r>
-              <a:rPr sz="1950" b="1">
-                <a:solidFill>
-                  <a:srgbClr val="2D63FF"/>
-                </a:solidFill>
-                <a:latin typeface="DejaVu Sans"/>
-                <a:ea typeface="DejaVu Sans"/>
-                <a:cs typeface="DejaVu Sans"/>
-              </a:rPr>
-              <a:t>1.</a:t>
-            </a:r>
-          </a:p>
-        </p:txBody>
-      </p:sp>
-      <p:sp>
-        <p:nvSpPr>
-          <p:cNvPr id="6" name="item-1">
-            <a:extLst xmlns:a="http://schemas.openxmlformats.org/drawingml/2006/main">
-              <a:ext uri="{FF2B5EF4-FFF2-40B4-BE49-F238E27FC236}">
-                <a16:creationId xmlns:a16="http://schemas.microsoft.com/office/drawing/2014/main" id="{859C8F94-E8BD-4849-ABD1-396450D2A5B6}"/>
-              </a:ext>
-            </a:extLst>
-          </p:cNvPr>
-          <p:cNvSpPr>
-            <a:spLocks xmlns:a="http://schemas.openxmlformats.org/drawingml/2006/main" noGrp="1"/>
-          </p:cNvSpPr>
-          <p:nvPr/>
-        </p:nvSpPr>
-        <p:spPr>
-          <a:xfrm xmlns:a="http://schemas.openxmlformats.org/drawingml/2006/main">
-            <a:off x="1352550" y="1676400"/>
-            <a:ext cx="9925050" cy="781050"/>
+          <p:cNvPr id="5" name="start-label">
+            <a:extLst xmlns:a="http://schemas.openxmlformats.org/drawingml/2006/main">
+              <a:ext uri="{FF2B5EF4-FFF2-40B4-BE49-F238E27FC236}">
+                <a16:creationId xmlns:a16="http://schemas.microsoft.com/office/drawing/2014/main" id="{27834349-24E1-407F-AB3F-9DADF1B9B2A6}"/>
+              </a:ext>
+            </a:extLst>
+          </p:cNvPr>
+          <p:cNvSpPr>
+            <a:spLocks xmlns:a="http://schemas.openxmlformats.org/drawingml/2006/main" noGrp="1"/>
+          </p:cNvSpPr>
+          <p:nvPr/>
+        </p:nvSpPr>
+        <p:spPr>
+          <a:xfrm xmlns:a="http://schemas.openxmlformats.org/drawingml/2006/main">
+            <a:off x="723900" y="1657350"/>
+            <a:ext cx="1428750" cy="352425"/>
+          </a:xfrm>
+          <a:prstGeom xmlns:a="http://schemas.openxmlformats.org/drawingml/2006/main" prst="rect">
+            <a:avLst/>
+          </a:prstGeom>
+          <a:noFill xmlns:a="http://schemas.openxmlformats.org/drawingml/2006/main"/>
+          <a:ln xmlns:a="http://schemas.openxmlformats.org/drawingml/2006/main" w="0">
+            <a:noFill/>
+          </a:ln>
+        </p:spPr>
+        <p:txBody>
+          <a:bodyPr xmlns:a="http://schemas.openxmlformats.org/drawingml/2006/main" wrap="square" lIns="0" tIns="0" rIns="0" bIns="0" anchor="t">
+            <a:noAutofit/>
+          </a:bodyPr>
+          <a:lstStyle xmlns:a="http://schemas.openxmlformats.org/drawingml/2006/main"/>
+          <a:p xmlns:a="http://schemas.openxmlformats.org/drawingml/2006/main">
+            <a:pPr>
+              <a:defRPr sz="1575" b="1">
+                <a:solidFill>
+                  <a:srgbClr val="77D8FF"/>
+                </a:solidFill>
+                <a:latin typeface="DejaVu Sans"/>
+                <a:ea typeface="DejaVu Sans"/>
+                <a:cs typeface="DejaVu Sans"/>
+              </a:defRPr>
+            </a:pPr>
+            <a:r>
+              <a:rPr sz="1575" b="1">
+                <a:solidFill>
+                  <a:srgbClr val="77D8FF"/>
+                </a:solidFill>
+                <a:latin typeface="DejaVu Sans"/>
+                <a:ea typeface="DejaVu Sans"/>
+                <a:cs typeface="DejaVu Sans"/>
+              </a:rPr>
+              <a:t>START</a:t>
+            </a:r>
+          </a:p>
+        </p:txBody>
+      </p:sp>
+      <p:sp>
+        <p:nvSpPr>
+          <p:cNvPr id="6" name="start">
+            <a:extLst xmlns:a="http://schemas.openxmlformats.org/drawingml/2006/main">
+              <a:ext uri="{FF2B5EF4-FFF2-40B4-BE49-F238E27FC236}">
+                <a16:creationId xmlns:a16="http://schemas.microsoft.com/office/drawing/2014/main" id="{2B754E1D-59DE-41F8-B858-29F22B6CA19F}"/>
+              </a:ext>
+            </a:extLst>
+          </p:cNvPr>
+          <p:cNvSpPr>
+            <a:spLocks xmlns:a="http://schemas.openxmlformats.org/drawingml/2006/main" noGrp="1"/>
+          </p:cNvSpPr>
+          <p:nvPr/>
+        </p:nvSpPr>
+        <p:spPr>
+          <a:xfrm xmlns:a="http://schemas.openxmlformats.org/drawingml/2006/main">
+            <a:off x="723900" y="1990725"/>
+            <a:ext cx="10572750" cy="685800"/>
           </a:xfrm>
           <a:prstGeom xmlns:a="http://schemas.openxmlformats.org/drawingml/2006/main" prst="rect">
             <a:avLst/>
@@ -12720,7 +12720,7 @@
             <a:pPr>
               <a:defRPr sz="1950" b="0">
                 <a:solidFill>
-                  <a:srgbClr val="101828"/>
+                  <a:srgbClr val="FFFFFF"/>
                 </a:solidFill>
                 <a:latin typeface="DejaVu Sans"/>
                 <a:ea typeface="DejaVu Sans"/>
@@ -12730,206 +12730,206 @@
             <a:r>
               <a:rPr sz="1950" b="0">
                 <a:solidFill>
-                  <a:srgbClr val="101828"/>
-                </a:solidFill>
-                <a:latin typeface="DejaVu Sans"/>
-                <a:ea typeface="DejaVu Sans"/>
-                <a:cs typeface="DejaVu Sans"/>
-              </a:rPr>
-              <a:t>Select Fetch-execute factory from Topic 1.1. Keep your worksheet beside you.</a:t>
-            </a:r>
-          </a:p>
-        </p:txBody>
-      </p:sp>
-      <p:sp>
-        <p:nvSpPr>
-          <p:cNvPr id="7" name="number-2">
-            <a:extLst xmlns:a="http://schemas.openxmlformats.org/drawingml/2006/main">
-              <a:ext uri="{FF2B5EF4-FFF2-40B4-BE49-F238E27FC236}">
-                <a16:creationId xmlns:a16="http://schemas.microsoft.com/office/drawing/2014/main" id="{4FAE9FF2-F733-4377-A760-B1D1F081E9B8}"/>
-              </a:ext>
-            </a:extLst>
-          </p:cNvPr>
-          <p:cNvSpPr>
-            <a:spLocks xmlns:a="http://schemas.openxmlformats.org/drawingml/2006/main" noGrp="1"/>
-          </p:cNvSpPr>
-          <p:nvPr/>
-        </p:nvSpPr>
-        <p:spPr>
-          <a:xfrm xmlns:a="http://schemas.openxmlformats.org/drawingml/2006/main">
-            <a:off x="723900" y="2647950"/>
-            <a:ext cx="590550" cy="476250"/>
-          </a:xfrm>
-          <a:prstGeom xmlns:a="http://schemas.openxmlformats.org/drawingml/2006/main" prst="rect">
-            <a:avLst/>
-          </a:prstGeom>
-          <a:noFill xmlns:a="http://schemas.openxmlformats.org/drawingml/2006/main"/>
-          <a:ln xmlns:a="http://schemas.openxmlformats.org/drawingml/2006/main" w="0">
-            <a:noFill/>
-          </a:ln>
-        </p:spPr>
-        <p:txBody>
-          <a:bodyPr xmlns:a="http://schemas.openxmlformats.org/drawingml/2006/main" wrap="square" lIns="0" tIns="0" rIns="0" bIns="0" anchor="t">
-            <a:noAutofit/>
-          </a:bodyPr>
-          <a:lstStyle xmlns:a="http://schemas.openxmlformats.org/drawingml/2006/main"/>
-          <a:p xmlns:a="http://schemas.openxmlformats.org/drawingml/2006/main">
-            <a:pPr>
-              <a:defRPr sz="1875" b="1">
-                <a:solidFill>
-                  <a:srgbClr val="2D63FF"/>
-                </a:solidFill>
-                <a:latin typeface="DejaVu Sans"/>
-                <a:ea typeface="DejaVu Sans"/>
-                <a:cs typeface="DejaVu Sans"/>
-              </a:defRPr>
-            </a:pPr>
-            <a:r>
-              <a:rPr sz="1875" b="1">
-                <a:solidFill>
-                  <a:srgbClr val="2D63FF"/>
-                </a:solidFill>
-                <a:latin typeface="DejaVu Sans"/>
-                <a:ea typeface="DejaVu Sans"/>
-                <a:cs typeface="DejaVu Sans"/>
-              </a:rPr>
-              <a:t>2.</a:t>
-            </a:r>
-          </a:p>
-        </p:txBody>
-      </p:sp>
-      <p:sp>
-        <p:nvSpPr>
-          <p:cNvPr id="8" name="item-2">
-            <a:extLst xmlns:a="http://schemas.openxmlformats.org/drawingml/2006/main">
-              <a:ext uri="{FF2B5EF4-FFF2-40B4-BE49-F238E27FC236}">
-                <a16:creationId xmlns:a16="http://schemas.microsoft.com/office/drawing/2014/main" id="{10CC82A7-01B7-4465-AADF-D9B29FC7780C}"/>
-              </a:ext>
-            </a:extLst>
-          </p:cNvPr>
-          <p:cNvSpPr>
-            <a:spLocks xmlns:a="http://schemas.openxmlformats.org/drawingml/2006/main" noGrp="1"/>
-          </p:cNvSpPr>
-          <p:nvPr/>
-        </p:nvSpPr>
-        <p:spPr>
-          <a:xfrm xmlns:a="http://schemas.openxmlformats.org/drawingml/2006/main">
-            <a:off x="1352550" y="2647950"/>
-            <a:ext cx="9925050" cy="838200"/>
-          </a:xfrm>
-          <a:prstGeom xmlns:a="http://schemas.openxmlformats.org/drawingml/2006/main" prst="rect">
-            <a:avLst/>
-          </a:prstGeom>
-          <a:noFill xmlns:a="http://schemas.openxmlformats.org/drawingml/2006/main"/>
-          <a:ln xmlns:a="http://schemas.openxmlformats.org/drawingml/2006/main" w="0">
-            <a:noFill/>
-          </a:ln>
-        </p:spPr>
-        <p:txBody>
-          <a:bodyPr xmlns:a="http://schemas.openxmlformats.org/drawingml/2006/main" wrap="square" lIns="0" tIns="0" rIns="0" bIns="0" anchor="t">
-            <a:noAutofit/>
-          </a:bodyPr>
-          <a:lstStyle xmlns:a="http://schemas.openxmlformats.org/drawingml/2006/main"/>
-          <a:p xmlns:a="http://schemas.openxmlformats.org/drawingml/2006/main">
-            <a:pPr>
-              <a:defRPr sz="1875" b="0">
-                <a:solidFill>
-                  <a:srgbClr val="101828"/>
-                </a:solidFill>
-                <a:latin typeface="DejaVu Sans"/>
-                <a:ea typeface="DejaVu Sans"/>
-                <a:cs typeface="DejaVu Sans"/>
-              </a:defRPr>
-            </a:pPr>
-            <a:r>
-              <a:rPr sz="1875" b="0">
-                <a:solidFill>
-                  <a:srgbClr val="101828"/>
-                </a:solidFill>
-                <a:latin typeface="DejaVu Sans"/>
-                <a:ea typeface="DejaVu Sans"/>
-                <a:cs typeface="DejaVu Sans"/>
-              </a:rPr>
-              <a:t>At each station, read the wall panel and write the key fact and challenge answer before tapping the badge.</a:t>
-            </a:r>
-          </a:p>
-        </p:txBody>
-      </p:sp>
-      <p:sp>
-        <p:nvSpPr>
-          <p:cNvPr id="9" name="number-3">
-            <a:extLst xmlns:a="http://schemas.openxmlformats.org/drawingml/2006/main">
-              <a:ext uri="{FF2B5EF4-FFF2-40B4-BE49-F238E27FC236}">
-                <a16:creationId xmlns:a16="http://schemas.microsoft.com/office/drawing/2014/main" id="{F0250261-42CA-43C9-BB4C-81A0DF51ED2B}"/>
-              </a:ext>
-            </a:extLst>
-          </p:cNvPr>
-          <p:cNvSpPr>
-            <a:spLocks xmlns:a="http://schemas.openxmlformats.org/drawingml/2006/main" noGrp="1"/>
-          </p:cNvSpPr>
-          <p:nvPr/>
-        </p:nvSpPr>
-        <p:spPr>
-          <a:xfrm xmlns:a="http://schemas.openxmlformats.org/drawingml/2006/main">
-            <a:off x="723900" y="3705225"/>
-            <a:ext cx="590550" cy="476250"/>
-          </a:xfrm>
-          <a:prstGeom xmlns:a="http://schemas.openxmlformats.org/drawingml/2006/main" prst="rect">
-            <a:avLst/>
-          </a:prstGeom>
-          <a:noFill xmlns:a="http://schemas.openxmlformats.org/drawingml/2006/main"/>
-          <a:ln xmlns:a="http://schemas.openxmlformats.org/drawingml/2006/main" w="0">
-            <a:noFill/>
-          </a:ln>
-        </p:spPr>
-        <p:txBody>
-          <a:bodyPr xmlns:a="http://schemas.openxmlformats.org/drawingml/2006/main" wrap="square" lIns="0" tIns="0" rIns="0" bIns="0" anchor="t">
-            <a:noAutofit/>
-          </a:bodyPr>
-          <a:lstStyle xmlns:a="http://schemas.openxmlformats.org/drawingml/2006/main"/>
-          <a:p xmlns:a="http://schemas.openxmlformats.org/drawingml/2006/main">
-            <a:pPr>
-              <a:defRPr sz="1950" b="1">
-                <a:solidFill>
-                  <a:srgbClr val="2D63FF"/>
-                </a:solidFill>
-                <a:latin typeface="DejaVu Sans"/>
-                <a:ea typeface="DejaVu Sans"/>
-                <a:cs typeface="DejaVu Sans"/>
-              </a:defRPr>
-            </a:pPr>
-            <a:r>
-              <a:rPr sz="1950" b="1">
-                <a:solidFill>
-                  <a:srgbClr val="2D63FF"/>
-                </a:solidFill>
-                <a:latin typeface="DejaVu Sans"/>
-                <a:ea typeface="DejaVu Sans"/>
-                <a:cs typeface="DejaVu Sans"/>
-              </a:rPr>
-              <a:t>3.</a:t>
-            </a:r>
-          </a:p>
-        </p:txBody>
-      </p:sp>
-      <p:sp>
-        <p:nvSpPr>
-          <p:cNvPr id="10" name="item-3">
-            <a:extLst xmlns:a="http://schemas.openxmlformats.org/drawingml/2006/main">
-              <a:ext uri="{FF2B5EF4-FFF2-40B4-BE49-F238E27FC236}">
-                <a16:creationId xmlns:a16="http://schemas.microsoft.com/office/drawing/2014/main" id="{F012FCB0-E84D-4B41-A9AC-1C7FC70B470E}"/>
-              </a:ext>
-            </a:extLst>
-          </p:cNvPr>
-          <p:cNvSpPr>
-            <a:spLocks xmlns:a="http://schemas.openxmlformats.org/drawingml/2006/main" noGrp="1"/>
-          </p:cNvSpPr>
-          <p:nvPr/>
-        </p:nvSpPr>
-        <p:spPr>
-          <a:xfrm xmlns:a="http://schemas.openxmlformats.org/drawingml/2006/main">
-            <a:off x="1352550" y="3705225"/>
-            <a:ext cx="9925050" cy="714375"/>
+                  <a:srgbClr val="FFFFFF"/>
+                </a:solidFill>
+                <a:latin typeface="DejaVu Sans"/>
+                <a:ea typeface="DejaVu Sans"/>
+                <a:cs typeface="DejaVu Sans"/>
+              </a:rPr>
+              <a:t>Select Fetch-execute factory from Topic 1.1 and keep your worksheet beside you.</a:t>
+            </a:r>
+          </a:p>
+        </p:txBody>
+      </p:sp>
+      <p:sp>
+        <p:nvSpPr>
+          <p:cNvPr id="7" name="own-words-label">
+            <a:extLst xmlns:a="http://schemas.openxmlformats.org/drawingml/2006/main">
+              <a:ext uri="{FF2B5EF4-FFF2-40B4-BE49-F238E27FC236}">
+                <a16:creationId xmlns:a16="http://schemas.microsoft.com/office/drawing/2014/main" id="{89E6AB7F-1EC6-459A-A40B-4082846AA484}"/>
+              </a:ext>
+            </a:extLst>
+          </p:cNvPr>
+          <p:cNvSpPr>
+            <a:spLocks xmlns:a="http://schemas.openxmlformats.org/drawingml/2006/main" noGrp="1"/>
+          </p:cNvSpPr>
+          <p:nvPr/>
+        </p:nvSpPr>
+        <p:spPr>
+          <a:xfrm xmlns:a="http://schemas.openxmlformats.org/drawingml/2006/main">
+            <a:off x="723900" y="2924175"/>
+            <a:ext cx="4000500" cy="352425"/>
+          </a:xfrm>
+          <a:prstGeom xmlns:a="http://schemas.openxmlformats.org/drawingml/2006/main" prst="rect">
+            <a:avLst/>
+          </a:prstGeom>
+          <a:noFill xmlns:a="http://schemas.openxmlformats.org/drawingml/2006/main"/>
+          <a:ln xmlns:a="http://schemas.openxmlformats.org/drawingml/2006/main" w="0">
+            <a:noFill/>
+          </a:ln>
+        </p:spPr>
+        <p:txBody>
+          <a:bodyPr xmlns:a="http://schemas.openxmlformats.org/drawingml/2006/main" wrap="square" lIns="0" tIns="0" rIns="0" bIns="0" anchor="t">
+            <a:noAutofit/>
+          </a:bodyPr>
+          <a:lstStyle xmlns:a="http://schemas.openxmlformats.org/drawingml/2006/main"/>
+          <a:p xmlns:a="http://schemas.openxmlformats.org/drawingml/2006/main">
+            <a:pPr>
+              <a:defRPr sz="1575" b="1">
+                <a:solidFill>
+                  <a:srgbClr val="77D8FF"/>
+                </a:solidFill>
+                <a:latin typeface="DejaVu Sans"/>
+                <a:ea typeface="DejaVu Sans"/>
+                <a:cs typeface="DejaVu Sans"/>
+              </a:defRPr>
+            </a:pPr>
+            <a:r>
+              <a:rPr sz="1575" b="1">
+                <a:solidFill>
+                  <a:srgbClr val="77D8FF"/>
+                </a:solidFill>
+                <a:latin typeface="DejaVu Sans"/>
+                <a:ea typeface="DejaVu Sans"/>
+                <a:cs typeface="DejaVu Sans"/>
+              </a:rPr>
+              <a:t>AT EVERY STATION</a:t>
+            </a:r>
+          </a:p>
+        </p:txBody>
+      </p:sp>
+      <p:sp>
+        <p:nvSpPr>
+          <p:cNvPr id="8" name="own-words">
+            <a:extLst xmlns:a="http://schemas.openxmlformats.org/drawingml/2006/main">
+              <a:ext uri="{FF2B5EF4-FFF2-40B4-BE49-F238E27FC236}">
+                <a16:creationId xmlns:a16="http://schemas.microsoft.com/office/drawing/2014/main" id="{AD6AC50D-84AB-4F0E-9C7A-AA5EE4082A40}"/>
+              </a:ext>
+            </a:extLst>
+          </p:cNvPr>
+          <p:cNvSpPr>
+            <a:spLocks xmlns:a="http://schemas.openxmlformats.org/drawingml/2006/main" noGrp="1"/>
+          </p:cNvSpPr>
+          <p:nvPr/>
+        </p:nvSpPr>
+        <p:spPr>
+          <a:xfrm xmlns:a="http://schemas.openxmlformats.org/drawingml/2006/main">
+            <a:off x="723900" y="3276600"/>
+            <a:ext cx="10572750" cy="1104900"/>
+          </a:xfrm>
+          <a:prstGeom xmlns:a="http://schemas.openxmlformats.org/drawingml/2006/main" prst="rect">
+            <a:avLst/>
+          </a:prstGeom>
+          <a:noFill xmlns:a="http://schemas.openxmlformats.org/drawingml/2006/main"/>
+          <a:ln xmlns:a="http://schemas.openxmlformats.org/drawingml/2006/main" w="0">
+            <a:noFill/>
+          </a:ln>
+        </p:spPr>
+        <p:txBody>
+          <a:bodyPr xmlns:a="http://schemas.openxmlformats.org/drawingml/2006/main" wrap="square" lIns="0" tIns="0" rIns="0" bIns="0" anchor="t">
+            <a:noAutofit/>
+          </a:bodyPr>
+          <a:lstStyle xmlns:a="http://schemas.openxmlformats.org/drawingml/2006/main"/>
+          <a:p xmlns:a="http://schemas.openxmlformats.org/drawingml/2006/main">
+            <a:pPr>
+              <a:defRPr sz="2250" b="1">
+                <a:solidFill>
+                  <a:srgbClr val="FFFFFF"/>
+                </a:solidFill>
+                <a:latin typeface="DejaVu Sans"/>
+                <a:ea typeface="DejaVu Sans"/>
+                <a:cs typeface="DejaVu Sans"/>
+              </a:defRPr>
+            </a:pPr>
+            <a:r>
+              <a:rPr sz="2250" b="1">
+                <a:solidFill>
+                  <a:srgbClr val="FFFFFF"/>
+                </a:solidFill>
+                <a:latin typeface="DejaVu Sans"/>
+                <a:ea typeface="DejaVu Sans"/>
+                <a:cs typeface="DejaVu Sans"/>
+              </a:rPr>
+              <a:t>Write the key fact IN YOUR OWN WORDS and answer the worksheet challenge before tapping the badge.</a:t>
+            </a:r>
+          </a:p>
+        </p:txBody>
+      </p:sp>
+      <p:sp>
+        <p:nvSpPr>
+          <p:cNvPr id="9" name="finish-label">
+            <a:extLst xmlns:a="http://schemas.openxmlformats.org/drawingml/2006/main">
+              <a:ext uri="{FF2B5EF4-FFF2-40B4-BE49-F238E27FC236}">
+                <a16:creationId xmlns:a16="http://schemas.microsoft.com/office/drawing/2014/main" id="{2EB34759-B627-42E0-A133-3D89755353C5}"/>
+              </a:ext>
+            </a:extLst>
+          </p:cNvPr>
+          <p:cNvSpPr>
+            <a:spLocks xmlns:a="http://schemas.openxmlformats.org/drawingml/2006/main" noGrp="1"/>
+          </p:cNvSpPr>
+          <p:nvPr/>
+        </p:nvSpPr>
+        <p:spPr>
+          <a:xfrm xmlns:a="http://schemas.openxmlformats.org/drawingml/2006/main">
+            <a:off x="723900" y="4638675"/>
+            <a:ext cx="1428750" cy="352425"/>
+          </a:xfrm>
+          <a:prstGeom xmlns:a="http://schemas.openxmlformats.org/drawingml/2006/main" prst="rect">
+            <a:avLst/>
+          </a:prstGeom>
+          <a:noFill xmlns:a="http://schemas.openxmlformats.org/drawingml/2006/main"/>
+          <a:ln xmlns:a="http://schemas.openxmlformats.org/drawingml/2006/main" w="0">
+            <a:noFill/>
+          </a:ln>
+        </p:spPr>
+        <p:txBody>
+          <a:bodyPr xmlns:a="http://schemas.openxmlformats.org/drawingml/2006/main" wrap="square" lIns="0" tIns="0" rIns="0" bIns="0" anchor="t">
+            <a:noAutofit/>
+          </a:bodyPr>
+          <a:lstStyle xmlns:a="http://schemas.openxmlformats.org/drawingml/2006/main"/>
+          <a:p xmlns:a="http://schemas.openxmlformats.org/drawingml/2006/main">
+            <a:pPr>
+              <a:defRPr sz="1575" b="1">
+                <a:solidFill>
+                  <a:srgbClr val="77D8FF"/>
+                </a:solidFill>
+                <a:latin typeface="DejaVu Sans"/>
+                <a:ea typeface="DejaVu Sans"/>
+                <a:cs typeface="DejaVu Sans"/>
+              </a:defRPr>
+            </a:pPr>
+            <a:r>
+              <a:rPr sz="1575" b="1">
+                <a:solidFill>
+                  <a:srgbClr val="77D8FF"/>
+                </a:solidFill>
+                <a:latin typeface="DejaVu Sans"/>
+                <a:ea typeface="DejaVu Sans"/>
+                <a:cs typeface="DejaVu Sans"/>
+              </a:rPr>
+              <a:t>FINISH</a:t>
+            </a:r>
+          </a:p>
+        </p:txBody>
+      </p:sp>
+      <p:sp>
+        <p:nvSpPr>
+          <p:cNvPr id="10" name="finish">
+            <a:extLst xmlns:a="http://schemas.openxmlformats.org/drawingml/2006/main">
+              <a:ext uri="{FF2B5EF4-FFF2-40B4-BE49-F238E27FC236}">
+                <a16:creationId xmlns:a16="http://schemas.microsoft.com/office/drawing/2014/main" id="{C113DBC7-0F67-4BA0-AF50-3DC3EF8F1AE9}"/>
+              </a:ext>
+            </a:extLst>
+          </p:cNvPr>
+          <p:cNvSpPr>
+            <a:spLocks xmlns:a="http://schemas.openxmlformats.org/drawingml/2006/main" noGrp="1"/>
+          </p:cNvSpPr>
+          <p:nvPr/>
+        </p:nvSpPr>
+        <p:spPr>
+          <a:xfrm xmlns:a="http://schemas.openxmlformats.org/drawingml/2006/main">
+            <a:off x="723900" y="4972050"/>
+            <a:ext cx="10572750" cy="666750"/>
           </a:xfrm>
           <a:prstGeom xmlns:a="http://schemas.openxmlformats.org/drawingml/2006/main" prst="rect">
             <a:avLst/>
@@ -12948,7 +12948,7 @@
             <a:pPr>
               <a:defRPr sz="1950" b="0">
                 <a:solidFill>
-                  <a:srgbClr val="101828"/>
+                  <a:srgbClr val="FFFFFF"/>
                 </a:solidFill>
                 <a:latin typeface="DejaVu Sans"/>
                 <a:ea typeface="DejaVu Sans"/>
@@ -12958,185 +12958,82 @@
             <a:r>
               <a:rPr sz="1950" b="0">
                 <a:solidFill>
-                  <a:srgbClr val="101828"/>
-                </a:solidFill>
-                <a:latin typeface="DejaVu Sans"/>
-                <a:ea typeface="DejaVu Sans"/>
-                <a:cs typeface="DejaVu Sans"/>
-              </a:rPr>
-              <a:t>Tap the badge and answer on screen. Your first answer is the one that counts.</a:t>
-            </a:r>
-          </a:p>
-        </p:txBody>
-      </p:sp>
-      <p:sp>
-        <p:nvSpPr>
-          <p:cNvPr id="11" name="number-4">
-            <a:extLst xmlns:a="http://schemas.openxmlformats.org/drawingml/2006/main">
-              <a:ext uri="{FF2B5EF4-FFF2-40B4-BE49-F238E27FC236}">
-                <a16:creationId xmlns:a16="http://schemas.microsoft.com/office/drawing/2014/main" id="{55D4608F-479B-4E8F-B720-EF1CBB280DA0}"/>
-              </a:ext>
-            </a:extLst>
-          </p:cNvPr>
-          <p:cNvSpPr>
-            <a:spLocks xmlns:a="http://schemas.openxmlformats.org/drawingml/2006/main" noGrp="1"/>
-          </p:cNvSpPr>
-          <p:nvPr/>
-        </p:nvSpPr>
-        <p:spPr>
-          <a:xfrm xmlns:a="http://schemas.openxmlformats.org/drawingml/2006/main">
-            <a:off x="723900" y="4695825"/>
-            <a:ext cx="590550" cy="476250"/>
-          </a:xfrm>
-          <a:prstGeom xmlns:a="http://schemas.openxmlformats.org/drawingml/2006/main" prst="rect">
-            <a:avLst/>
-          </a:prstGeom>
-          <a:noFill xmlns:a="http://schemas.openxmlformats.org/drawingml/2006/main"/>
-          <a:ln xmlns:a="http://schemas.openxmlformats.org/drawingml/2006/main" w="0">
-            <a:noFill/>
-          </a:ln>
-        </p:spPr>
-        <p:txBody>
-          <a:bodyPr xmlns:a="http://schemas.openxmlformats.org/drawingml/2006/main" wrap="square" lIns="0" tIns="0" rIns="0" bIns="0" anchor="t">
-            <a:noAutofit/>
-          </a:bodyPr>
-          <a:lstStyle xmlns:a="http://schemas.openxmlformats.org/drawingml/2006/main"/>
-          <a:p xmlns:a="http://schemas.openxmlformats.org/drawingml/2006/main">
-            <a:pPr>
-              <a:defRPr sz="1875" b="1">
-                <a:solidFill>
-                  <a:srgbClr val="2D63FF"/>
-                </a:solidFill>
-                <a:latin typeface="DejaVu Sans"/>
-                <a:ea typeface="DejaVu Sans"/>
-                <a:cs typeface="DejaVu Sans"/>
-              </a:defRPr>
-            </a:pPr>
-            <a:r>
-              <a:rPr sz="1875" b="1">
-                <a:solidFill>
-                  <a:srgbClr val="2D63FF"/>
-                </a:solidFill>
-                <a:latin typeface="DejaVu Sans"/>
-                <a:ea typeface="DejaVu Sans"/>
-                <a:cs typeface="DejaVu Sans"/>
-              </a:rPr>
-              <a:t>4.</a:t>
-            </a:r>
-          </a:p>
-        </p:txBody>
-      </p:sp>
-      <p:sp>
-        <p:nvSpPr>
-          <p:cNvPr id="12" name="item-4">
-            <a:extLst xmlns:a="http://schemas.openxmlformats.org/drawingml/2006/main">
-              <a:ext uri="{FF2B5EF4-FFF2-40B4-BE49-F238E27FC236}">
-                <a16:creationId xmlns:a16="http://schemas.microsoft.com/office/drawing/2014/main" id="{C50B1094-4B56-486F-AD71-0A412B590968}"/>
-              </a:ext>
-            </a:extLst>
-          </p:cNvPr>
-          <p:cNvSpPr>
-            <a:spLocks xmlns:a="http://schemas.openxmlformats.org/drawingml/2006/main" noGrp="1"/>
-          </p:cNvSpPr>
-          <p:nvPr/>
-        </p:nvSpPr>
-        <p:spPr>
-          <a:xfrm xmlns:a="http://schemas.openxmlformats.org/drawingml/2006/main">
-            <a:off x="1352550" y="4695825"/>
-            <a:ext cx="9925050" cy="838200"/>
-          </a:xfrm>
-          <a:prstGeom xmlns:a="http://schemas.openxmlformats.org/drawingml/2006/main" prst="rect">
-            <a:avLst/>
-          </a:prstGeom>
-          <a:noFill xmlns:a="http://schemas.openxmlformats.org/drawingml/2006/main"/>
-          <a:ln xmlns:a="http://schemas.openxmlformats.org/drawingml/2006/main" w="0">
-            <a:noFill/>
-          </a:ln>
-        </p:spPr>
-        <p:txBody>
-          <a:bodyPr xmlns:a="http://schemas.openxmlformats.org/drawingml/2006/main" wrap="square" lIns="0" tIns="0" rIns="0" bIns="0" anchor="t">
-            <a:noAutofit/>
-          </a:bodyPr>
-          <a:lstStyle xmlns:a="http://schemas.openxmlformats.org/drawingml/2006/main"/>
-          <a:p xmlns:a="http://schemas.openxmlformats.org/drawingml/2006/main">
-            <a:pPr>
-              <a:defRPr sz="1875" b="0">
-                <a:solidFill>
-                  <a:srgbClr val="101828"/>
-                </a:solidFill>
-                <a:latin typeface="DejaVu Sans"/>
-                <a:ea typeface="DejaVu Sans"/>
-                <a:cs typeface="DejaVu Sans"/>
-              </a:defRPr>
-            </a:pPr>
-            <a:r>
-              <a:rPr sz="1875" b="0">
-                <a:solidFill>
-                  <a:srgbClr val="101828"/>
-                </a:solidFill>
-                <a:latin typeface="DejaVu Sans"/>
-                <a:ea typeface="DejaVu Sans"/>
-                <a:cs typeface="DejaVu Sans"/>
-              </a:rPr>
-              <a:t>When the score screen appears, copy your score into the yellow worksheet box (out of 22).</a:t>
-            </a:r>
-          </a:p>
-        </p:txBody>
-      </p:sp>
-      <p:sp>
-        <p:nvSpPr>
-          <p:cNvPr id="13" name="open-link">
-            <a:extLst xmlns:a="http://schemas.openxmlformats.org/drawingml/2006/main">
-              <a:ext uri="{FF2B5EF4-FFF2-40B4-BE49-F238E27FC236}">
-                <a16:creationId xmlns:a16="http://schemas.microsoft.com/office/drawing/2014/main" id="{703CE6B7-F6DB-4447-A2D5-F33FA8C75189}"/>
-              </a:ext>
-            </a:extLst>
-          </p:cNvPr>
-          <p:cNvSpPr>
-            <a:spLocks xmlns:a="http://schemas.openxmlformats.org/drawingml/2006/main" noGrp="1"/>
-          </p:cNvSpPr>
-          <p:nvPr/>
-        </p:nvSpPr>
-        <p:spPr>
-          <a:xfrm xmlns:a="http://schemas.openxmlformats.org/drawingml/2006/main">
-            <a:off x="723900" y="5781675"/>
-            <a:ext cx="4953000" cy="352425"/>
-          </a:xfrm>
-          <a:prstGeom xmlns:a="http://schemas.openxmlformats.org/drawingml/2006/main" prst="rect">
-            <a:avLst/>
-          </a:prstGeom>
-          <a:noFill xmlns:a="http://schemas.openxmlformats.org/drawingml/2006/main"/>
-          <a:ln xmlns:a="http://schemas.openxmlformats.org/drawingml/2006/main" w="0">
-            <a:noFill/>
-          </a:ln>
-        </p:spPr>
-        <p:txBody>
-          <a:bodyPr xmlns:a="http://schemas.openxmlformats.org/drawingml/2006/main" wrap="square" lIns="0" tIns="0" rIns="0" bIns="0" anchor="t">
-            <a:noAutofit/>
-          </a:bodyPr>
-          <a:lstStyle xmlns:a="http://schemas.openxmlformats.org/drawingml/2006/main"/>
-          <a:p xmlns:a="http://schemas.openxmlformats.org/drawingml/2006/main">
-            <a:pPr>
-              <a:defRPr sz="1650" b="1">
-                <a:solidFill>
-                  <a:srgbClr val="2D63FF"/>
-                </a:solidFill>
-                <a:latin typeface="DejaVu Sans"/>
-                <a:ea typeface="DejaVu Sans"/>
-                <a:cs typeface="DejaVu Sans"/>
-              </a:defRPr>
-            </a:pPr>
-            <a:r>
-              <a:rPr sz="1650" b="1">
-                <a:solidFill>
-                  <a:srgbClr val="2D63FF"/>
-                </a:solidFill>
-                <a:latin typeface="DejaVu Sans"/>
-                <a:ea typeface="DejaVu Sans"/>
-                <a:cs typeface="DejaVu Sans"/>
-                <a:hlinkClick xmlns:r="http://schemas.openxmlformats.org/officeDocument/2006/relationships" r:id="Re33157ce64f544d1"/>
+                  <a:srgbClr val="FFFFFF"/>
+                </a:solidFill>
+                <a:latin typeface="DejaVu Sans"/>
+                <a:ea typeface="DejaVu Sans"/>
+                <a:cs typeface="DejaVu Sans"/>
+              </a:rPr>
+              <a:t>Answer on screen, then copy your score into the yellow worksheet box (out of 22).</a:t>
+            </a:r>
+          </a:p>
+        </p:txBody>
+      </p:sp>
+      <p:sp>
+        <p:nvSpPr>
+          <p:cNvPr id="11" name="open-link">
+            <a:extLst xmlns:a="http://schemas.openxmlformats.org/drawingml/2006/main">
+              <a:ext uri="{FF2B5EF4-FFF2-40B4-BE49-F238E27FC236}">
+                <a16:creationId xmlns:a16="http://schemas.microsoft.com/office/drawing/2014/main" id="{2B767C09-2842-4E8D-8865-E4868622682B}"/>
+              </a:ext>
+            </a:extLst>
+          </p:cNvPr>
+          <p:cNvSpPr>
+            <a:spLocks xmlns:a="http://schemas.openxmlformats.org/drawingml/2006/main" noGrp="1"/>
+          </p:cNvSpPr>
+          <p:nvPr/>
+        </p:nvSpPr>
+        <p:spPr>
+          <a:xfrm xmlns:a="http://schemas.openxmlformats.org/drawingml/2006/main">
+            <a:off x="723900" y="5838825"/>
+            <a:ext cx="5715000" cy="361950"/>
+          </a:xfrm>
+          <a:prstGeom xmlns:a="http://schemas.openxmlformats.org/drawingml/2006/main" prst="rect">
+            <a:avLst/>
+          </a:prstGeom>
+          <a:noFill xmlns:a="http://schemas.openxmlformats.org/drawingml/2006/main"/>
+          <a:ln xmlns:a="http://schemas.openxmlformats.org/drawingml/2006/main" w="0">
+            <a:noFill/>
+          </a:ln>
+        </p:spPr>
+        <p:txBody>
+          <a:bodyPr xmlns:a="http://schemas.openxmlformats.org/drawingml/2006/main" wrap="square" lIns="0" tIns="0" rIns="0" bIns="0" anchor="t">
+            <a:noAutofit/>
+          </a:bodyPr>
+          <a:lstStyle xmlns:a="http://schemas.openxmlformats.org/drawingml/2006/main"/>
+          <a:p xmlns:a="http://schemas.openxmlformats.org/drawingml/2006/main">
+            <a:pPr>
+              <a:defRPr sz="1725" b="1">
+                <a:solidFill>
+                  <a:srgbClr val="77D8FF"/>
+                </a:solidFill>
+                <a:latin typeface="DejaVu Sans"/>
+                <a:ea typeface="DejaVu Sans"/>
+                <a:cs typeface="DejaVu Sans"/>
+              </a:defRPr>
+            </a:pPr>
+            <a:r>
+              <a:rPr sz="1725" b="1">
+                <a:solidFill>
+                  <a:srgbClr val="77D8FF"/>
+                </a:solidFill>
+                <a:latin typeface="DejaVu Sans"/>
+                <a:ea typeface="DejaVu Sans"/>
+                <a:cs typeface="DejaVu Sans"/>
+                <a:hlinkClick xmlns:r="http://schemas.openxmlformats.org/officeDocument/2006/relationships" r:id="R6c752406c6b44bcf"/>
               </a:rPr>
               <a:t>Open the experience online</a:t>
+            </a:r>
+            <a:r>
+              <a:rPr sz="1725" b="1">
+                <a:solidFill>
+                  <a:srgbClr val="77D8FF"/>
+                </a:solidFill>
+                <a:latin typeface="DejaVu Sans"/>
+                <a:ea typeface="DejaVu Sans"/>
+                <a:cs typeface="DejaVu Sans"/>
+              </a:rPr>
+              <a:t>  ↗</a:t>
             </a:r>
           </a:p>
         </p:txBody>
@@ -13144,7 +13041,7 @@
     </p:spTree>
     <p:extLst>
       <p:ext uri="{BB962C8B-B14F-4D97-AF65-F5344CB8AC3E}">
-        <p14:creationId xmlns:p14="http://schemas.microsoft.com/office/powerpoint/2010/main" val="592090903"/>
+        <p14:creationId xmlns:p14="http://schemas.microsoft.com/office/powerpoint/2010/main" val="1916297020"/>
       </p:ext>
     </p:extLst>
   </p:cSld>
@@ -13175,7 +13072,7 @@
           <p:cNvPr id="15" name="topic">
             <a:extLst xmlns:a="http://schemas.openxmlformats.org/drawingml/2006/main">
               <a:ext uri="{FF2B5EF4-FFF2-40B4-BE49-F238E27FC236}">
-                <a16:creationId xmlns:a16="http://schemas.microsoft.com/office/drawing/2014/main" id="{B9A1F7DD-BD63-4C9F-BC21-5F3A2217D17E}"/>
+                <a16:creationId xmlns:a16="http://schemas.microsoft.com/office/drawing/2014/main" id="{D4BF4A18-B0A9-44DC-8E48-5708A1187004}"/>
               </a:ext>
             </a:extLst>
           </p:cNvPr>
@@ -13187,7 +13084,7 @@
         <p:spPr>
           <a:xfrm xmlns:a="http://schemas.openxmlformats.org/drawingml/2006/main">
             <a:off x="666750" y="323850"/>
-            <a:ext cx="6667500" cy="276225"/>
+            <a:ext cx="9810750" cy="276225"/>
           </a:xfrm>
           <a:prstGeom xmlns:a="http://schemas.openxmlformats.org/drawingml/2006/main" prst="rect">
             <a:avLst/>
@@ -13222,7 +13119,7 @@
                 <a:ea typeface="DejaVu Sans"/>
                 <a:cs typeface="DejaVu Sans"/>
               </a:rPr>
-              <a:t>TOPIC 1.1   LESSON 01</a:t>
+              <a:t>TOPIC 1.1   /   LESSON 01   /   EXPERIENCE</a:t>
             </a:r>
           </a:p>
         </p:txBody>
@@ -13232,7 +13129,7 @@
           <p:cNvPr id="2" name="heading">
             <a:extLst xmlns:a="http://schemas.openxmlformats.org/drawingml/2006/main">
               <a:ext uri="{FF2B5EF4-FFF2-40B4-BE49-F238E27FC236}">
-                <a16:creationId xmlns:a16="http://schemas.microsoft.com/office/drawing/2014/main" id="{ABD95D19-2D7F-4B0F-A218-8263C84278A2}"/>
+                <a16:creationId xmlns:a16="http://schemas.microsoft.com/office/drawing/2014/main" id="{7A606052-8113-43DF-914B-31AD3D94D2B0}"/>
               </a:ext>
             </a:extLst>
           </p:cNvPr>
@@ -13289,7 +13186,7 @@
           <p:cNvPr id="3" name="footer">
             <a:extLst xmlns:a="http://schemas.openxmlformats.org/drawingml/2006/main">
               <a:ext uri="{FF2B5EF4-FFF2-40B4-BE49-F238E27FC236}">
-                <a16:creationId xmlns:a16="http://schemas.microsoft.com/office/drawing/2014/main" id="{7E3D045B-DFA8-4DB1-B95C-B9F4E6D71BA5}"/>
+                <a16:creationId xmlns:a16="http://schemas.microsoft.com/office/drawing/2014/main" id="{35C07C64-5F7D-42FE-8A18-DE162611B73F}"/>
               </a:ext>
             </a:extLst>
           </p:cNvPr>
@@ -13336,7 +13233,7 @@
                 <a:ea typeface="DejaVu Sans"/>
                 <a:cs typeface="DejaVu Sans"/>
               </a:rPr>
-              <a:t>Revise 360    OCR J277 1.1 Systems architecture    Experience</a:t>
+              <a:t>Revise 360    OCR J277 1.1 Systems architecture</a:t>
             </a:r>
           </a:p>
         </p:txBody>
@@ -13346,7 +13243,7 @@
           <p:cNvPr id="4" name="page">
             <a:extLst xmlns:a="http://schemas.openxmlformats.org/drawingml/2006/main">
               <a:ext uri="{FF2B5EF4-FFF2-40B4-BE49-F238E27FC236}">
-                <a16:creationId xmlns:a16="http://schemas.microsoft.com/office/drawing/2014/main" id="{DED6CBB7-78A3-445D-B577-FE7F8CCFCC77}"/>
+                <a16:creationId xmlns:a16="http://schemas.microsoft.com/office/drawing/2014/main" id="{1E14B9BA-1CAF-4854-BB5F-86F43304407A}"/>
               </a:ext>
             </a:extLst>
           </p:cNvPr>
@@ -13403,19 +13300,19 @@
           <p:cNvPr id="5" name="route-intro">
             <a:extLst xmlns:a="http://schemas.openxmlformats.org/drawingml/2006/main">
               <a:ext uri="{FF2B5EF4-FFF2-40B4-BE49-F238E27FC236}">
-                <a16:creationId xmlns:a16="http://schemas.microsoft.com/office/drawing/2014/main" id="{10C6F521-5E4E-4847-AAEC-0CA0865292A4}"/>
-              </a:ext>
-            </a:extLst>
-          </p:cNvPr>
-          <p:cNvSpPr>
-            <a:spLocks xmlns:a="http://schemas.openxmlformats.org/drawingml/2006/main" noGrp="1"/>
-          </p:cNvSpPr>
-          <p:nvPr/>
-        </p:nvSpPr>
-        <p:spPr>
-          <a:xfrm xmlns:a="http://schemas.openxmlformats.org/drawingml/2006/main">
-            <a:off x="704850" y="1581150"/>
-            <a:ext cx="10477500" cy="504825"/>
+                <a16:creationId xmlns:a16="http://schemas.microsoft.com/office/drawing/2014/main" id="{791212C0-D81E-4C7B-AD62-11B79439A5FC}"/>
+              </a:ext>
+            </a:extLst>
+          </p:cNvPr>
+          <p:cNvSpPr>
+            <a:spLocks xmlns:a="http://schemas.openxmlformats.org/drawingml/2006/main" noGrp="1"/>
+          </p:cNvSpPr>
+          <p:nvPr/>
+        </p:nvSpPr>
+        <p:spPr>
+          <a:xfrm xmlns:a="http://schemas.openxmlformats.org/drawingml/2006/main">
+            <a:off x="704850" y="1533525"/>
+            <a:ext cx="10477500" cy="590550"/>
           </a:xfrm>
           <a:prstGeom xmlns:a="http://schemas.openxmlformats.org/drawingml/2006/main" prst="rect">
             <a:avLst/>
@@ -13450,7 +13347,7 @@
                 <a:ea typeface="DejaVu Sans"/>
                 <a:cs typeface="DejaVu Sans"/>
               </a:rPr>
-              <a:t>Use the same route as the experience and worksheet:</a:t>
+              <a:t>Follow your worksheet route. Write key facts in your own words before tapping each badge.</a:t>
             </a:r>
           </a:p>
         </p:txBody>
@@ -13460,7 +13357,7 @@
           <p:cNvPr id="6" name="route-direction-0">
             <a:extLst xmlns:a="http://schemas.openxmlformats.org/drawingml/2006/main">
               <a:ext uri="{FF2B5EF4-FFF2-40B4-BE49-F238E27FC236}">
-                <a16:creationId xmlns:a16="http://schemas.microsoft.com/office/drawing/2014/main" id="{78BA4E56-0AD0-4D52-AB49-8ABB30920968}"/>
+                <a16:creationId xmlns:a16="http://schemas.microsoft.com/office/drawing/2014/main" id="{FA809A63-EC2E-4A6F-A7C2-867022444F6E}"/>
               </a:ext>
             </a:extLst>
           </p:cNvPr>
@@ -13517,7 +13414,7 @@
           <p:cNvPr id="7" name="route-names-0">
             <a:extLst xmlns:a="http://schemas.openxmlformats.org/drawingml/2006/main">
               <a:ext uri="{FF2B5EF4-FFF2-40B4-BE49-F238E27FC236}">
-                <a16:creationId xmlns:a16="http://schemas.microsoft.com/office/drawing/2014/main" id="{DEB9978B-34F2-4DDB-921E-C95509938F4C}"/>
+                <a16:creationId xmlns:a16="http://schemas.microsoft.com/office/drawing/2014/main" id="{839FBD8E-14A2-444F-A79C-04F97AF54948}"/>
               </a:ext>
             </a:extLst>
           </p:cNvPr>
@@ -13597,7 +13494,7 @@
           <p:cNvPr id="8" name="route-direction-1">
             <a:extLst xmlns:a="http://schemas.openxmlformats.org/drawingml/2006/main">
               <a:ext uri="{FF2B5EF4-FFF2-40B4-BE49-F238E27FC236}">
-                <a16:creationId xmlns:a16="http://schemas.microsoft.com/office/drawing/2014/main" id="{67CD2FD7-3A11-4278-AD62-18F8D190583F}"/>
+                <a16:creationId xmlns:a16="http://schemas.microsoft.com/office/drawing/2014/main" id="{7DE13BFE-0FAF-46D6-858A-1687995997E9}"/>
               </a:ext>
             </a:extLst>
           </p:cNvPr>
@@ -13654,7 +13551,7 @@
           <p:cNvPr id="9" name="route-names-1">
             <a:extLst xmlns:a="http://schemas.openxmlformats.org/drawingml/2006/main">
               <a:ext uri="{FF2B5EF4-FFF2-40B4-BE49-F238E27FC236}">
-                <a16:creationId xmlns:a16="http://schemas.microsoft.com/office/drawing/2014/main" id="{3CA032BE-6061-4E76-B31E-A60622845B2E}"/>
+                <a16:creationId xmlns:a16="http://schemas.microsoft.com/office/drawing/2014/main" id="{BB38C0D0-7569-4898-A0AE-B4B794161F43}"/>
               </a:ext>
             </a:extLst>
           </p:cNvPr>
@@ -13734,7 +13631,7 @@
           <p:cNvPr id="10" name="route-direction-2">
             <a:extLst xmlns:a="http://schemas.openxmlformats.org/drawingml/2006/main">
               <a:ext uri="{FF2B5EF4-FFF2-40B4-BE49-F238E27FC236}">
-                <a16:creationId xmlns:a16="http://schemas.microsoft.com/office/drawing/2014/main" id="{674E90E1-0F7F-49D7-AE33-993CD71A4ABF}"/>
+                <a16:creationId xmlns:a16="http://schemas.microsoft.com/office/drawing/2014/main" id="{6A96764B-D5CE-498E-86EA-D09CB0330307}"/>
               </a:ext>
             </a:extLst>
           </p:cNvPr>
@@ -13791,7 +13688,7 @@
           <p:cNvPr id="11" name="route-names-2">
             <a:extLst xmlns:a="http://schemas.openxmlformats.org/drawingml/2006/main">
               <a:ext uri="{FF2B5EF4-FFF2-40B4-BE49-F238E27FC236}">
-                <a16:creationId xmlns:a16="http://schemas.microsoft.com/office/drawing/2014/main" id="{57C8F419-EE45-43D2-99E8-BD6F53332EBB}"/>
+                <a16:creationId xmlns:a16="http://schemas.microsoft.com/office/drawing/2014/main" id="{B246A1E4-F79D-4E71-82EF-9A0EC46684E6}"/>
               </a:ext>
             </a:extLst>
           </p:cNvPr>
@@ -13871,7 +13768,7 @@
           <p:cNvPr id="12" name="route-direction-3">
             <a:extLst xmlns:a="http://schemas.openxmlformats.org/drawingml/2006/main">
               <a:ext uri="{FF2B5EF4-FFF2-40B4-BE49-F238E27FC236}">
-                <a16:creationId xmlns:a16="http://schemas.microsoft.com/office/drawing/2014/main" id="{DF61336D-20C9-4569-8FFF-230F0AC8BA9C}"/>
+                <a16:creationId xmlns:a16="http://schemas.microsoft.com/office/drawing/2014/main" id="{9007AC77-1529-409C-B5A4-A2018B6A3219}"/>
               </a:ext>
             </a:extLst>
           </p:cNvPr>
@@ -13928,7 +13825,7 @@
           <p:cNvPr id="13" name="route-names-3">
             <a:extLst xmlns:a="http://schemas.openxmlformats.org/drawingml/2006/main">
               <a:ext uri="{FF2B5EF4-FFF2-40B4-BE49-F238E27FC236}">
-                <a16:creationId xmlns:a16="http://schemas.microsoft.com/office/drawing/2014/main" id="{3A6B7794-ABB7-4BA8-8DFB-B6A4FEB11949}"/>
+                <a16:creationId xmlns:a16="http://schemas.microsoft.com/office/drawing/2014/main" id="{CDAA6E78-B54B-4CFB-8893-995760264789}"/>
               </a:ext>
             </a:extLst>
           </p:cNvPr>
@@ -13989,7 +13886,7 @@
           <p:nvPr/>
         </p:nvPicPr>
         <p:blipFill>
-          <a:blip xmlns:r="http://schemas.openxmlformats.org/officeDocument/2006/relationships" xmlns:a="http://schemas.openxmlformats.org/drawingml/2006/main" r:embed="Re265ec3138854902"/>
+          <a:blip xmlns:r="http://schemas.openxmlformats.org/officeDocument/2006/relationships" xmlns:a="http://schemas.openxmlformats.org/drawingml/2006/main" r:embed="R0e9c516556b94bc8"/>
           <a:stretch xmlns:a="http://schemas.openxmlformats.org/drawingml/2006/main"/>
         </p:blipFill>
         <p:spPr>
@@ -14005,7 +13902,7 @@
     </p:spTree>
     <p:extLst>
       <p:ext uri="{BB962C8B-B14F-4D97-AF65-F5344CB8AC3E}">
-        <p14:creationId xmlns:p14="http://schemas.microsoft.com/office/powerpoint/2010/main" val="434415961"/>
+        <p14:creationId xmlns:p14="http://schemas.microsoft.com/office/powerpoint/2010/main" val="1482273097"/>
       </p:ext>
     </p:extLst>
   </p:cSld>
@@ -14036,7 +13933,7 @@
           <p:cNvPr id="9" name="topic">
             <a:extLst xmlns:a="http://schemas.openxmlformats.org/drawingml/2006/main">
               <a:ext uri="{FF2B5EF4-FFF2-40B4-BE49-F238E27FC236}">
-                <a16:creationId xmlns:a16="http://schemas.microsoft.com/office/drawing/2014/main" id="{230FF95B-4773-493A-ACF7-561AA4958018}"/>
+                <a16:creationId xmlns:a16="http://schemas.microsoft.com/office/drawing/2014/main" id="{B43BD6FE-5BED-41A8-AF62-4EF43F01C9D9}"/>
               </a:ext>
             </a:extLst>
           </p:cNvPr>
@@ -14048,7 +13945,7 @@
         <p:spPr>
           <a:xfrm xmlns:a="http://schemas.openxmlformats.org/drawingml/2006/main">
             <a:off x="666750" y="323850"/>
-            <a:ext cx="6667500" cy="276225"/>
+            <a:ext cx="9810750" cy="276225"/>
           </a:xfrm>
           <a:prstGeom xmlns:a="http://schemas.openxmlformats.org/drawingml/2006/main" prst="rect">
             <a:avLst/>
@@ -14083,7 +13980,7 @@
                 <a:ea typeface="DejaVu Sans"/>
                 <a:cs typeface="DejaVu Sans"/>
               </a:rPr>
-              <a:t>TOPIC 1.1   LESSON 01</a:t>
+              <a:t>TOPIC 1.1   /   LESSON 01   /   WORKSHEET</a:t>
             </a:r>
           </a:p>
         </p:txBody>
@@ -14093,7 +13990,7 @@
           <p:cNvPr id="2" name="heading">
             <a:extLst xmlns:a="http://schemas.openxmlformats.org/drawingml/2006/main">
               <a:ext uri="{FF2B5EF4-FFF2-40B4-BE49-F238E27FC236}">
-                <a16:creationId xmlns:a16="http://schemas.microsoft.com/office/drawing/2014/main" id="{CA6D7128-28F2-4794-AF8C-3C1E8BD9832D}"/>
+                <a16:creationId xmlns:a16="http://schemas.microsoft.com/office/drawing/2014/main" id="{8ED470A4-DA67-4B78-8E9A-0EEB505C5D68}"/>
               </a:ext>
             </a:extLst>
           </p:cNvPr>
@@ -14150,7 +14047,7 @@
           <p:cNvPr id="3" name="footer">
             <a:extLst xmlns:a="http://schemas.openxmlformats.org/drawingml/2006/main">
               <a:ext uri="{FF2B5EF4-FFF2-40B4-BE49-F238E27FC236}">
-                <a16:creationId xmlns:a16="http://schemas.microsoft.com/office/drawing/2014/main" id="{1BF83A4D-4C21-41E5-8B8A-A1119DA0381B}"/>
+                <a16:creationId xmlns:a16="http://schemas.microsoft.com/office/drawing/2014/main" id="{0136638B-80E0-461E-880B-67FA0D432B12}"/>
               </a:ext>
             </a:extLst>
           </p:cNvPr>
@@ -14197,7 +14094,7 @@
                 <a:ea typeface="DejaVu Sans"/>
                 <a:cs typeface="DejaVu Sans"/>
               </a:rPr>
-              <a:t>Revise 360    OCR J277 1.1 Systems architecture    Worksheet</a:t>
+              <a:t>Revise 360    OCR J277 1.1 Systems architecture</a:t>
             </a:r>
           </a:p>
         </p:txBody>
@@ -14207,7 +14104,7 @@
           <p:cNvPr id="4" name="page">
             <a:extLst xmlns:a="http://schemas.openxmlformats.org/drawingml/2006/main">
               <a:ext uri="{FF2B5EF4-FFF2-40B4-BE49-F238E27FC236}">
-                <a16:creationId xmlns:a16="http://schemas.microsoft.com/office/drawing/2014/main" id="{D0AA90E2-D74B-42BF-A3DC-E69916338848}"/>
+                <a16:creationId xmlns:a16="http://schemas.microsoft.com/office/drawing/2014/main" id="{73E94AEB-F108-4CDD-BCFF-292FE0DA56B8}"/>
               </a:ext>
             </a:extLst>
           </p:cNvPr>
@@ -14264,7 +14161,7 @@
           <p:cNvPr id="5" name="star">
             <a:extLst xmlns:a="http://schemas.openxmlformats.org/drawingml/2006/main">
               <a:ext uri="{FF2B5EF4-FFF2-40B4-BE49-F238E27FC236}">
-                <a16:creationId xmlns:a16="http://schemas.microsoft.com/office/drawing/2014/main" id="{0BC660FF-9DB0-4A73-9DA2-124BF76351EC}"/>
+                <a16:creationId xmlns:a16="http://schemas.microsoft.com/office/drawing/2014/main" id="{9724ACA5-7F45-458B-9946-616E2D6D4647}"/>
               </a:ext>
             </a:extLst>
           </p:cNvPr>
@@ -14321,7 +14218,7 @@
           <p:cNvPr id="6" name="score">
             <a:extLst xmlns:a="http://schemas.openxmlformats.org/drawingml/2006/main">
               <a:ext uri="{FF2B5EF4-FFF2-40B4-BE49-F238E27FC236}">
-                <a16:creationId xmlns:a16="http://schemas.microsoft.com/office/drawing/2014/main" id="{C61D1269-1163-4496-904D-D4320A9DBFB8}"/>
+                <a16:creationId xmlns:a16="http://schemas.microsoft.com/office/drawing/2014/main" id="{C8E8E1DF-E722-40C0-A3DD-D4CFCBA72EA8}"/>
               </a:ext>
             </a:extLst>
           </p:cNvPr>
@@ -14378,7 +14275,7 @@
           <p:cNvPr id="7" name="key-label">
             <a:extLst xmlns:a="http://schemas.openxmlformats.org/drawingml/2006/main">
               <a:ext uri="{FF2B5EF4-FFF2-40B4-BE49-F238E27FC236}">
-                <a16:creationId xmlns:a16="http://schemas.microsoft.com/office/drawing/2014/main" id="{CAFC72C8-0EEC-48E6-93CC-3C4C8B1E636C}"/>
+                <a16:creationId xmlns:a16="http://schemas.microsoft.com/office/drawing/2014/main" id="{86CFA3FF-9434-46E7-B2E2-D4907E1FA81B}"/>
               </a:ext>
             </a:extLst>
           </p:cNvPr>
@@ -14435,7 +14332,7 @@
           <p:cNvPr id="8" name="key-question">
             <a:extLst xmlns:a="http://schemas.openxmlformats.org/drawingml/2006/main">
               <a:ext uri="{FF2B5EF4-FFF2-40B4-BE49-F238E27FC236}">
-                <a16:creationId xmlns:a16="http://schemas.microsoft.com/office/drawing/2014/main" id="{D41D3C60-5019-4308-8BD9-E6B93AB3F4B1}"/>
+                <a16:creationId xmlns:a16="http://schemas.microsoft.com/office/drawing/2014/main" id="{CD6FB411-7856-4691-84D2-299575305A14}"/>
               </a:ext>
             </a:extLst>
           </p:cNvPr>
@@ -14490,7 +14387,7 @@
     </p:spTree>
     <p:extLst>
       <p:ext uri="{BB962C8B-B14F-4D97-AF65-F5344CB8AC3E}">
-        <p14:creationId xmlns:p14="http://schemas.microsoft.com/office/powerpoint/2010/main" val="994166787"/>
+        <p14:creationId xmlns:p14="http://schemas.microsoft.com/office/powerpoint/2010/main" val="2108352942"/>
       </p:ext>
     </p:extLst>
   </p:cSld>

</xml_diff>